<commit_message>
Actualizar URL del repo en README y presentación
</commit_message>
<xml_diff>
--- a/presentacion/Presentacion_Grupo7_Final.pptx
+++ b/presentacion/Presentacion_Grupo7_Final.pptx
@@ -2144,7 +2144,7 @@
                 <a:ea typeface="Calibri" pitchFamily="34" charset="-122"/>
                 <a:cs typeface="Calibri" pitchFamily="34" charset="-120"/>
               </a:rPr>
-              <a:t>github.com/grupo7-eda-ecobici   ·   Presentación · 22/04/2026</a:t>
+              <a:t>github.com/cimberlina/grupo7-eda-ecobici   ·   Presentación · 22/04/2026</a:t>
             </a:r>
             <a:endParaRPr lang="en-US" sz="850" dirty="0"/>
           </a:p>
@@ -4426,7 +4426,7 @@
                 <a:ea typeface="Calibri" pitchFamily="34" charset="-122"/>
                 <a:cs typeface="Calibri" pitchFamily="34" charset="-120"/>
               </a:rPr>
-              <a:t>Repositorio: github.com/grupo7-eda-ecobici  ·  Gracias · abierto a preguntas</a:t>
+              <a:t>Repositorio: github.com/cimberlina/grupo7-eda-ecobici  ·  Gracias · abierto a preguntas</a:t>
             </a:r>
             <a:endParaRPr lang="en-US" sz="1200" dirty="0"/>
           </a:p>
@@ -4488,7 +4488,7 @@
                 <a:ea typeface="Calibri" pitchFamily="34" charset="-122"/>
                 <a:cs typeface="Calibri" pitchFamily="34" charset="-120"/>
               </a:rPr>
-              <a:t>Grupo 7 · CEIA FIUBA · 1B 2026  ·  github.com/grupo7-eda-ecobici</a:t>
+              <a:t>Grupo 7 · CEIA FIUBA · 1B 2026  ·  github.com/cimberlina/grupo7-eda-ecobici</a:t>
             </a:r>
             <a:endParaRPr lang="en-US" sz="900" dirty="0"/>
           </a:p>

</xml_diff>

<commit_message>
Agregada Matriz OD y gráficos comparativos de finde vs hábiles
</commit_message>
<xml_diff>
--- a/presentacion/Presentacion_Grupo7_Final.pptx
+++ b/presentacion/Presentacion_Grupo7_Final.pptx
@@ -4,18 +4,19 @@
   <p:sldMasterIdLst>
     <p:sldMasterId id="2147483648" r:id="rId1"/>
   </p:sldMasterIdLst>
+  <p:notesMasterIdLst>
+    <p:notesMasterId r:id="rId9"/>
+  </p:notesMasterIdLst>
   <p:sldIdLst>
     <p:sldId id="256" r:id="rId2"/>
     <p:sldId id="257" r:id="rId3"/>
-    <p:sldId id="258" r:id="rId4"/>
-    <p:sldId id="259" r:id="rId5"/>
-    <p:sldId id="260" r:id="rId6"/>
-    <p:sldId id="261" r:id="rId7"/>
+    <p:sldId id="262" r:id="rId4"/>
+    <p:sldId id="258" r:id="rId5"/>
+    <p:sldId id="259" r:id="rId6"/>
+    <p:sldId id="260" r:id="rId7"/>
+    <p:sldId id="261" r:id="rId8"/>
   </p:sldIdLst>
-  <p:notesMasterIdLst>
-    <p:notesMasterId r:id="rId8"/>
-  </p:notesMasterIdLst>
-  <p:sldSz cx="9144000" cy="5143500"/>
+  <p:sldSz cx="9144000" cy="5143500" type="screen16x9"/>
   <p:notesSz cx="5143500" cy="9144000"/>
   <p:defaultTextStyle>
     <a:lvl1pPr marL="0" algn="l" defTabSz="914400" rtl="0" eaLnBrk="1" latinLnBrk="0" hangingPunct="1">
@@ -109,6 +110,11 @@
       </a:defRPr>
     </a:lvl9pPr>
   </p:defaultTextStyle>
+  <p:extLst>
+    <p:ext uri="{EFAFB233-063F-42B5-8137-9DF3F51BA10A}">
+      <p15:sldGuideLst xmlns:p15="http://schemas.microsoft.com/office/powerpoint/2012/main"/>
+    </p:ext>
+  </p:extLst>
 </p:presentation>
 </file>
 
@@ -134,234 +140,10 @@
           <a:chExt cx="0" cy="0"/>
         </a:xfrm>
       </p:grpSpPr>
-      <p:sp>
-        <p:nvSpPr>
-          <p:cNvPr id="2" name="Header Placeholder 1"/>
-          <p:cNvSpPr>
-            <a:spLocks noGrp="1"/>
-          </p:cNvSpPr>
-          <p:nvPr>
-            <p:ph type="hdr" sz="quarter"/>
-          </p:nvPr>
-        </p:nvSpPr>
-        <p:spPr>
-          <a:xfrm>
-            <a:off x="0" y="0"/>
-            <a:ext cx="2971800" cy="458788"/>
-          </a:xfrm>
-          <a:prstGeom prst="rect">
-            <a:avLst/>
-          </a:prstGeom>
-        </p:spPr>
-        <p:txBody>
-          <a:bodyPr vert="horz" lIns="91440" tIns="45720" rIns="91440" bIns="45720" rtlCol="0"/>
-          <a:lstStyle>
-            <a:lvl1pPr algn="l">
-              <a:defRPr sz="1200"/>
-            </a:lvl1pPr>
-          </a:lstStyle>
-          <a:p>
-            <a:endParaRPr lang="en-US"/>
-          </a:p>
-        </p:txBody>
-      </p:sp>
-      <p:sp>
-        <p:nvSpPr>
-          <p:cNvPr id="3" name="Date Placeholder 2"/>
-          <p:cNvSpPr>
-            <a:spLocks noGrp="1"/>
-          </p:cNvSpPr>
-          <p:nvPr>
-            <p:ph type="dt" idx="1"/>
-          </p:nvPr>
-        </p:nvSpPr>
-        <p:spPr>
-          <a:xfrm>
-            <a:off x="3884613" y="0"/>
-            <a:ext cx="2971800" cy="458788"/>
-          </a:xfrm>
-          <a:prstGeom prst="rect">
-            <a:avLst/>
-          </a:prstGeom>
-        </p:spPr>
-        <p:txBody>
-          <a:bodyPr vert="horz" lIns="91440" tIns="45720" rIns="91440" bIns="45720" rtlCol="0"/>
-          <a:lstStyle>
-            <a:lvl1pPr algn="r">
-              <a:defRPr sz="1200"/>
-            </a:lvl1pPr>
-          </a:lstStyle>
-          <a:p>
-            <a:fld id="{5282F153-3F37-0F45-9E97-73ACFA13230C}" type="datetimeFigureOut">
-              <a:rPr lang="en-US"/>
-              <a:t>7/23/19</a:t>
-            </a:fld>
-            <a:endParaRPr lang="en-US"/>
-          </a:p>
-        </p:txBody>
-      </p:sp>
-      <p:sp>
-        <p:nvSpPr>
-          <p:cNvPr id="4" name="Slide Image Placeholder 3"/>
-          <p:cNvSpPr>
-            <a:spLocks noGrp="1" noRot="1" noChangeAspect="1"/>
-          </p:cNvSpPr>
-          <p:nvPr>
-            <p:ph type="sldImg" idx="2"/>
-          </p:nvPr>
-        </p:nvSpPr>
-        <p:spPr>
-          <a:xfrm>
-            <a:off x="685800" y="1143000"/>
-            <a:ext cx="5486400" cy="3086100"/>
-          </a:xfrm>
-          <a:prstGeom prst="rect">
-            <a:avLst/>
-          </a:prstGeom>
-          <a:noFill/>
-          <a:ln w="12700">
-            <a:solidFill>
-              <a:prstClr val="black"/>
-            </a:solidFill>
-          </a:ln>
-        </p:spPr>
-        <p:txBody>
-          <a:bodyPr vert="horz" lIns="91440" tIns="45720" rIns="91440" bIns="45720" rtlCol="0" anchor="ctr"/>
-          <a:lstStyle/>
-          <a:p>
-            <a:endParaRPr lang="en-US"/>
-          </a:p>
-        </p:txBody>
-      </p:sp>
-      <p:sp>
-        <p:nvSpPr>
-          <p:cNvPr id="5" name="Notes Placeholder 4"/>
-          <p:cNvSpPr>
-            <a:spLocks noGrp="1"/>
-          </p:cNvSpPr>
-          <p:nvPr>
-            <p:ph type="body" sz="quarter" idx="3"/>
-          </p:nvPr>
-        </p:nvSpPr>
-        <p:spPr>
-          <a:xfrm>
-            <a:off x="685800" y="4400550"/>
-            <a:ext cx="5486400" cy="3600450"/>
-          </a:xfrm>
-          <a:prstGeom prst="rect">
-            <a:avLst/>
-          </a:prstGeom>
-        </p:spPr>
-        <p:txBody>
-          <a:bodyPr vert="horz" lIns="91440" tIns="45720" rIns="91440" bIns="45720" rtlCol="0"/>
-          <a:lstStyle/>
-          <a:p>
-            <a:pPr lvl="0"/>
-            <a:r>
-              <a:rPr lang="en-US"/>
-              <a:t>Click to edit Master text styles</a:t>
-            </a:r>
-          </a:p>
-          <a:p>
-            <a:pPr lvl="1"/>
-            <a:r>
-              <a:rPr lang="en-US"/>
-              <a:t>Second level</a:t>
-            </a:r>
-          </a:p>
-          <a:p>
-            <a:pPr lvl="2"/>
-            <a:r>
-              <a:rPr lang="en-US"/>
-              <a:t>Third level</a:t>
-            </a:r>
-          </a:p>
-          <a:p>
-            <a:pPr lvl="3"/>
-            <a:r>
-              <a:rPr lang="en-US"/>
-              <a:t>Fourth level</a:t>
-            </a:r>
-          </a:p>
-          <a:p>
-            <a:pPr lvl="4"/>
-            <a:r>
-              <a:rPr lang="en-US"/>
-              <a:t>Fifth level</a:t>
-            </a:r>
-          </a:p>
-        </p:txBody>
-      </p:sp>
-      <p:sp>
-        <p:nvSpPr>
-          <p:cNvPr id="6" name="Footer Placeholder 5"/>
-          <p:cNvSpPr>
-            <a:spLocks noGrp="1"/>
-          </p:cNvSpPr>
-          <p:nvPr>
-            <p:ph type="ftr" sz="quarter" idx="4"/>
-          </p:nvPr>
-        </p:nvSpPr>
-        <p:spPr>
-          <a:xfrm>
-            <a:off x="0" y="8685213"/>
-            <a:ext cx="2971800" cy="458787"/>
-          </a:xfrm>
-          <a:prstGeom prst="rect">
-            <a:avLst/>
-          </a:prstGeom>
-        </p:spPr>
-        <p:txBody>
-          <a:bodyPr vert="horz" lIns="91440" tIns="45720" rIns="91440" bIns="45720" rtlCol="0" anchor="b"/>
-          <a:lstStyle>
-            <a:lvl1pPr algn="l">
-              <a:defRPr sz="1200"/>
-            </a:lvl1pPr>
-          </a:lstStyle>
-          <a:p>
-            <a:endParaRPr lang="en-US"/>
-          </a:p>
-        </p:txBody>
-      </p:sp>
-      <p:sp>
-        <p:nvSpPr>
-          <p:cNvPr id="7" name="Slide Number Placeholder 6"/>
-          <p:cNvSpPr>
-            <a:spLocks noGrp="1"/>
-          </p:cNvSpPr>
-          <p:nvPr>
-            <p:ph type="sldNum" sz="quarter" idx="5"/>
-          </p:nvPr>
-        </p:nvSpPr>
-        <p:spPr>
-          <a:xfrm>
-            <a:off x="3884613" y="8685213"/>
-            <a:ext cx="2971800" cy="458787"/>
-          </a:xfrm>
-          <a:prstGeom prst="rect">
-            <a:avLst/>
-          </a:prstGeom>
-        </p:spPr>
-        <p:txBody>
-          <a:bodyPr vert="horz" lIns="91440" tIns="45720" rIns="91440" bIns="45720" rtlCol="0" anchor="b"/>
-          <a:lstStyle>
-            <a:lvl1pPr algn="r">
-              <a:defRPr sz="1200"/>
-            </a:lvl1pPr>
-          </a:lstStyle>
-          <a:p>
-            <a:fld id="{CE5E9CC1-C706-0F49-92D6-E571CC5EEA8F}" type="slidenum">
-              <a:rPr lang="en-US"/>
-              <a:t>‹#›</a:t>
-            </a:fld>
-            <a:endParaRPr lang="en-US"/>
-          </a:p>
-        </p:txBody>
-      </p:sp>
     </p:spTree>
     <p:extLst>
       <p:ext uri="{BB962C8B-B14F-4D97-AF65-F5344CB8AC3E}">
-        <p14:creationId xmlns:p14="http://schemas.microsoft.com/office/powerpoint/2010/main" val="1024086991"/>
+        <p14:creationId xmlns:p14="http://schemas.microsoft.com/office/powerpoint/2010/main" val="3697216142"/>
       </p:ext>
     </p:extLst>
   </p:cSld>
@@ -505,10 +287,6 @@
           <a:bodyPr/>
           <a:lstStyle/>
           <a:p>
-            <a:r>
-              <a:rPr lang="en-US" dirty="0"/>
-              <a:t/>
-            </a:r>
             <a:endParaRPr lang="en-US" dirty="0"/>
           </a:p>
         </p:txBody>
@@ -593,10 +371,6 @@
           <a:bodyPr/>
           <a:lstStyle/>
           <a:p>
-            <a:r>
-              <a:rPr lang="en-US" dirty="0"/>
-              <a:t/>
-            </a:r>
             <a:endParaRPr lang="en-US" dirty="0"/>
           </a:p>
         </p:txBody>
@@ -642,7 +416,13 @@
   <p:cSld>
     <p:spTree>
       <p:nvGrpSpPr>
-        <p:cNvPr id="1" name=""/>
+        <p:cNvPr id="1" name="">
+          <a:extLst>
+            <a:ext uri="{FF2B5EF4-FFF2-40B4-BE49-F238E27FC236}">
+              <a16:creationId xmlns:a16="http://schemas.microsoft.com/office/drawing/2014/main" id="{64361144-5959-0284-6E62-4E5539B456C6}"/>
+            </a:ext>
+          </a:extLst>
+        </p:cNvPr>
         <p:cNvGrpSpPr/>
         <p:nvPr/>
       </p:nvGrpSpPr>
@@ -656,7 +436,13 @@
       </p:grpSpPr>
       <p:sp>
         <p:nvSpPr>
-          <p:cNvPr id="2" name="Slide Image Placeholder 1"/>
+          <p:cNvPr id="2" name="Slide Image Placeholder 1">
+            <a:extLst>
+              <a:ext uri="{FF2B5EF4-FFF2-40B4-BE49-F238E27FC236}">
+                <a16:creationId xmlns:a16="http://schemas.microsoft.com/office/drawing/2014/main" id="{5C51189E-D5E0-7D61-8131-05FDF9E6D95A}"/>
+              </a:ext>
+            </a:extLst>
+          </p:cNvPr>
           <p:cNvSpPr>
             <a:spLocks noGrp="1" noRot="1" noChangeAspect="1"/>
           </p:cNvSpPr>
@@ -668,7 +454,13 @@
       </p:sp>
       <p:sp>
         <p:nvSpPr>
-          <p:cNvPr id="3" name="Notes Placeholder 2"/>
+          <p:cNvPr id="3" name="Notes Placeholder 2">
+            <a:extLst>
+              <a:ext uri="{FF2B5EF4-FFF2-40B4-BE49-F238E27FC236}">
+                <a16:creationId xmlns:a16="http://schemas.microsoft.com/office/drawing/2014/main" id="{97D735A1-A9BF-6049-A1F5-AE3BFC940A0A}"/>
+              </a:ext>
+            </a:extLst>
+          </p:cNvPr>
           <p:cNvSpPr>
             <a:spLocks noGrp="1"/>
           </p:cNvSpPr>
@@ -681,17 +473,19 @@
           <a:bodyPr/>
           <a:lstStyle/>
           <a:p>
-            <a:r>
-              <a:rPr lang="en-US" dirty="0"/>
-              <a:t/>
-            </a:r>
             <a:endParaRPr lang="en-US" dirty="0"/>
           </a:p>
         </p:txBody>
       </p:sp>
       <p:sp>
         <p:nvSpPr>
-          <p:cNvPr id="4" name="Slide Number Placeholder 3"/>
+          <p:cNvPr id="4" name="Slide Number Placeholder 3">
+            <a:extLst>
+              <a:ext uri="{FF2B5EF4-FFF2-40B4-BE49-F238E27FC236}">
+                <a16:creationId xmlns:a16="http://schemas.microsoft.com/office/drawing/2014/main" id="{DE676E27-EC82-8CD3-C75F-EAFE34C49369}"/>
+              </a:ext>
+            </a:extLst>
+          </p:cNvPr>
           <p:cNvSpPr>
             <a:spLocks noGrp="1"/>
           </p:cNvSpPr>
@@ -704,18 +498,78 @@
           <a:bodyPr/>
           <a:lstStyle/>
           <a:p>
+            <a:pPr marL="0" marR="0" lvl="0" indent="0" algn="l" defTabSz="914400" rtl="0" eaLnBrk="1" fontAlgn="auto" latinLnBrk="0" hangingPunct="1">
+              <a:lnSpc>
+                <a:spcPct val="100000"/>
+              </a:lnSpc>
+              <a:spcBef>
+                <a:spcPts val="0"/>
+              </a:spcBef>
+              <a:spcAft>
+                <a:spcPts val="0"/>
+              </a:spcAft>
+              <a:buClrTx/>
+              <a:buSzTx/>
+              <a:buFontTx/>
+              <a:buNone/>
+              <a:tabLst/>
+              <a:defRPr/>
+            </a:pPr>
             <a:fld id="{F7021451-1387-4CA6-816F-3879F97B5CBC}" type="slidenum">
-              <a:rPr lang="en-US"/>
+              <a:rPr kumimoji="0" lang="en-US" sz="1800" b="0" i="0" u="none" strike="noStrike" kern="1200" cap="none" spc="0" normalizeH="0" baseline="0" noProof="0">
+                <a:ln>
+                  <a:noFill/>
+                </a:ln>
+                <a:solidFill>
+                  <a:prstClr val="black"/>
+                </a:solidFill>
+                <a:effectLst/>
+                <a:uLnTx/>
+                <a:uFillTx/>
+                <a:latin typeface="Aptos" panose="02110004020202020204"/>
+                <a:ea typeface="+mn-ea"/>
+                <a:cs typeface="+mn-cs"/>
+              </a:rPr>
+              <a:pPr marL="0" marR="0" lvl="0" indent="0" algn="l" defTabSz="914400" rtl="0" eaLnBrk="1" fontAlgn="auto" latinLnBrk="0" hangingPunct="1">
+                <a:lnSpc>
+                  <a:spcPct val="100000"/>
+                </a:lnSpc>
+                <a:spcBef>
+                  <a:spcPts val="0"/>
+                </a:spcBef>
+                <a:spcAft>
+                  <a:spcPts val="0"/>
+                </a:spcAft>
+                <a:buClrTx/>
+                <a:buSzTx/>
+                <a:buFontTx/>
+                <a:buNone/>
+                <a:tabLst/>
+                <a:defRPr/>
+              </a:pPr>
               <a:t>3</a:t>
             </a:fld>
-            <a:endParaRPr lang="en-US"/>
+            <a:endParaRPr kumimoji="0" lang="en-US" sz="1800" b="0" i="0" u="none" strike="noStrike" kern="1200" cap="none" spc="0" normalizeH="0" baseline="0" noProof="0">
+              <a:ln>
+                <a:noFill/>
+              </a:ln>
+              <a:solidFill>
+                <a:prstClr val="black"/>
+              </a:solidFill>
+              <a:effectLst/>
+              <a:uLnTx/>
+              <a:uFillTx/>
+              <a:latin typeface="Aptos" panose="02110004020202020204"/>
+              <a:ea typeface="+mn-ea"/>
+              <a:cs typeface="+mn-cs"/>
+            </a:endParaRPr>
           </a:p>
         </p:txBody>
       </p:sp>
     </p:spTree>
     <p:extLst>
       <p:ext uri="{BB962C8B-B14F-4D97-AF65-F5344CB8AC3E}">
-        <p14:creationId xmlns:p14="http://schemas.microsoft.com/office/powerpoint/2010/main" val="1024086991"/>
+        <p14:creationId xmlns:p14="http://schemas.microsoft.com/office/powerpoint/2010/main" val="286157490"/>
       </p:ext>
     </p:extLst>
   </p:cSld>
@@ -769,10 +623,6 @@
           <a:bodyPr/>
           <a:lstStyle/>
           <a:p>
-            <a:r>
-              <a:rPr lang="en-US" dirty="0"/>
-              <a:t/>
-            </a:r>
             <a:endParaRPr lang="en-US" dirty="0"/>
           </a:p>
         </p:txBody>
@@ -857,10 +707,6 @@
           <a:bodyPr/>
           <a:lstStyle/>
           <a:p>
-            <a:r>
-              <a:rPr lang="en-US" dirty="0"/>
-              <a:t/>
-            </a:r>
             <a:endParaRPr lang="en-US" dirty="0"/>
           </a:p>
         </p:txBody>
@@ -945,10 +791,6 @@
           <a:bodyPr/>
           <a:lstStyle/>
           <a:p>
-            <a:r>
-              <a:rPr lang="en-US" dirty="0"/>
-              <a:t/>
-            </a:r>
             <a:endParaRPr lang="en-US" dirty="0"/>
           </a:p>
         </p:txBody>
@@ -971,6 +813,90 @@
             <a:fld id="{F7021451-1387-4CA6-816F-3879F97B5CBC}" type="slidenum">
               <a:rPr lang="en-US"/>
               <a:t>6</a:t>
+            </a:fld>
+            <a:endParaRPr lang="en-US"/>
+          </a:p>
+        </p:txBody>
+      </p:sp>
+    </p:spTree>
+    <p:extLst>
+      <p:ext uri="{BB962C8B-B14F-4D97-AF65-F5344CB8AC3E}">
+        <p14:creationId xmlns:p14="http://schemas.microsoft.com/office/powerpoint/2010/main" val="1024086991"/>
+      </p:ext>
+    </p:extLst>
+  </p:cSld>
+  <p:clrMapOvr>
+    <a:masterClrMapping/>
+  </p:clrMapOvr>
+</p:notes>
+</file>
+
+<file path=ppt/notesSlides/notesSlide7.xml><?xml version="1.0" encoding="utf-8"?>
+<p:notes xmlns:a="http://schemas.openxmlformats.org/drawingml/2006/main" xmlns:r="http://schemas.openxmlformats.org/officeDocument/2006/relationships" xmlns:p="http://schemas.openxmlformats.org/presentationml/2006/main">
+  <p:cSld>
+    <p:spTree>
+      <p:nvGrpSpPr>
+        <p:cNvPr id="1" name=""/>
+        <p:cNvGrpSpPr/>
+        <p:nvPr/>
+      </p:nvGrpSpPr>
+      <p:grpSpPr>
+        <a:xfrm>
+          <a:off x="0" y="0"/>
+          <a:ext cx="0" cy="0"/>
+          <a:chOff x="0" y="0"/>
+          <a:chExt cx="0" cy="0"/>
+        </a:xfrm>
+      </p:grpSpPr>
+      <p:sp>
+        <p:nvSpPr>
+          <p:cNvPr id="2" name="Slide Image Placeholder 1"/>
+          <p:cNvSpPr>
+            <a:spLocks noGrp="1" noRot="1" noChangeAspect="1"/>
+          </p:cNvSpPr>
+          <p:nvPr>
+            <p:ph type="sldImg"/>
+          </p:nvPr>
+        </p:nvSpPr>
+        <p:spPr/>
+      </p:sp>
+      <p:sp>
+        <p:nvSpPr>
+          <p:cNvPr id="3" name="Notes Placeholder 2"/>
+          <p:cNvSpPr>
+            <a:spLocks noGrp="1"/>
+          </p:cNvSpPr>
+          <p:nvPr>
+            <p:ph type="body" idx="1"/>
+          </p:nvPr>
+        </p:nvSpPr>
+        <p:spPr/>
+        <p:txBody>
+          <a:bodyPr/>
+          <a:lstStyle/>
+          <a:p>
+            <a:endParaRPr lang="en-US" dirty="0"/>
+          </a:p>
+        </p:txBody>
+      </p:sp>
+      <p:sp>
+        <p:nvSpPr>
+          <p:cNvPr id="4" name="Slide Number Placeholder 3"/>
+          <p:cNvSpPr>
+            <a:spLocks noGrp="1"/>
+          </p:cNvSpPr>
+          <p:nvPr>
+            <p:ph type="sldNum" sz="quarter" idx="10"/>
+          </p:nvPr>
+        </p:nvSpPr>
+        <p:spPr/>
+        <p:txBody>
+          <a:bodyPr/>
+          <a:lstStyle/>
+          <a:p>
+            <a:fld id="{F7021451-1387-4CA6-816F-3879F97B5CBC}" type="slidenum">
+              <a:rPr lang="en-US"/>
+              <a:t>7</a:t>
             </a:fld>
             <a:endParaRPr lang="en-US"/>
           </a:p>
@@ -1022,6 +948,11 @@
 <file path=ppt/slideMasters/slideMaster1.xml><?xml version="1.0" encoding="utf-8"?>
 <p:sldMaster xmlns:a="http://schemas.openxmlformats.org/drawingml/2006/main" xmlns:r="http://schemas.openxmlformats.org/officeDocument/2006/relationships" xmlns:p="http://schemas.openxmlformats.org/presentationml/2006/main">
   <p:cSld>
+    <p:bg>
+      <p:bgRef idx="1001">
+        <a:schemeClr val="bg1"/>
+      </p:bgRef>
+    </p:bg>
     <p:spTree>
       <p:nvGrpSpPr>
         <p:cNvPr id="1" name=""/>
@@ -1304,6 +1235,7 @@
         <a:solidFill>
           <a:srgbClr val="0F1724"/>
         </a:solidFill>
+        <a:effectLst/>
       </p:bgPr>
     </p:bg>
     <p:spTree>
@@ -1339,6 +1271,13 @@
           </a:solidFill>
           <a:ln/>
         </p:spPr>
+        <p:txBody>
+          <a:bodyPr/>
+          <a:lstStyle/>
+          <a:p>
+            <a:endParaRPr lang="en-US"/>
+          </a:p>
+        </p:txBody>
       </p:sp>
       <p:sp>
         <p:nvSpPr>
@@ -1359,6 +1298,13 @@
           </a:solidFill>
           <a:ln/>
         </p:spPr>
+        <p:txBody>
+          <a:bodyPr/>
+          <a:lstStyle/>
+          <a:p>
+            <a:endParaRPr lang="en-US"/>
+          </a:p>
+        </p:txBody>
       </p:sp>
       <p:sp>
         <p:nvSpPr>
@@ -1381,11 +1327,11 @@
           <a:bodyPr wrap="square" lIns="0" tIns="0" rIns="0" bIns="0" rtlCol="0" anchor="ctr"/>
           <a:lstStyle/>
           <a:p>
-            <a:pPr indent="0" marL="0">
+            <a:pPr marL="0" indent="0">
               <a:buNone/>
             </a:pPr>
             <a:r>
-              <a:rPr lang="en-US" sz="1100" b="1" spc="800" kern="0" dirty="0">
+              <a:rPr lang="en-US" sz="1100" b="1" kern="0" spc="800" dirty="0">
                 <a:solidFill>
                   <a:srgbClr val="E67E22"/>
                 </a:solidFill>
@@ -1420,7 +1366,7 @@
           <a:bodyPr wrap="square" lIns="0" tIns="0" rIns="0" bIns="0" rtlCol="0" anchor="ctr"/>
           <a:lstStyle/>
           <a:p>
-            <a:pPr indent="0" marL="0">
+            <a:pPr marL="0" indent="0">
               <a:buNone/>
             </a:pPr>
             <a:r>
@@ -1459,7 +1405,7 @@
           <a:bodyPr wrap="square" lIns="0" tIns="0" rIns="0" bIns="0" rtlCol="0" anchor="ctr"/>
           <a:lstStyle/>
           <a:p>
-            <a:pPr indent="0" marL="0">
+            <a:pPr marL="0" indent="0">
               <a:buNone/>
             </a:pPr>
             <a:r>
@@ -1498,7 +1444,7 @@
           <a:bodyPr wrap="square" lIns="0" tIns="0" rIns="0" bIns="0" rtlCol="0" anchor="ctr"/>
           <a:lstStyle/>
           <a:p>
-            <a:pPr indent="0" marL="0">
+            <a:pPr marL="0" indent="0">
               <a:buNone/>
             </a:pPr>
             <a:r>
@@ -1515,7 +1461,7 @@
             <a:endParaRPr lang="en-US" sz="1200" dirty="0"/>
           </a:p>
           <a:p>
-            <a:pPr indent="0" marL="0">
+            <a:pPr marL="0" indent="0">
               <a:buNone/>
             </a:pPr>
             <a:r>
@@ -1554,7 +1500,7 @@
           <a:bodyPr wrap="square" lIns="0" tIns="0" rIns="0" bIns="0" rtlCol="0" anchor="ctr"/>
           <a:lstStyle/>
           <a:p>
-            <a:pPr indent="0" marL="0">
+            <a:pPr marL="0" indent="0">
               <a:buNone/>
             </a:pPr>
             <a:r>
@@ -1594,6 +1540,13 @@
             <a:prstDash val="solid"/>
           </a:ln>
         </p:spPr>
+        <p:txBody>
+          <a:bodyPr/>
+          <a:lstStyle/>
+          <a:p>
+            <a:endParaRPr lang="en-US"/>
+          </a:p>
+        </p:txBody>
       </p:sp>
       <p:sp>
         <p:nvSpPr>
@@ -1616,11 +1569,11 @@
           <a:bodyPr wrap="square" lIns="0" tIns="0" rIns="0" bIns="0" rtlCol="0" anchor="ctr"/>
           <a:lstStyle/>
           <a:p>
-            <a:pPr indent="0" marL="0">
+            <a:pPr marL="0" indent="0">
               <a:buNone/>
             </a:pPr>
             <a:r>
-              <a:rPr lang="en-US" sz="1000" b="1" spc="600" kern="0" dirty="0">
+              <a:rPr lang="en-US" sz="1000" b="1" kern="0" spc="600" dirty="0">
                 <a:solidFill>
                   <a:srgbClr val="E67E22"/>
                 </a:solidFill>
@@ -1658,6 +1611,13 @@
             <a:prstDash val="solid"/>
           </a:ln>
         </p:spPr>
+        <p:txBody>
+          <a:bodyPr/>
+          <a:lstStyle/>
+          <a:p>
+            <a:endParaRPr lang="en-US"/>
+          </a:p>
+        </p:txBody>
       </p:sp>
       <p:sp>
         <p:nvSpPr>
@@ -1680,7 +1640,7 @@
           <a:bodyPr wrap="square" lIns="0" tIns="0" rIns="0" bIns="0" rtlCol="0" anchor="ctr"/>
           <a:lstStyle/>
           <a:p>
-            <a:pPr algn="l" indent="0" marL="0">
+            <a:pPr marL="0" indent="0" algn="l">
               <a:buNone/>
             </a:pPr>
             <a:r>
@@ -1719,11 +1679,11 @@
           <a:bodyPr wrap="square" lIns="0" tIns="0" rIns="0" bIns="0" rtlCol="0" anchor="t"/>
           <a:lstStyle/>
           <a:p>
-            <a:pPr algn="l" indent="0" marL="0">
+            <a:pPr marL="0" indent="0" algn="l">
               <a:buNone/>
             </a:pPr>
             <a:r>
-              <a:rPr lang="en-US" sz="950" b="1" spc="300" kern="0" dirty="0">
+              <a:rPr lang="en-US" sz="950" b="1" kern="0" spc="300" dirty="0">
                 <a:solidFill>
                   <a:srgbClr val="FFFFFF"/>
                 </a:solidFill>
@@ -1758,7 +1718,7 @@
           <a:bodyPr wrap="square" lIns="25400" tIns="25400" rIns="25400" bIns="25400" rtlCol="0" anchor="ctr"/>
           <a:lstStyle/>
           <a:p>
-            <a:pPr algn="l" indent="0" marL="0">
+            <a:pPr marL="0" indent="0" algn="l">
               <a:buNone/>
             </a:pPr>
             <a:r>
@@ -1775,7 +1735,7 @@
             <a:endParaRPr lang="en-US" sz="900" dirty="0"/>
           </a:p>
           <a:p>
-            <a:pPr algn="l" indent="0" marL="0">
+            <a:pPr marL="0" indent="0" algn="l">
               <a:buNone/>
             </a:pPr>
             <a:r>
@@ -1817,6 +1777,13 @@
             <a:prstDash val="solid"/>
           </a:ln>
         </p:spPr>
+        <p:txBody>
+          <a:bodyPr/>
+          <a:lstStyle/>
+          <a:p>
+            <a:endParaRPr lang="en-US"/>
+          </a:p>
+        </p:txBody>
       </p:sp>
       <p:sp>
         <p:nvSpPr>
@@ -1839,7 +1806,7 @@
           <a:bodyPr wrap="square" lIns="0" tIns="0" rIns="0" bIns="0" rtlCol="0" anchor="ctr"/>
           <a:lstStyle/>
           <a:p>
-            <a:pPr algn="l" indent="0" marL="0">
+            <a:pPr marL="0" indent="0" algn="l">
               <a:buNone/>
             </a:pPr>
             <a:r>
@@ -1878,11 +1845,11 @@
           <a:bodyPr wrap="square" lIns="0" tIns="0" rIns="0" bIns="0" rtlCol="0" anchor="t"/>
           <a:lstStyle/>
           <a:p>
-            <a:pPr algn="l" indent="0" marL="0">
+            <a:pPr marL="0" indent="0" algn="l">
               <a:buNone/>
             </a:pPr>
             <a:r>
-              <a:rPr lang="en-US" sz="950" b="1" spc="300" kern="0" dirty="0">
+              <a:rPr lang="en-US" sz="950" b="1" kern="0" spc="300" dirty="0">
                 <a:solidFill>
                   <a:srgbClr val="FFFFFF"/>
                 </a:solidFill>
@@ -1917,7 +1884,7 @@
           <a:bodyPr wrap="square" lIns="25400" tIns="25400" rIns="25400" bIns="25400" rtlCol="0" anchor="ctr"/>
           <a:lstStyle/>
           <a:p>
-            <a:pPr algn="l" indent="0" marL="0">
+            <a:pPr marL="0" indent="0" algn="l">
               <a:buNone/>
             </a:pPr>
             <a:r>
@@ -1934,7 +1901,7 @@
             <a:endParaRPr lang="en-US" sz="900" dirty="0"/>
           </a:p>
           <a:p>
-            <a:pPr algn="l" indent="0" marL="0">
+            <a:pPr marL="0" indent="0" algn="l">
               <a:buNone/>
             </a:pPr>
             <a:r>
@@ -1976,6 +1943,13 @@
             <a:prstDash val="solid"/>
           </a:ln>
         </p:spPr>
+        <p:txBody>
+          <a:bodyPr/>
+          <a:lstStyle/>
+          <a:p>
+            <a:endParaRPr lang="en-US"/>
+          </a:p>
+        </p:txBody>
       </p:sp>
       <p:sp>
         <p:nvSpPr>
@@ -1998,7 +1972,7 @@
           <a:bodyPr wrap="square" lIns="0" tIns="0" rIns="0" bIns="0" rtlCol="0" anchor="ctr"/>
           <a:lstStyle/>
           <a:p>
-            <a:pPr algn="l" indent="0" marL="0">
+            <a:pPr marL="0" indent="0" algn="l">
               <a:buNone/>
             </a:pPr>
             <a:r>
@@ -2037,11 +2011,11 @@
           <a:bodyPr wrap="square" lIns="0" tIns="0" rIns="0" bIns="0" rtlCol="0" anchor="t"/>
           <a:lstStyle/>
           <a:p>
-            <a:pPr algn="l" indent="0" marL="0">
+            <a:pPr marL="0" indent="0" algn="l">
               <a:buNone/>
             </a:pPr>
             <a:r>
-              <a:rPr lang="en-US" sz="950" b="1" spc="300" kern="0" dirty="0">
+              <a:rPr lang="en-US" sz="950" b="1" kern="0" spc="300" dirty="0">
                 <a:solidFill>
                   <a:srgbClr val="FFFFFF"/>
                 </a:solidFill>
@@ -2076,7 +2050,7 @@
           <a:bodyPr wrap="square" lIns="25400" tIns="25400" rIns="25400" bIns="25400" rtlCol="0" anchor="ctr"/>
           <a:lstStyle/>
           <a:p>
-            <a:pPr algn="l" indent="0" marL="0">
+            <a:pPr marL="0" indent="0" algn="l">
               <a:buNone/>
             </a:pPr>
             <a:r>
@@ -2093,7 +2067,7 @@
             <a:endParaRPr lang="en-US" sz="900" dirty="0"/>
           </a:p>
           <a:p>
-            <a:pPr algn="l" indent="0" marL="0">
+            <a:pPr marL="0" indent="0" algn="l">
               <a:buNone/>
             </a:pPr>
             <a:r>
@@ -2132,7 +2106,7 @@
           <a:bodyPr wrap="square" lIns="0" tIns="0" rIns="0" bIns="0" rtlCol="0" anchor="ctr"/>
           <a:lstStyle/>
           <a:p>
-            <a:pPr algn="l" indent="0" marL="0">
+            <a:pPr marL="0" indent="0" algn="l">
               <a:buNone/>
             </a:pPr>
             <a:r>
@@ -2166,6 +2140,7 @@
         <a:solidFill>
           <a:srgbClr val="FAF5EC"/>
         </a:solidFill>
+        <a:effectLst/>
       </p:bgPr>
     </p:bg>
     <p:spTree>
@@ -2201,6 +2176,13 @@
           </a:solidFill>
           <a:ln/>
         </p:spPr>
+        <p:txBody>
+          <a:bodyPr/>
+          <a:lstStyle/>
+          <a:p>
+            <a:endParaRPr lang="en-US"/>
+          </a:p>
+        </p:txBody>
       </p:sp>
       <p:sp>
         <p:nvSpPr>
@@ -2221,6 +2203,13 @@
           </a:solidFill>
           <a:ln/>
         </p:spPr>
+        <p:txBody>
+          <a:bodyPr/>
+          <a:lstStyle/>
+          <a:p>
+            <a:endParaRPr lang="en-US"/>
+          </a:p>
+        </p:txBody>
       </p:sp>
       <p:sp>
         <p:nvSpPr>
@@ -2243,11 +2232,11 @@
           <a:bodyPr wrap="square" lIns="0" tIns="0" rIns="0" bIns="0" rtlCol="0" anchor="ctr"/>
           <a:lstStyle/>
           <a:p>
-            <a:pPr indent="0" marL="0">
+            <a:pPr marL="0" indent="0">
               <a:buNone/>
             </a:pPr>
             <a:r>
-              <a:rPr lang="en-US" sz="1000" b="1" spc="600" kern="0" dirty="0">
+              <a:rPr lang="en-US" sz="1000" b="1" kern="0" spc="600" dirty="0">
                 <a:solidFill>
                   <a:srgbClr val="E67E22"/>
                 </a:solidFill>
@@ -2282,7 +2271,7 @@
           <a:bodyPr wrap="square" lIns="0" tIns="0" rIns="0" bIns="0" rtlCol="0" anchor="ctr"/>
           <a:lstStyle/>
           <a:p>
-            <a:pPr indent="0" marL="0">
+            <a:pPr marL="0" indent="0">
               <a:buNone/>
             </a:pPr>
             <a:r>
@@ -2321,11 +2310,11 @@
           <a:bodyPr wrap="square" lIns="0" tIns="0" rIns="0" bIns="0" rtlCol="0" anchor="ctr"/>
           <a:lstStyle/>
           <a:p>
-            <a:pPr indent="0" marL="0">
+            <a:pPr marL="0" indent="0">
               <a:buNone/>
             </a:pPr>
             <a:r>
-              <a:rPr lang="en-US" sz="900" b="1" spc="400" kern="0" dirty="0">
+              <a:rPr lang="en-US" sz="900" b="1" kern="0" spc="400" dirty="0">
                 <a:solidFill>
                   <a:srgbClr val="E67E22"/>
                 </a:solidFill>
@@ -2360,7 +2349,7 @@
           <a:bodyPr wrap="square" lIns="0" tIns="0" rIns="0" bIns="0" rtlCol="0" anchor="ctr"/>
           <a:lstStyle/>
           <a:p>
-            <a:pPr indent="0" marL="0">
+            <a:pPr marL="0" indent="0">
               <a:buNone/>
             </a:pPr>
             <a:r>
@@ -2380,211 +2369,7 @@
       </p:sp>
       <p:pic>
         <p:nvPicPr>
-          <p:cNvPr id="8" name="Image 0" descr="/sessions/sharp-quirky-brown/mnt/TP Final AdD 2026/TP Final AdD/images_tutorial/fig_panel_temporal_hora_dia_mes.png">    </p:cNvPr>
-          <p:cNvPicPr>
-            <a:picLocks noChangeAspect="1"/>
-          </p:cNvPicPr>
-          <p:nvPr/>
-        </p:nvPicPr>
-        <p:blipFill>
-          <a:blip r:embed="rId1"/>
-          <a:stretch>
-            <a:fillRect/>
-          </a:stretch>
-        </p:blipFill>
-        <p:spPr>
-          <a:xfrm>
-            <a:off x="320040" y="1444752"/>
-            <a:ext cx="4114800" cy="1371600"/>
-          </a:xfrm>
-          <a:prstGeom prst="rect">
-            <a:avLst/>
-          </a:prstGeom>
-        </p:spPr>
-      </p:pic>
-      <p:sp>
-        <p:nvSpPr>
-          <p:cNvPr id="9" name="Text 6"/>
-          <p:cNvSpPr/>
-          <p:nvPr/>
-        </p:nvSpPr>
-        <p:spPr>
-          <a:xfrm>
-            <a:off x="4709160" y="914400"/>
-            <a:ext cx="4114800" cy="228600"/>
-          </a:xfrm>
-          <a:prstGeom prst="rect">
-            <a:avLst/>
-          </a:prstGeom>
-          <a:noFill/>
-          <a:ln/>
-        </p:spPr>
-        <p:txBody>
-          <a:bodyPr wrap="square" lIns="0" tIns="0" rIns="0" bIns="0" rtlCol="0" anchor="ctr"/>
-          <a:lstStyle/>
-          <a:p>
-            <a:pPr indent="0" marL="0">
-              <a:buNone/>
-            </a:pPr>
-            <a:r>
-              <a:rPr lang="en-US" sz="900" b="1" spc="400" kern="0" dirty="0">
-                <a:solidFill>
-                  <a:srgbClr val="E67E22"/>
-                </a:solidFill>
-                <a:latin typeface="Arial" pitchFamily="34" charset="0"/>
-                <a:ea typeface="Arial" pitchFamily="34" charset="-122"/>
-                <a:cs typeface="Arial" pitchFamily="34" charset="-120"/>
-              </a:rPr>
-              <a:t>TOP 15 ESTACIONES · ORIGEN / DESTINO</a:t>
-            </a:r>
-            <a:endParaRPr lang="en-US" sz="900" dirty="0"/>
-          </a:p>
-        </p:txBody>
-      </p:sp>
-      <p:sp>
-        <p:nvSpPr>
-          <p:cNvPr id="10" name="Text 7"/>
-          <p:cNvSpPr/>
-          <p:nvPr/>
-        </p:nvSpPr>
-        <p:spPr>
-          <a:xfrm>
-            <a:off x="4709160" y="1115568"/>
-            <a:ext cx="4114800" cy="274320"/>
-          </a:xfrm>
-          <a:prstGeom prst="rect">
-            <a:avLst/>
-          </a:prstGeom>
-          <a:noFill/>
-          <a:ln/>
-        </p:spPr>
-        <p:txBody>
-          <a:bodyPr wrap="square" lIns="0" tIns="0" rIns="0" bIns="0" rtlCol="0" anchor="ctr"/>
-          <a:lstStyle/>
-          <a:p>
-            <a:pPr indent="0" marL="0">
-              <a:buNone/>
-            </a:pPr>
-            <a:r>
-              <a:rPr lang="en-US" sz="1000" i="1" dirty="0">
-                <a:solidFill>
-                  <a:srgbClr val="2C3E50"/>
-                </a:solidFill>
-                <a:latin typeface="Calibri" pitchFamily="34" charset="0"/>
-                <a:ea typeface="Calibri" pitchFamily="34" charset="-122"/>
-                <a:cs typeface="Calibri" pitchFamily="34" charset="-120"/>
-              </a:rPr>
-              <a:t>Concentración Pareto en microcentro · simetría origen-destino</a:t>
-            </a:r>
-            <a:endParaRPr lang="en-US" sz="1000" dirty="0"/>
-          </a:p>
-        </p:txBody>
-      </p:sp>
-      <p:pic>
-        <p:nvPicPr>
-          <p:cNvPr id="11" name="Image 1" descr="/sessions/sharp-quirky-brown/mnt/TP Final AdD 2026/TP Final AdD/images_tutorial/fig_top15_estaciones_origen_destino.png">    </p:cNvPr>
-          <p:cNvPicPr>
-            <a:picLocks noChangeAspect="1"/>
-          </p:cNvPicPr>
-          <p:nvPr/>
-        </p:nvPicPr>
-        <p:blipFill>
-          <a:blip r:embed="rId2"/>
-          <a:stretch>
-            <a:fillRect/>
-          </a:stretch>
-        </p:blipFill>
-        <p:spPr>
-          <a:xfrm>
-            <a:off x="4709160" y="1444752"/>
-            <a:ext cx="4114800" cy="1371600"/>
-          </a:xfrm>
-          <a:prstGeom prst="rect">
-            <a:avLst/>
-          </a:prstGeom>
-        </p:spPr>
-      </p:pic>
-      <p:sp>
-        <p:nvSpPr>
-          <p:cNvPr id="12" name="Text 8"/>
-          <p:cNvSpPr/>
-          <p:nvPr/>
-        </p:nvSpPr>
-        <p:spPr>
-          <a:xfrm>
-            <a:off x="320040" y="2926080"/>
-            <a:ext cx="4114800" cy="228600"/>
-          </a:xfrm>
-          <a:prstGeom prst="rect">
-            <a:avLst/>
-          </a:prstGeom>
-          <a:noFill/>
-          <a:ln/>
-        </p:spPr>
-        <p:txBody>
-          <a:bodyPr wrap="square" lIns="0" tIns="0" rIns="0" bIns="0" rtlCol="0" anchor="ctr"/>
-          <a:lstStyle/>
-          <a:p>
-            <a:pPr indent="0" marL="0">
-              <a:buNone/>
-            </a:pPr>
-            <a:r>
-              <a:rPr lang="en-US" sz="900" b="1" spc="400" kern="0" dirty="0">
-                <a:solidFill>
-                  <a:srgbClr val="E67E22"/>
-                </a:solidFill>
-                <a:latin typeface="Arial" pitchFamily="34" charset="0"/>
-                <a:ea typeface="Arial" pitchFamily="34" charset="-122"/>
-                <a:cs typeface="Arial" pitchFamily="34" charset="-120"/>
-              </a:rPr>
-              <a:t>DISTRIBUCIÓN DE duracion_minutos</a:t>
-            </a:r>
-            <a:endParaRPr lang="en-US" sz="900" dirty="0"/>
-          </a:p>
-        </p:txBody>
-      </p:sp>
-      <p:sp>
-        <p:nvSpPr>
-          <p:cNvPr id="13" name="Text 9"/>
-          <p:cNvSpPr/>
-          <p:nvPr/>
-        </p:nvSpPr>
-        <p:spPr>
-          <a:xfrm>
-            <a:off x="320040" y="3127248"/>
-            <a:ext cx="4114800" cy="274320"/>
-          </a:xfrm>
-          <a:prstGeom prst="rect">
-            <a:avLst/>
-          </a:prstGeom>
-          <a:noFill/>
-          <a:ln/>
-        </p:spPr>
-        <p:txBody>
-          <a:bodyPr wrap="square" lIns="0" tIns="0" rIns="0" bIns="0" rtlCol="0" anchor="ctr"/>
-          <a:lstStyle/>
-          <a:p>
-            <a:pPr indent="0" marL="0">
-              <a:buNone/>
-            </a:pPr>
-            <a:r>
-              <a:rPr lang="en-US" sz="1000" i="1" dirty="0">
-                <a:solidFill>
-                  <a:srgbClr val="2C3E50"/>
-                </a:solidFill>
-                <a:latin typeface="Calibri" pitchFamily="34" charset="0"/>
-                <a:ea typeface="Calibri" pitchFamily="34" charset="-122"/>
-                <a:cs typeface="Calibri" pitchFamily="34" charset="-120"/>
-              </a:rPr>
-              <a:t>Asimetría positiva · mediana ≈ 16 min · justifica discretización en 3 clases</a:t>
-            </a:r>
-            <a:endParaRPr lang="en-US" sz="1000" dirty="0"/>
-          </a:p>
-        </p:txBody>
-      </p:sp>
-      <p:pic>
-        <p:nvPicPr>
-          <p:cNvPr id="14" name="Image 2" descr="/sessions/sharp-quirky-brown/mnt/TP Final AdD 2026/TP Final AdD/images_tutorial/fig_histograma_duracion_minutos_dark.png">    </p:cNvPr>
+          <p:cNvPr id="8" name="Image 0" descr="/sessions/sharp-quirky-brown/mnt/TP Final AdD 2026/TP Final AdD/images_tutorial/fig_panel_temporal_hora_dia_mes.png"/>
           <p:cNvPicPr>
             <a:picLocks noChangeAspect="1"/>
           </p:cNvPicPr>
@@ -2598,7 +2383,7 @@
         </p:blipFill>
         <p:spPr>
           <a:xfrm>
-            <a:off x="320040" y="3456432"/>
+            <a:off x="320040" y="1444752"/>
             <a:ext cx="4114800" cy="1371600"/>
           </a:xfrm>
           <a:prstGeom prst="rect">
@@ -2608,13 +2393,13 @@
       </p:pic>
       <p:sp>
         <p:nvSpPr>
-          <p:cNvPr id="15" name="Text 10"/>
-          <p:cNvSpPr/>
-          <p:nvPr/>
-        </p:nvSpPr>
-        <p:spPr>
-          <a:xfrm>
-            <a:off x="4709160" y="2926080"/>
+          <p:cNvPr id="9" name="Text 6"/>
+          <p:cNvSpPr/>
+          <p:nvPr/>
+        </p:nvSpPr>
+        <p:spPr>
+          <a:xfrm>
+            <a:off x="4709160" y="914400"/>
             <a:ext cx="4114800" cy="228600"/>
           </a:xfrm>
           <a:prstGeom prst="rect">
@@ -2627,11 +2412,11 @@
           <a:bodyPr wrap="square" lIns="0" tIns="0" rIns="0" bIns="0" rtlCol="0" anchor="ctr"/>
           <a:lstStyle/>
           <a:p>
-            <a:pPr indent="0" marL="0">
+            <a:pPr marL="0" indent="0">
               <a:buNone/>
             </a:pPr>
             <a:r>
-              <a:rPr lang="en-US" sz="900" b="1" spc="400" kern="0" dirty="0">
+              <a:rPr lang="en-US" sz="900" b="1" kern="0" spc="400" dirty="0">
                 <a:solidFill>
                   <a:srgbClr val="E67E22"/>
                 </a:solidFill>
@@ -2639,7 +2424,7 @@
                 <a:ea typeface="Arial" pitchFamily="34" charset="-122"/>
                 <a:cs typeface="Arial" pitchFamily="34" charset="-120"/>
               </a:rPr>
-              <a:t>FALTANTES · MCAR / MAR / MNAR</a:t>
+              <a:t>TOP 15 ESTACIONES · ORIGEN / DESTINO</a:t>
             </a:r>
             <a:endParaRPr lang="en-US" sz="900" dirty="0"/>
           </a:p>
@@ -2647,13 +2432,13 @@
       </p:sp>
       <p:sp>
         <p:nvSpPr>
-          <p:cNvPr id="16" name="Text 11"/>
-          <p:cNvSpPr/>
-          <p:nvPr/>
-        </p:nvSpPr>
-        <p:spPr>
-          <a:xfrm>
-            <a:off x="4709160" y="3127248"/>
+          <p:cNvPr id="10" name="Text 7"/>
+          <p:cNvSpPr/>
+          <p:nvPr/>
+        </p:nvSpPr>
+        <p:spPr>
+          <a:xfrm>
+            <a:off x="4709160" y="1115568"/>
             <a:ext cx="4114800" cy="274320"/>
           </a:xfrm>
           <a:prstGeom prst="rect">
@@ -2666,7 +2451,7 @@
           <a:bodyPr wrap="square" lIns="0" tIns="0" rIns="0" bIns="0" rtlCol="0" anchor="ctr"/>
           <a:lstStyle/>
           <a:p>
-            <a:pPr indent="0" marL="0">
+            <a:pPr marL="0" indent="0">
               <a:buNone/>
             </a:pPr>
             <a:r>
@@ -2678,7 +2463,7 @@
                 <a:ea typeface="Calibri" pitchFamily="34" charset="-122"/>
                 <a:cs typeface="Calibri" pitchFamily="34" charset="-120"/>
               </a:rPr>
-              <a:t>Tipificación por variable · género (MNAR) · fecha_destino (MAR)</a:t>
+              <a:t>Concentración Pareto en microcentro · simetría origen-destino</a:t>
             </a:r>
             <a:endParaRPr lang="en-US" sz="1000" dirty="0"/>
           </a:p>
@@ -2686,7 +2471,7 @@
       </p:sp>
       <p:pic>
         <p:nvPicPr>
-          <p:cNvPr id="17" name="Image 3" descr="/sessions/sharp-quirky-brown/mnt/TP Final AdD 2026/TP Final AdD/images_tutorial/fig_faltantes_MCAR_MAR_MNAR_composite.png">    </p:cNvPr>
+          <p:cNvPr id="11" name="Image 1" descr="/sessions/sharp-quirky-brown/mnt/TP Final AdD 2026/TP Final AdD/images_tutorial/fig_top15_estaciones_origen_destino.png"/>
           <p:cNvPicPr>
             <a:picLocks noChangeAspect="1"/>
           </p:cNvPicPr>
@@ -2700,6 +2485,210 @@
         </p:blipFill>
         <p:spPr>
           <a:xfrm>
+            <a:off x="4709160" y="1444752"/>
+            <a:ext cx="4114800" cy="1371600"/>
+          </a:xfrm>
+          <a:prstGeom prst="rect">
+            <a:avLst/>
+          </a:prstGeom>
+        </p:spPr>
+      </p:pic>
+      <p:sp>
+        <p:nvSpPr>
+          <p:cNvPr id="12" name="Text 8"/>
+          <p:cNvSpPr/>
+          <p:nvPr/>
+        </p:nvSpPr>
+        <p:spPr>
+          <a:xfrm>
+            <a:off x="320040" y="2926080"/>
+            <a:ext cx="4114800" cy="228600"/>
+          </a:xfrm>
+          <a:prstGeom prst="rect">
+            <a:avLst/>
+          </a:prstGeom>
+          <a:noFill/>
+          <a:ln/>
+        </p:spPr>
+        <p:txBody>
+          <a:bodyPr wrap="square" lIns="0" tIns="0" rIns="0" bIns="0" rtlCol="0" anchor="ctr"/>
+          <a:lstStyle/>
+          <a:p>
+            <a:pPr marL="0" indent="0">
+              <a:buNone/>
+            </a:pPr>
+            <a:r>
+              <a:rPr lang="en-US" sz="900" b="1" kern="0" spc="400" dirty="0">
+                <a:solidFill>
+                  <a:srgbClr val="E67E22"/>
+                </a:solidFill>
+                <a:latin typeface="Arial" pitchFamily="34" charset="0"/>
+                <a:ea typeface="Arial" pitchFamily="34" charset="-122"/>
+                <a:cs typeface="Arial" pitchFamily="34" charset="-120"/>
+              </a:rPr>
+              <a:t>DISTRIBUCIÓN DE duracion_minutos</a:t>
+            </a:r>
+            <a:endParaRPr lang="en-US" sz="900" dirty="0"/>
+          </a:p>
+        </p:txBody>
+      </p:sp>
+      <p:sp>
+        <p:nvSpPr>
+          <p:cNvPr id="13" name="Text 9"/>
+          <p:cNvSpPr/>
+          <p:nvPr/>
+        </p:nvSpPr>
+        <p:spPr>
+          <a:xfrm>
+            <a:off x="320040" y="3127248"/>
+            <a:ext cx="4114800" cy="274320"/>
+          </a:xfrm>
+          <a:prstGeom prst="rect">
+            <a:avLst/>
+          </a:prstGeom>
+          <a:noFill/>
+          <a:ln/>
+        </p:spPr>
+        <p:txBody>
+          <a:bodyPr wrap="square" lIns="0" tIns="0" rIns="0" bIns="0" rtlCol="0" anchor="ctr"/>
+          <a:lstStyle/>
+          <a:p>
+            <a:pPr marL="0" indent="0">
+              <a:buNone/>
+            </a:pPr>
+            <a:r>
+              <a:rPr lang="en-US" sz="1000" i="1" dirty="0">
+                <a:solidFill>
+                  <a:srgbClr val="2C3E50"/>
+                </a:solidFill>
+                <a:latin typeface="Calibri" pitchFamily="34" charset="0"/>
+                <a:ea typeface="Calibri" pitchFamily="34" charset="-122"/>
+                <a:cs typeface="Calibri" pitchFamily="34" charset="-120"/>
+              </a:rPr>
+              <a:t>Asimetría positiva · mediana ≈ 16 min · justifica discretización en 3 clases</a:t>
+            </a:r>
+            <a:endParaRPr lang="en-US" sz="1000" dirty="0"/>
+          </a:p>
+        </p:txBody>
+      </p:sp>
+      <p:pic>
+        <p:nvPicPr>
+          <p:cNvPr id="14" name="Image 2" descr="/sessions/sharp-quirky-brown/mnt/TP Final AdD 2026/TP Final AdD/images_tutorial/fig_histograma_duracion_minutos_dark.png"/>
+          <p:cNvPicPr>
+            <a:picLocks noChangeAspect="1"/>
+          </p:cNvPicPr>
+          <p:nvPr/>
+        </p:nvPicPr>
+        <p:blipFill>
+          <a:blip r:embed="rId5"/>
+          <a:stretch>
+            <a:fillRect/>
+          </a:stretch>
+        </p:blipFill>
+        <p:spPr>
+          <a:xfrm>
+            <a:off x="320040" y="3456432"/>
+            <a:ext cx="4114800" cy="1371600"/>
+          </a:xfrm>
+          <a:prstGeom prst="rect">
+            <a:avLst/>
+          </a:prstGeom>
+        </p:spPr>
+      </p:pic>
+      <p:sp>
+        <p:nvSpPr>
+          <p:cNvPr id="15" name="Text 10"/>
+          <p:cNvSpPr/>
+          <p:nvPr/>
+        </p:nvSpPr>
+        <p:spPr>
+          <a:xfrm>
+            <a:off x="4709160" y="2926080"/>
+            <a:ext cx="4114800" cy="228600"/>
+          </a:xfrm>
+          <a:prstGeom prst="rect">
+            <a:avLst/>
+          </a:prstGeom>
+          <a:noFill/>
+          <a:ln/>
+        </p:spPr>
+        <p:txBody>
+          <a:bodyPr wrap="square" lIns="0" tIns="0" rIns="0" bIns="0" rtlCol="0" anchor="ctr"/>
+          <a:lstStyle/>
+          <a:p>
+            <a:pPr marL="0" indent="0">
+              <a:buNone/>
+            </a:pPr>
+            <a:r>
+              <a:rPr lang="en-US" sz="900" b="1" kern="0" spc="400" dirty="0">
+                <a:solidFill>
+                  <a:srgbClr val="E67E22"/>
+                </a:solidFill>
+                <a:latin typeface="Arial" pitchFamily="34" charset="0"/>
+                <a:ea typeface="Arial" pitchFamily="34" charset="-122"/>
+                <a:cs typeface="Arial" pitchFamily="34" charset="-120"/>
+              </a:rPr>
+              <a:t>FALTANTES · MCAR / MAR / MNAR</a:t>
+            </a:r>
+            <a:endParaRPr lang="en-US" sz="900" dirty="0"/>
+          </a:p>
+        </p:txBody>
+      </p:sp>
+      <p:sp>
+        <p:nvSpPr>
+          <p:cNvPr id="16" name="Text 11"/>
+          <p:cNvSpPr/>
+          <p:nvPr/>
+        </p:nvSpPr>
+        <p:spPr>
+          <a:xfrm>
+            <a:off x="4709160" y="3127248"/>
+            <a:ext cx="4114800" cy="274320"/>
+          </a:xfrm>
+          <a:prstGeom prst="rect">
+            <a:avLst/>
+          </a:prstGeom>
+          <a:noFill/>
+          <a:ln/>
+        </p:spPr>
+        <p:txBody>
+          <a:bodyPr wrap="square" lIns="0" tIns="0" rIns="0" bIns="0" rtlCol="0" anchor="ctr"/>
+          <a:lstStyle/>
+          <a:p>
+            <a:pPr marL="0" indent="0">
+              <a:buNone/>
+            </a:pPr>
+            <a:r>
+              <a:rPr lang="en-US" sz="1000" i="1" dirty="0">
+                <a:solidFill>
+                  <a:srgbClr val="2C3E50"/>
+                </a:solidFill>
+                <a:latin typeface="Calibri" pitchFamily="34" charset="0"/>
+                <a:ea typeface="Calibri" pitchFamily="34" charset="-122"/>
+                <a:cs typeface="Calibri" pitchFamily="34" charset="-120"/>
+              </a:rPr>
+              <a:t>Tipificación por variable · género (MNAR) · fecha_destino (MAR)</a:t>
+            </a:r>
+            <a:endParaRPr lang="en-US" sz="1000" dirty="0"/>
+          </a:p>
+        </p:txBody>
+      </p:sp>
+      <p:pic>
+        <p:nvPicPr>
+          <p:cNvPr id="17" name="Image 3" descr="/sessions/sharp-quirky-brown/mnt/TP Final AdD 2026/TP Final AdD/images_tutorial/fig_faltantes_MCAR_MAR_MNAR_composite.png"/>
+          <p:cNvPicPr>
+            <a:picLocks noChangeAspect="1"/>
+          </p:cNvPicPr>
+          <p:nvPr/>
+        </p:nvPicPr>
+        <p:blipFill>
+          <a:blip r:embed="rId6"/>
+          <a:stretch>
+            <a:fillRect/>
+          </a:stretch>
+        </p:blipFill>
+        <p:spPr>
+          <a:xfrm>
             <a:off x="4709160" y="3456432"/>
             <a:ext cx="4114800" cy="1371600"/>
           </a:xfrm>
@@ -2730,6 +2719,13 @@
             <a:prstDash val="solid"/>
           </a:ln>
         </p:spPr>
+        <p:txBody>
+          <a:bodyPr/>
+          <a:lstStyle/>
+          <a:p>
+            <a:endParaRPr lang="en-US"/>
+          </a:p>
+        </p:txBody>
       </p:sp>
       <p:sp>
         <p:nvSpPr>
@@ -2752,7 +2748,7 @@
           <a:bodyPr wrap="square" lIns="0" tIns="0" rIns="0" bIns="0" rtlCol="0" anchor="ctr"/>
           <a:lstStyle/>
           <a:p>
-            <a:pPr indent="0" marL="0">
+            <a:pPr marL="0" indent="0">
               <a:buNone/>
             </a:pPr>
             <a:r>
@@ -2780,12 +2776,1241 @@
 
 <file path=ppt/slides/slide3.xml><?xml version="1.0" encoding="utf-8"?>
 <p:sld xmlns:a="http://schemas.openxmlformats.org/drawingml/2006/main" xmlns:r="http://schemas.openxmlformats.org/officeDocument/2006/relationships" xmlns:p="http://schemas.openxmlformats.org/presentationml/2006/main">
+  <p:cSld>
+    <p:bg>
+      <p:bgPr>
+        <a:solidFill>
+          <a:srgbClr val="FAF5EC"/>
+        </a:solidFill>
+        <a:effectLst/>
+      </p:bgPr>
+    </p:bg>
+    <p:spTree>
+      <p:nvGrpSpPr>
+        <p:cNvPr id="1" name="">
+          <a:extLst>
+            <a:ext uri="{FF2B5EF4-FFF2-40B4-BE49-F238E27FC236}">
+              <a16:creationId xmlns:a16="http://schemas.microsoft.com/office/drawing/2014/main" id="{D9DE52D4-D972-7712-52D2-F09F714B11DE}"/>
+            </a:ext>
+          </a:extLst>
+        </p:cNvPr>
+        <p:cNvGrpSpPr/>
+        <p:nvPr/>
+      </p:nvGrpSpPr>
+      <p:grpSpPr>
+        <a:xfrm>
+          <a:off x="0" y="0"/>
+          <a:ext cx="0" cy="0"/>
+          <a:chOff x="0" y="0"/>
+          <a:chExt cx="0" cy="0"/>
+        </a:xfrm>
+      </p:grpSpPr>
+      <p:sp>
+        <p:nvSpPr>
+          <p:cNvPr id="2" name="Shape 0">
+            <a:extLst>
+              <a:ext uri="{FF2B5EF4-FFF2-40B4-BE49-F238E27FC236}">
+                <a16:creationId xmlns:a16="http://schemas.microsoft.com/office/drawing/2014/main" id="{08FE15FC-AE71-9AA0-B554-984CA3477425}"/>
+              </a:ext>
+            </a:extLst>
+          </p:cNvPr>
+          <p:cNvSpPr/>
+          <p:nvPr/>
+        </p:nvSpPr>
+        <p:spPr>
+          <a:xfrm>
+            <a:off x="0" y="0"/>
+            <a:ext cx="9144000" cy="777240"/>
+          </a:xfrm>
+          <a:prstGeom prst="rect">
+            <a:avLst/>
+          </a:prstGeom>
+          <a:solidFill>
+            <a:srgbClr val="1A2332"/>
+          </a:solidFill>
+          <a:ln/>
+        </p:spPr>
+        <p:txBody>
+          <a:bodyPr/>
+          <a:lstStyle/>
+          <a:p>
+            <a:pPr marL="0" marR="0" lvl="0" indent="0" algn="l" defTabSz="914400" rtl="0" eaLnBrk="1" fontAlgn="auto" latinLnBrk="0" hangingPunct="1">
+              <a:lnSpc>
+                <a:spcPct val="100000"/>
+              </a:lnSpc>
+              <a:spcBef>
+                <a:spcPts val="0"/>
+              </a:spcBef>
+              <a:spcAft>
+                <a:spcPts val="0"/>
+              </a:spcAft>
+              <a:buClrTx/>
+              <a:buSzTx/>
+              <a:buFontTx/>
+              <a:buNone/>
+              <a:tabLst/>
+              <a:defRPr/>
+            </a:pPr>
+            <a:endParaRPr kumimoji="0" lang="en-US" sz="1800" b="0" i="0" u="none" strike="noStrike" kern="1200" cap="none" spc="0" normalizeH="0" baseline="0" noProof="0">
+              <a:ln>
+                <a:noFill/>
+              </a:ln>
+              <a:solidFill>
+                <a:prstClr val="black"/>
+              </a:solidFill>
+              <a:effectLst/>
+              <a:uLnTx/>
+              <a:uFillTx/>
+              <a:latin typeface="Calibri" panose="020F0502020204030204"/>
+              <a:ea typeface="+mn-ea"/>
+              <a:cs typeface="+mn-cs"/>
+            </a:endParaRPr>
+          </a:p>
+        </p:txBody>
+      </p:sp>
+      <p:sp>
+        <p:nvSpPr>
+          <p:cNvPr id="3" name="Shape 1">
+            <a:extLst>
+              <a:ext uri="{FF2B5EF4-FFF2-40B4-BE49-F238E27FC236}">
+                <a16:creationId xmlns:a16="http://schemas.microsoft.com/office/drawing/2014/main" id="{305B7000-ABD4-952F-D408-405AE20049E5}"/>
+              </a:ext>
+            </a:extLst>
+          </p:cNvPr>
+          <p:cNvSpPr/>
+          <p:nvPr/>
+        </p:nvSpPr>
+        <p:spPr>
+          <a:xfrm>
+            <a:off x="0" y="0"/>
+            <a:ext cx="73152" cy="5143500"/>
+          </a:xfrm>
+          <a:prstGeom prst="rect">
+            <a:avLst/>
+          </a:prstGeom>
+          <a:solidFill>
+            <a:srgbClr val="E67E22"/>
+          </a:solidFill>
+          <a:ln/>
+        </p:spPr>
+        <p:txBody>
+          <a:bodyPr/>
+          <a:lstStyle/>
+          <a:p>
+            <a:pPr marL="0" marR="0" lvl="0" indent="0" algn="l" defTabSz="914400" rtl="0" eaLnBrk="1" fontAlgn="auto" latinLnBrk="0" hangingPunct="1">
+              <a:lnSpc>
+                <a:spcPct val="100000"/>
+              </a:lnSpc>
+              <a:spcBef>
+                <a:spcPts val="0"/>
+              </a:spcBef>
+              <a:spcAft>
+                <a:spcPts val="0"/>
+              </a:spcAft>
+              <a:buClrTx/>
+              <a:buSzTx/>
+              <a:buFontTx/>
+              <a:buNone/>
+              <a:tabLst/>
+              <a:defRPr/>
+            </a:pPr>
+            <a:endParaRPr kumimoji="0" lang="en-US" sz="1800" b="0" i="0" u="none" strike="noStrike" kern="1200" cap="none" spc="0" normalizeH="0" baseline="0" noProof="0">
+              <a:ln>
+                <a:noFill/>
+              </a:ln>
+              <a:solidFill>
+                <a:prstClr val="black"/>
+              </a:solidFill>
+              <a:effectLst/>
+              <a:uLnTx/>
+              <a:uFillTx/>
+              <a:latin typeface="Calibri" panose="020F0502020204030204"/>
+              <a:ea typeface="+mn-ea"/>
+              <a:cs typeface="+mn-cs"/>
+            </a:endParaRPr>
+          </a:p>
+        </p:txBody>
+      </p:sp>
+      <p:sp>
+        <p:nvSpPr>
+          <p:cNvPr id="4" name="Text 2">
+            <a:extLst>
+              <a:ext uri="{FF2B5EF4-FFF2-40B4-BE49-F238E27FC236}">
+                <a16:creationId xmlns:a16="http://schemas.microsoft.com/office/drawing/2014/main" id="{7258740D-41B1-3F45-8AC1-AD03ED4C575A}"/>
+              </a:ext>
+            </a:extLst>
+          </p:cNvPr>
+          <p:cNvSpPr/>
+          <p:nvPr/>
+        </p:nvSpPr>
+        <p:spPr>
+          <a:xfrm>
+            <a:off x="365760" y="109728"/>
+            <a:ext cx="8412480" cy="228600"/>
+          </a:xfrm>
+          <a:prstGeom prst="rect">
+            <a:avLst/>
+          </a:prstGeom>
+          <a:noFill/>
+          <a:ln/>
+        </p:spPr>
+        <p:txBody>
+          <a:bodyPr wrap="square" lIns="0" tIns="0" rIns="0" bIns="0" rtlCol="0" anchor="ctr"/>
+          <a:lstStyle/>
+          <a:p>
+            <a:pPr marL="0" marR="0" lvl="0" indent="0" algn="l" defTabSz="914400" rtl="0" eaLnBrk="1" fontAlgn="auto" latinLnBrk="0" hangingPunct="1">
+              <a:lnSpc>
+                <a:spcPct val="100000"/>
+              </a:lnSpc>
+              <a:spcBef>
+                <a:spcPts val="0"/>
+              </a:spcBef>
+              <a:spcAft>
+                <a:spcPts val="0"/>
+              </a:spcAft>
+              <a:buClrTx/>
+              <a:buSzTx/>
+              <a:buFontTx/>
+              <a:buNone/>
+              <a:tabLst/>
+              <a:defRPr/>
+            </a:pPr>
+            <a:r>
+              <a:rPr kumimoji="0" lang="en-US" sz="1000" b="1" i="0" u="none" strike="noStrike" kern="0" cap="none" spc="600" normalizeH="0" baseline="0" noProof="0" dirty="0">
+                <a:ln>
+                  <a:noFill/>
+                </a:ln>
+                <a:solidFill>
+                  <a:srgbClr val="E67E22"/>
+                </a:solidFill>
+                <a:effectLst/>
+                <a:uLnTx/>
+                <a:uFillTx/>
+                <a:latin typeface="Arial" pitchFamily="34" charset="0"/>
+                <a:ea typeface="Arial" pitchFamily="34" charset="-122"/>
+                <a:cs typeface="Arial" pitchFamily="34" charset="-120"/>
+              </a:rPr>
+              <a:t>ANÁLISIS EXPLORATORIO DE DATOS</a:t>
+            </a:r>
+            <a:endParaRPr kumimoji="0" lang="en-US" sz="1000" b="0" i="0" u="none" strike="noStrike" kern="1200" cap="none" spc="0" normalizeH="0" baseline="0" noProof="0" dirty="0">
+              <a:ln>
+                <a:noFill/>
+              </a:ln>
+              <a:solidFill>
+                <a:prstClr val="black"/>
+              </a:solidFill>
+              <a:effectLst/>
+              <a:uLnTx/>
+              <a:uFillTx/>
+              <a:latin typeface="Calibri" panose="020F0502020204030204"/>
+              <a:ea typeface="+mn-ea"/>
+              <a:cs typeface="+mn-cs"/>
+            </a:endParaRPr>
+          </a:p>
+        </p:txBody>
+      </p:sp>
+      <p:sp>
+        <p:nvSpPr>
+          <p:cNvPr id="5" name="Text 3">
+            <a:extLst>
+              <a:ext uri="{FF2B5EF4-FFF2-40B4-BE49-F238E27FC236}">
+                <a16:creationId xmlns:a16="http://schemas.microsoft.com/office/drawing/2014/main" id="{8AD67705-5BA6-184C-843E-C703A58C415B}"/>
+              </a:ext>
+            </a:extLst>
+          </p:cNvPr>
+          <p:cNvSpPr/>
+          <p:nvPr/>
+        </p:nvSpPr>
+        <p:spPr>
+          <a:xfrm>
+            <a:off x="365760" y="310896"/>
+            <a:ext cx="8412480" cy="411480"/>
+          </a:xfrm>
+          <a:prstGeom prst="rect">
+            <a:avLst/>
+          </a:prstGeom>
+          <a:noFill/>
+          <a:ln/>
+        </p:spPr>
+        <p:txBody>
+          <a:bodyPr wrap="square" lIns="0" tIns="0" rIns="0" bIns="0" rtlCol="0" anchor="ctr"/>
+          <a:lstStyle/>
+          <a:p>
+            <a:pPr marL="0" marR="0" lvl="0" indent="0" algn="l" defTabSz="914400" rtl="0" eaLnBrk="1" fontAlgn="auto" latinLnBrk="0" hangingPunct="1">
+              <a:lnSpc>
+                <a:spcPct val="100000"/>
+              </a:lnSpc>
+              <a:spcBef>
+                <a:spcPts val="0"/>
+              </a:spcBef>
+              <a:spcAft>
+                <a:spcPts val="0"/>
+              </a:spcAft>
+              <a:buClrTx/>
+              <a:buSzTx/>
+              <a:buFontTx/>
+              <a:buNone/>
+              <a:tabLst/>
+              <a:defRPr/>
+            </a:pPr>
+            <a:r>
+              <a:rPr kumimoji="0" lang="en-US" sz="2200" b="1" i="0" u="none" strike="noStrike" kern="1200" cap="none" spc="0" normalizeH="0" baseline="0" noProof="0" dirty="0" err="1">
+                <a:ln>
+                  <a:noFill/>
+                </a:ln>
+                <a:solidFill>
+                  <a:srgbClr val="FFFFFF"/>
+                </a:solidFill>
+                <a:effectLst/>
+                <a:uLnTx/>
+                <a:uFillTx/>
+                <a:latin typeface="Georgia" pitchFamily="34" charset="0"/>
+                <a:ea typeface="Georgia" pitchFamily="34" charset="-122"/>
+                <a:cs typeface="Georgia" pitchFamily="34" charset="-120"/>
+              </a:rPr>
+              <a:t>Principales</a:t>
+            </a:r>
+            <a:r>
+              <a:rPr kumimoji="0" lang="en-US" sz="2200" b="1" i="0" u="none" strike="noStrike" kern="1200" cap="none" spc="0" normalizeH="0" baseline="0" noProof="0" dirty="0">
+                <a:ln>
+                  <a:noFill/>
+                </a:ln>
+                <a:solidFill>
+                  <a:srgbClr val="FFFFFF"/>
+                </a:solidFill>
+                <a:effectLst/>
+                <a:uLnTx/>
+                <a:uFillTx/>
+                <a:latin typeface="Georgia" pitchFamily="34" charset="0"/>
+                <a:ea typeface="Georgia" pitchFamily="34" charset="-122"/>
+                <a:cs typeface="Georgia" pitchFamily="34" charset="-120"/>
+              </a:rPr>
+              <a:t> </a:t>
+            </a:r>
+            <a:r>
+              <a:rPr lang="en-US" sz="2200" b="1" dirty="0">
+                <a:solidFill>
+                  <a:srgbClr val="FFFFFF"/>
+                </a:solidFill>
+                <a:latin typeface="Georgia" pitchFamily="34" charset="0"/>
+                <a:ea typeface="Georgia" pitchFamily="34" charset="-122"/>
+                <a:cs typeface="Georgia" pitchFamily="34" charset="-120"/>
+              </a:rPr>
+              <a:t>C</a:t>
+            </a:r>
+            <a:r>
+              <a:rPr kumimoji="0" lang="en-US" sz="2200" b="1" i="0" u="none" strike="noStrike" kern="1200" cap="none" spc="0" normalizeH="0" baseline="0" noProof="0" dirty="0" err="1">
+                <a:ln>
+                  <a:noFill/>
+                </a:ln>
+                <a:solidFill>
+                  <a:srgbClr val="FFFFFF"/>
+                </a:solidFill>
+                <a:effectLst/>
+                <a:uLnTx/>
+                <a:uFillTx/>
+                <a:latin typeface="Georgia" pitchFamily="34" charset="0"/>
+                <a:ea typeface="Georgia" pitchFamily="34" charset="-122"/>
+                <a:cs typeface="Georgia" pitchFamily="34" charset="-120"/>
+              </a:rPr>
+              <a:t>aracterística</a:t>
+            </a:r>
+            <a:r>
+              <a:rPr lang="en-US" sz="2200" b="1" dirty="0">
+                <a:solidFill>
+                  <a:srgbClr val="FFFFFF"/>
+                </a:solidFill>
+                <a:latin typeface="Georgia" pitchFamily="34" charset="0"/>
+                <a:ea typeface="Georgia" pitchFamily="34" charset="-122"/>
+                <a:cs typeface="Georgia" pitchFamily="34" charset="-120"/>
+              </a:rPr>
+              <a:t>s de Dataset</a:t>
+            </a:r>
+            <a:endParaRPr kumimoji="0" lang="en-US" sz="2200" b="0" i="0" u="none" strike="noStrike" kern="1200" cap="none" spc="0" normalizeH="0" baseline="0" noProof="0" dirty="0">
+              <a:ln>
+                <a:noFill/>
+              </a:ln>
+              <a:solidFill>
+                <a:prstClr val="black"/>
+              </a:solidFill>
+              <a:effectLst/>
+              <a:uLnTx/>
+              <a:uFillTx/>
+              <a:latin typeface="Calibri" panose="020F0502020204030204"/>
+              <a:ea typeface="+mn-ea"/>
+              <a:cs typeface="+mn-cs"/>
+            </a:endParaRPr>
+          </a:p>
+        </p:txBody>
+      </p:sp>
+      <p:sp>
+        <p:nvSpPr>
+          <p:cNvPr id="10" name="Text 7">
+            <a:extLst>
+              <a:ext uri="{FF2B5EF4-FFF2-40B4-BE49-F238E27FC236}">
+                <a16:creationId xmlns:a16="http://schemas.microsoft.com/office/drawing/2014/main" id="{9161C479-5E49-47CB-7F3A-ECF1D3DDF211}"/>
+              </a:ext>
+            </a:extLst>
+          </p:cNvPr>
+          <p:cNvSpPr/>
+          <p:nvPr/>
+        </p:nvSpPr>
+        <p:spPr>
+          <a:xfrm>
+            <a:off x="243838" y="1001097"/>
+            <a:ext cx="2948432" cy="1187470"/>
+          </a:xfrm>
+          <a:prstGeom prst="rect">
+            <a:avLst/>
+          </a:prstGeom>
+          <a:noFill/>
+          <a:ln/>
+        </p:spPr>
+        <p:txBody>
+          <a:bodyPr wrap="square" lIns="0" tIns="0" rIns="0" bIns="0" rtlCol="0" anchor="t"/>
+          <a:lstStyle/>
+          <a:p>
+            <a:pPr marL="171450" lvl="0" indent="-171450">
+              <a:buFont typeface="Wingdings" panose="05000000000000000000" pitchFamily="2" charset="2"/>
+              <a:buChar char="§"/>
+            </a:pPr>
+            <a:r>
+              <a:rPr lang="es-ES" sz="1000" i="1" dirty="0">
+                <a:solidFill>
+                  <a:srgbClr val="2C3E50"/>
+                </a:solidFill>
+                <a:latin typeface="Calibri" pitchFamily="34" charset="0"/>
+                <a:ea typeface="Calibri" pitchFamily="34" charset="-122"/>
+                <a:cs typeface="Calibri" pitchFamily="34" charset="-120"/>
+              </a:rPr>
+              <a:t>La red cubre principalmente el corredor céntrico y los barrios de mayor densidad (Palermo, Recoleta, Etc.). La cobertura disminuye hacia los límites de la ciudad.</a:t>
+            </a:r>
+          </a:p>
+          <a:p>
+            <a:pPr marL="171450" indent="-171450">
+              <a:buFont typeface="Wingdings" panose="05000000000000000000" pitchFamily="2" charset="2"/>
+              <a:buChar char="§"/>
+            </a:pPr>
+            <a:r>
+              <a:rPr lang="en-US" sz="1000" i="1" dirty="0">
+                <a:solidFill>
+                  <a:srgbClr val="2C3E50"/>
+                </a:solidFill>
+                <a:latin typeface="Calibri" pitchFamily="34" charset="0"/>
+                <a:ea typeface="Calibri" pitchFamily="34" charset="-122"/>
+                <a:cs typeface="Calibri" pitchFamily="34" charset="-120"/>
+              </a:rPr>
+              <a:t>La </a:t>
+            </a:r>
+            <a:r>
+              <a:rPr lang="en-US" sz="1000" i="1" dirty="0" err="1">
+                <a:solidFill>
+                  <a:srgbClr val="2C3E50"/>
+                </a:solidFill>
+                <a:latin typeface="Calibri" pitchFamily="34" charset="0"/>
+                <a:ea typeface="Calibri" pitchFamily="34" charset="-122"/>
+                <a:cs typeface="Calibri" pitchFamily="34" charset="-120"/>
+              </a:rPr>
+              <a:t>mediana</a:t>
+            </a:r>
+            <a:r>
+              <a:rPr lang="en-US" sz="1000" i="1" dirty="0">
+                <a:solidFill>
+                  <a:srgbClr val="2C3E50"/>
+                </a:solidFill>
+                <a:latin typeface="Calibri" pitchFamily="34" charset="0"/>
+                <a:ea typeface="Calibri" pitchFamily="34" charset="-122"/>
+                <a:cs typeface="Calibri" pitchFamily="34" charset="-120"/>
+              </a:rPr>
+              <a:t> de las </a:t>
+            </a:r>
+            <a:r>
+              <a:rPr lang="en-US" sz="1000" i="1" dirty="0" err="1">
+                <a:solidFill>
+                  <a:srgbClr val="2C3E50"/>
+                </a:solidFill>
+                <a:latin typeface="Calibri" pitchFamily="34" charset="0"/>
+                <a:ea typeface="Calibri" pitchFamily="34" charset="-122"/>
+                <a:cs typeface="Calibri" pitchFamily="34" charset="-120"/>
+              </a:rPr>
+              <a:t>distancias</a:t>
+            </a:r>
+            <a:r>
+              <a:rPr lang="en-US" sz="1000" i="1" dirty="0">
+                <a:solidFill>
+                  <a:srgbClr val="2C3E50"/>
+                </a:solidFill>
+                <a:latin typeface="Calibri" pitchFamily="34" charset="0"/>
+                <a:ea typeface="Calibri" pitchFamily="34" charset="-122"/>
+                <a:cs typeface="Calibri" pitchFamily="34" charset="-120"/>
+              </a:rPr>
+              <a:t> </a:t>
+            </a:r>
+            <a:r>
+              <a:rPr lang="en-US" sz="1000" i="1" dirty="0" err="1">
+                <a:solidFill>
+                  <a:srgbClr val="2C3E50"/>
+                </a:solidFill>
+                <a:latin typeface="Calibri" pitchFamily="34" charset="0"/>
+                <a:ea typeface="Calibri" pitchFamily="34" charset="-122"/>
+                <a:cs typeface="Calibri" pitchFamily="34" charset="-120"/>
+              </a:rPr>
+              <a:t>recorridas</a:t>
+            </a:r>
+            <a:r>
+              <a:rPr lang="en-US" sz="1000" i="1" dirty="0">
+                <a:solidFill>
+                  <a:srgbClr val="2C3E50"/>
+                </a:solidFill>
+                <a:latin typeface="Calibri" pitchFamily="34" charset="0"/>
+                <a:ea typeface="Calibri" pitchFamily="34" charset="-122"/>
+                <a:cs typeface="Calibri" pitchFamily="34" charset="-120"/>
+              </a:rPr>
+              <a:t> es </a:t>
+            </a:r>
+            <a:r>
+              <a:rPr lang="en-US" sz="1000" i="1" dirty="0" err="1">
+                <a:solidFill>
+                  <a:srgbClr val="2C3E50"/>
+                </a:solidFill>
+                <a:latin typeface="Calibri" pitchFamily="34" charset="0"/>
+                <a:ea typeface="Calibri" pitchFamily="34" charset="-122"/>
+                <a:cs typeface="Calibri" pitchFamily="34" charset="-120"/>
+              </a:rPr>
+              <a:t>menor</a:t>
+            </a:r>
+            <a:r>
+              <a:rPr lang="en-US" sz="1000" i="1" dirty="0">
+                <a:solidFill>
+                  <a:srgbClr val="2C3E50"/>
+                </a:solidFill>
+                <a:latin typeface="Calibri" pitchFamily="34" charset="0"/>
+                <a:ea typeface="Calibri" pitchFamily="34" charset="-122"/>
+                <a:cs typeface="Calibri" pitchFamily="34" charset="-120"/>
+              </a:rPr>
+              <a:t> a 2km (</a:t>
+            </a:r>
+            <a:r>
+              <a:rPr lang="en-US" sz="1000" i="1" dirty="0" err="1">
+                <a:solidFill>
+                  <a:srgbClr val="2C3E50"/>
+                </a:solidFill>
+                <a:latin typeface="Calibri" pitchFamily="34" charset="0"/>
+                <a:ea typeface="Calibri" pitchFamily="34" charset="-122"/>
+                <a:cs typeface="Calibri" pitchFamily="34" charset="-120"/>
+              </a:rPr>
+              <a:t>acorde</a:t>
+            </a:r>
+            <a:r>
+              <a:rPr lang="en-US" sz="1000" i="1" dirty="0">
+                <a:solidFill>
+                  <a:srgbClr val="2C3E50"/>
+                </a:solidFill>
+                <a:latin typeface="Calibri" pitchFamily="34" charset="0"/>
+                <a:ea typeface="Calibri" pitchFamily="34" charset="-122"/>
+                <a:cs typeface="Calibri" pitchFamily="34" charset="-120"/>
+              </a:rPr>
+              <a:t> a </a:t>
+            </a:r>
+            <a:r>
+              <a:rPr lang="en-US" sz="1000" i="1" dirty="0" err="1">
+                <a:solidFill>
+                  <a:srgbClr val="2C3E50"/>
+                </a:solidFill>
+                <a:latin typeface="Calibri" pitchFamily="34" charset="0"/>
+                <a:ea typeface="Calibri" pitchFamily="34" charset="-122"/>
+                <a:cs typeface="Calibri" pitchFamily="34" charset="-120"/>
+              </a:rPr>
+              <a:t>recorridos</a:t>
+            </a:r>
+            <a:r>
+              <a:rPr lang="en-US" sz="1000" i="1" dirty="0">
+                <a:solidFill>
+                  <a:srgbClr val="2C3E50"/>
+                </a:solidFill>
+                <a:latin typeface="Calibri" pitchFamily="34" charset="0"/>
+                <a:ea typeface="Calibri" pitchFamily="34" charset="-122"/>
+                <a:cs typeface="Calibri" pitchFamily="34" charset="-120"/>
+              </a:rPr>
+              <a:t> </a:t>
+            </a:r>
+            <a:r>
+              <a:rPr lang="en-US" sz="1000" i="1" dirty="0" err="1">
+                <a:solidFill>
+                  <a:srgbClr val="2C3E50"/>
+                </a:solidFill>
+                <a:latin typeface="Calibri" pitchFamily="34" charset="0"/>
+                <a:ea typeface="Calibri" pitchFamily="34" charset="-122"/>
+                <a:cs typeface="Calibri" pitchFamily="34" charset="-120"/>
+              </a:rPr>
+              <a:t>urbanos</a:t>
+            </a:r>
+            <a:r>
+              <a:rPr lang="en-US" sz="1000" i="1" dirty="0">
+                <a:solidFill>
+                  <a:srgbClr val="2C3E50"/>
+                </a:solidFill>
+                <a:latin typeface="Calibri" pitchFamily="34" charset="0"/>
+                <a:ea typeface="Calibri" pitchFamily="34" charset="-122"/>
+                <a:cs typeface="Calibri" pitchFamily="34" charset="-120"/>
+              </a:rPr>
+              <a:t>)</a:t>
+            </a:r>
+          </a:p>
+          <a:p>
+            <a:pPr marL="171450" lvl="0" indent="-171450">
+              <a:buFont typeface="Wingdings" panose="05000000000000000000" pitchFamily="2" charset="2"/>
+              <a:buChar char="§"/>
+            </a:pPr>
+            <a:r>
+              <a:rPr lang="en-US" sz="1000" i="1" dirty="0" err="1">
+                <a:solidFill>
+                  <a:srgbClr val="2C3E50"/>
+                </a:solidFill>
+                <a:latin typeface="Calibri" pitchFamily="34" charset="0"/>
+                <a:ea typeface="Calibri" pitchFamily="34" charset="-122"/>
+                <a:cs typeface="Calibri" pitchFamily="34" charset="-120"/>
+              </a:rPr>
+              <a:t>Descentralizacion</a:t>
+            </a:r>
+            <a:r>
+              <a:rPr lang="en-US" sz="1000" i="1" dirty="0">
+                <a:solidFill>
+                  <a:srgbClr val="2C3E50"/>
+                </a:solidFill>
+                <a:latin typeface="Calibri" pitchFamily="34" charset="0"/>
+                <a:ea typeface="Calibri" pitchFamily="34" charset="-122"/>
+                <a:cs typeface="Calibri" pitchFamily="34" charset="-120"/>
+              </a:rPr>
+              <a:t> de </a:t>
+            </a:r>
+            <a:r>
+              <a:rPr lang="en-US" sz="1000" i="1" dirty="0" err="1">
+                <a:solidFill>
+                  <a:srgbClr val="2C3E50"/>
+                </a:solidFill>
+                <a:latin typeface="Calibri" pitchFamily="34" charset="0"/>
+                <a:ea typeface="Calibri" pitchFamily="34" charset="-122"/>
+                <a:cs typeface="Calibri" pitchFamily="34" charset="-120"/>
+              </a:rPr>
+              <a:t>recorridos</a:t>
+            </a:r>
+            <a:r>
+              <a:rPr lang="en-US" sz="1000" i="1" dirty="0">
+                <a:solidFill>
+                  <a:srgbClr val="2C3E50"/>
+                </a:solidFill>
+                <a:latin typeface="Calibri" pitchFamily="34" charset="0"/>
+                <a:ea typeface="Calibri" pitchFamily="34" charset="-122"/>
+                <a:cs typeface="Calibri" pitchFamily="34" charset="-120"/>
+              </a:rPr>
+              <a:t>: </a:t>
+            </a:r>
+            <a:r>
+              <a:rPr lang="es-ES" sz="1000" i="1" dirty="0">
+                <a:solidFill>
+                  <a:srgbClr val="2C3E50"/>
+                </a:solidFill>
+                <a:latin typeface="Calibri" pitchFamily="34" charset="0"/>
+                <a:ea typeface="Calibri" pitchFamily="34" charset="-122"/>
+                <a:cs typeface="Calibri" pitchFamily="34" charset="-120"/>
+              </a:rPr>
+              <a:t>La matriz del Top 10 captura el 1.86% de la demanda total del sistema.</a:t>
+            </a:r>
+          </a:p>
+        </p:txBody>
+      </p:sp>
+      <p:sp>
+        <p:nvSpPr>
+          <p:cNvPr id="12" name="Text 8">
+            <a:extLst>
+              <a:ext uri="{FF2B5EF4-FFF2-40B4-BE49-F238E27FC236}">
+                <a16:creationId xmlns:a16="http://schemas.microsoft.com/office/drawing/2014/main" id="{D5D82CCC-95CC-D901-5F4C-BBEB03FC6136}"/>
+              </a:ext>
+            </a:extLst>
+          </p:cNvPr>
+          <p:cNvSpPr/>
+          <p:nvPr/>
+        </p:nvSpPr>
+        <p:spPr>
+          <a:xfrm>
+            <a:off x="243838" y="809244"/>
+            <a:ext cx="6111241" cy="228600"/>
+          </a:xfrm>
+          <a:prstGeom prst="rect">
+            <a:avLst/>
+          </a:prstGeom>
+          <a:noFill/>
+          <a:ln/>
+        </p:spPr>
+        <p:txBody>
+          <a:bodyPr wrap="square" lIns="0" tIns="0" rIns="0" bIns="0" rtlCol="0" anchor="ctr"/>
+          <a:lstStyle/>
+          <a:p>
+            <a:pPr marL="0" marR="0" lvl="0" indent="0" algn="l" defTabSz="914400" eaLnBrk="1" fontAlgn="auto" latinLnBrk="0" hangingPunct="1">
+              <a:lnSpc>
+                <a:spcPct val="100000"/>
+              </a:lnSpc>
+              <a:spcBef>
+                <a:spcPts val="0"/>
+              </a:spcBef>
+              <a:spcAft>
+                <a:spcPts val="0"/>
+              </a:spcAft>
+              <a:buClrTx/>
+              <a:buSzTx/>
+              <a:buFontTx/>
+              <a:buNone/>
+              <a:tabLst/>
+              <a:defRPr/>
+            </a:pPr>
+            <a:r>
+              <a:rPr kumimoji="0" lang="en-US" sz="700" b="1" i="0" u="none" strike="noStrike" kern="0" cap="none" spc="400" normalizeH="0" baseline="0" noProof="0" dirty="0">
+                <a:ln>
+                  <a:noFill/>
+                </a:ln>
+                <a:solidFill>
+                  <a:srgbClr val="E67E22"/>
+                </a:solidFill>
+                <a:effectLst/>
+                <a:uLnTx/>
+                <a:uFillTx/>
+                <a:latin typeface="Arial" panose="020B0604020202020204" pitchFamily="34" charset="0"/>
+                <a:ea typeface="Arial" pitchFamily="34" charset="-122"/>
+                <a:cs typeface="Arial" panose="020B0604020202020204" pitchFamily="34" charset="0"/>
+              </a:rPr>
+              <a:t>DISTRIBUCIÓ</a:t>
+            </a:r>
+            <a:r>
+              <a:rPr lang="en-US" sz="700" b="1" kern="0" spc="400" dirty="0">
+                <a:solidFill>
+                  <a:srgbClr val="E67E22"/>
+                </a:solidFill>
+                <a:latin typeface="Arial" panose="020B0604020202020204" pitchFamily="34" charset="0"/>
+                <a:ea typeface="Arial" pitchFamily="34" charset="-122"/>
+                <a:cs typeface="Arial" panose="020B0604020202020204" pitchFamily="34" charset="0"/>
+              </a:rPr>
+              <a:t>N DE ESTACIONES – MATRIZ ORIGEN DESTINO</a:t>
+            </a:r>
+            <a:endParaRPr kumimoji="0" lang="en-US" sz="700" b="0" i="0" u="none" strike="noStrike" kern="1200" cap="none" spc="0" normalizeH="0" baseline="0" noProof="0" dirty="0">
+              <a:ln>
+                <a:noFill/>
+              </a:ln>
+              <a:solidFill>
+                <a:prstClr val="black"/>
+              </a:solidFill>
+              <a:effectLst/>
+              <a:uLnTx/>
+              <a:uFillTx/>
+              <a:latin typeface="Arial" panose="020B0604020202020204" pitchFamily="34" charset="0"/>
+              <a:cs typeface="Arial" panose="020B0604020202020204" pitchFamily="34" charset="0"/>
+            </a:endParaRPr>
+          </a:p>
+        </p:txBody>
+      </p:sp>
+      <p:pic>
+        <p:nvPicPr>
+          <p:cNvPr id="21" name="Imagen 20">
+            <a:extLst>
+              <a:ext uri="{FF2B5EF4-FFF2-40B4-BE49-F238E27FC236}">
+                <a16:creationId xmlns:a16="http://schemas.microsoft.com/office/drawing/2014/main" id="{EFE964D2-6E67-B0B7-414B-8B91B40BFE62}"/>
+              </a:ext>
+            </a:extLst>
+          </p:cNvPr>
+          <p:cNvPicPr>
+            <a:picLocks noChangeAspect="1"/>
+          </p:cNvPicPr>
+          <p:nvPr/>
+        </p:nvPicPr>
+        <p:blipFill>
+          <a:blip r:embed="rId3"/>
+          <a:stretch>
+            <a:fillRect/>
+          </a:stretch>
+        </p:blipFill>
+        <p:spPr>
+          <a:xfrm>
+            <a:off x="3362956" y="1022502"/>
+            <a:ext cx="2227220" cy="2109692"/>
+          </a:xfrm>
+          <a:prstGeom prst="rect">
+            <a:avLst/>
+          </a:prstGeom>
+        </p:spPr>
+      </p:pic>
+      <p:pic>
+        <p:nvPicPr>
+          <p:cNvPr id="23" name="Imagen 22">
+            <a:extLst>
+              <a:ext uri="{FF2B5EF4-FFF2-40B4-BE49-F238E27FC236}">
+                <a16:creationId xmlns:a16="http://schemas.microsoft.com/office/drawing/2014/main" id="{1DC6B7C1-3574-3BA0-54CC-D5D43D209AE2}"/>
+              </a:ext>
+            </a:extLst>
+          </p:cNvPr>
+          <p:cNvPicPr>
+            <a:picLocks noChangeAspect="1"/>
+          </p:cNvPicPr>
+          <p:nvPr/>
+        </p:nvPicPr>
+        <p:blipFill>
+          <a:blip r:embed="rId4"/>
+          <a:stretch>
+            <a:fillRect/>
+          </a:stretch>
+        </p:blipFill>
+        <p:spPr>
+          <a:xfrm>
+            <a:off x="5590176" y="777240"/>
+            <a:ext cx="3172339" cy="2361103"/>
+          </a:xfrm>
+          <a:prstGeom prst="rect">
+            <a:avLst/>
+          </a:prstGeom>
+        </p:spPr>
+      </p:pic>
+      <p:pic>
+        <p:nvPicPr>
+          <p:cNvPr id="25" name="Imagen 24">
+            <a:extLst>
+              <a:ext uri="{FF2B5EF4-FFF2-40B4-BE49-F238E27FC236}">
+                <a16:creationId xmlns:a16="http://schemas.microsoft.com/office/drawing/2014/main" id="{D182477E-D500-91E5-E6A8-E34E3F0A697F}"/>
+              </a:ext>
+            </a:extLst>
+          </p:cNvPr>
+          <p:cNvPicPr>
+            <a:picLocks noChangeAspect="1"/>
+          </p:cNvPicPr>
+          <p:nvPr/>
+        </p:nvPicPr>
+        <p:blipFill>
+          <a:blip r:embed="rId5"/>
+          <a:stretch>
+            <a:fillRect/>
+          </a:stretch>
+        </p:blipFill>
+        <p:spPr>
+          <a:xfrm>
+            <a:off x="414524" y="2112377"/>
+            <a:ext cx="2948432" cy="1019817"/>
+          </a:xfrm>
+          <a:prstGeom prst="rect">
+            <a:avLst/>
+          </a:prstGeom>
+        </p:spPr>
+      </p:pic>
+      <p:sp>
+        <p:nvSpPr>
+          <p:cNvPr id="26" name="Text 8">
+            <a:extLst>
+              <a:ext uri="{FF2B5EF4-FFF2-40B4-BE49-F238E27FC236}">
+                <a16:creationId xmlns:a16="http://schemas.microsoft.com/office/drawing/2014/main" id="{7387B89E-551B-E587-CBEA-6D539E380C0D}"/>
+              </a:ext>
+            </a:extLst>
+          </p:cNvPr>
+          <p:cNvSpPr/>
+          <p:nvPr/>
+        </p:nvSpPr>
+        <p:spPr>
+          <a:xfrm>
+            <a:off x="243837" y="3144001"/>
+            <a:ext cx="6111241" cy="228600"/>
+          </a:xfrm>
+          <a:prstGeom prst="rect">
+            <a:avLst/>
+          </a:prstGeom>
+          <a:noFill/>
+          <a:ln/>
+        </p:spPr>
+        <p:txBody>
+          <a:bodyPr wrap="square" lIns="0" tIns="0" rIns="0" bIns="0" rtlCol="0" anchor="ctr"/>
+          <a:lstStyle/>
+          <a:p>
+            <a:pPr marL="0" marR="0" lvl="0" indent="0" algn="l" defTabSz="914400" eaLnBrk="1" fontAlgn="auto" latinLnBrk="0" hangingPunct="1">
+              <a:lnSpc>
+                <a:spcPct val="100000"/>
+              </a:lnSpc>
+              <a:spcBef>
+                <a:spcPts val="0"/>
+              </a:spcBef>
+              <a:spcAft>
+                <a:spcPts val="0"/>
+              </a:spcAft>
+              <a:buClrTx/>
+              <a:buSzTx/>
+              <a:buFontTx/>
+              <a:buNone/>
+              <a:tabLst/>
+              <a:defRPr/>
+            </a:pPr>
+            <a:r>
+              <a:rPr lang="en-US" sz="700" b="1" kern="0" spc="400" dirty="0">
+                <a:solidFill>
+                  <a:srgbClr val="E67E22"/>
+                </a:solidFill>
+                <a:latin typeface="Arial" panose="020B0604020202020204" pitchFamily="34" charset="0"/>
+                <a:ea typeface="Arial" pitchFamily="34" charset="-122"/>
+                <a:cs typeface="Arial" panose="020B0604020202020204" pitchFamily="34" charset="0"/>
+              </a:rPr>
+              <a:t>DURACIÓN DE VIAJES-TARFARIO VIGENTE 2024</a:t>
+            </a:r>
+            <a:endParaRPr kumimoji="0" lang="en-US" sz="700" b="0" i="0" u="none" strike="noStrike" kern="1200" cap="none" spc="0" normalizeH="0" baseline="0" noProof="0" dirty="0">
+              <a:ln>
+                <a:noFill/>
+              </a:ln>
+              <a:solidFill>
+                <a:prstClr val="black"/>
+              </a:solidFill>
+              <a:effectLst/>
+              <a:uLnTx/>
+              <a:uFillTx/>
+              <a:latin typeface="Arial" panose="020B0604020202020204" pitchFamily="34" charset="0"/>
+              <a:cs typeface="Arial" panose="020B0604020202020204" pitchFamily="34" charset="0"/>
+            </a:endParaRPr>
+          </a:p>
+        </p:txBody>
+      </p:sp>
+      <p:sp>
+        <p:nvSpPr>
+          <p:cNvPr id="27" name="Text 7">
+            <a:extLst>
+              <a:ext uri="{FF2B5EF4-FFF2-40B4-BE49-F238E27FC236}">
+                <a16:creationId xmlns:a16="http://schemas.microsoft.com/office/drawing/2014/main" id="{330F680F-BEC8-A3F9-3E4A-31724441CA61}"/>
+              </a:ext>
+            </a:extLst>
+          </p:cNvPr>
+          <p:cNvSpPr/>
+          <p:nvPr/>
+        </p:nvSpPr>
+        <p:spPr>
+          <a:xfrm>
+            <a:off x="243838" y="3372601"/>
+            <a:ext cx="4156282" cy="1187470"/>
+          </a:xfrm>
+          <a:prstGeom prst="rect">
+            <a:avLst/>
+          </a:prstGeom>
+          <a:noFill/>
+          <a:ln/>
+        </p:spPr>
+        <p:txBody>
+          <a:bodyPr wrap="square" lIns="0" tIns="0" rIns="0" bIns="0" rtlCol="0" anchor="t"/>
+          <a:lstStyle/>
+          <a:p>
+            <a:pPr marL="171450" indent="-171450">
+              <a:buFont typeface="Wingdings" panose="05000000000000000000" pitchFamily="2" charset="2"/>
+              <a:buChar char="§"/>
+            </a:pPr>
+            <a:r>
+              <a:rPr lang="es-AR" sz="1000" i="1" dirty="0">
+                <a:solidFill>
+                  <a:srgbClr val="2C3E50"/>
+                </a:solidFill>
+                <a:latin typeface="Calibri" pitchFamily="34" charset="0"/>
+                <a:ea typeface="Calibri" pitchFamily="34" charset="-122"/>
+                <a:cs typeface="Calibri" pitchFamily="34" charset="-120"/>
+              </a:rPr>
+              <a:t>Distribución de duración con asimetría positivo.</a:t>
+            </a:r>
+          </a:p>
+          <a:p>
+            <a:pPr marL="171450" indent="-171450">
+              <a:buFont typeface="Wingdings" panose="05000000000000000000" pitchFamily="2" charset="2"/>
+              <a:buChar char="§"/>
+            </a:pPr>
+            <a:r>
+              <a:rPr lang="es-AR" sz="1000" i="1" dirty="0">
+                <a:solidFill>
+                  <a:srgbClr val="2C3E50"/>
+                </a:solidFill>
+                <a:latin typeface="Calibri" pitchFamily="34" charset="0"/>
+                <a:ea typeface="Calibri" pitchFamily="34" charset="-122"/>
+                <a:cs typeface="Calibri" pitchFamily="34" charset="-120"/>
+              </a:rPr>
+              <a:t>Los viajes día de semana &gt; 30min y los viajes de fin de semana se abonaban.</a:t>
+            </a:r>
+          </a:p>
+          <a:p>
+            <a:pPr marL="171450" indent="-171450">
+              <a:buFont typeface="Wingdings" panose="05000000000000000000" pitchFamily="2" charset="2"/>
+              <a:buChar char="§"/>
+            </a:pPr>
+            <a:r>
+              <a:rPr lang="es-AR" sz="1000" i="1" dirty="0">
+                <a:solidFill>
+                  <a:srgbClr val="2C3E50"/>
+                </a:solidFill>
+                <a:latin typeface="Calibri" pitchFamily="34" charset="0"/>
+                <a:ea typeface="Calibri" pitchFamily="34" charset="-122"/>
+                <a:cs typeface="Calibri" pitchFamily="34" charset="-120"/>
+              </a:rPr>
+              <a:t>Mayor cantidad de viajes en días hábiles pero de menor recorrido que los del fin de semana.</a:t>
+            </a:r>
+          </a:p>
+          <a:p>
+            <a:pPr marL="171450" indent="-171450">
+              <a:buFont typeface="Wingdings" panose="05000000000000000000" pitchFamily="2" charset="2"/>
+              <a:buChar char="§"/>
+            </a:pPr>
+            <a:r>
+              <a:rPr lang="es-AR" sz="1000" i="1" dirty="0">
+                <a:solidFill>
+                  <a:srgbClr val="2C3E50"/>
+                </a:solidFill>
+                <a:latin typeface="Calibri" pitchFamily="34" charset="0"/>
+                <a:ea typeface="Calibri" pitchFamily="34" charset="-122"/>
+                <a:cs typeface="Calibri" pitchFamily="34" charset="-120"/>
+              </a:rPr>
+              <a:t>Menor dispersión en la duración de los viajes en horas de la mañana </a:t>
+            </a:r>
+          </a:p>
+          <a:p>
+            <a:pPr marL="171450" indent="-171450">
+              <a:buFont typeface="Wingdings" panose="05000000000000000000" pitchFamily="2" charset="2"/>
+              <a:buChar char="§"/>
+            </a:pPr>
+            <a:endParaRPr lang="es-AR" sz="1000" i="1" dirty="0">
+              <a:solidFill>
+                <a:srgbClr val="2C3E50"/>
+              </a:solidFill>
+              <a:latin typeface="Calibri" pitchFamily="34" charset="0"/>
+              <a:ea typeface="Calibri" pitchFamily="34" charset="-122"/>
+              <a:cs typeface="Calibri" pitchFamily="34" charset="-120"/>
+            </a:endParaRPr>
+          </a:p>
+          <a:p>
+            <a:pPr marL="171450" indent="-171450">
+              <a:buFont typeface="Wingdings" panose="05000000000000000000" pitchFamily="2" charset="2"/>
+              <a:buChar char="§"/>
+            </a:pPr>
+            <a:endParaRPr lang="es-AR" sz="1000" i="1" dirty="0">
+              <a:solidFill>
+                <a:srgbClr val="2C3E50"/>
+              </a:solidFill>
+              <a:latin typeface="Calibri" pitchFamily="34" charset="0"/>
+              <a:ea typeface="Calibri" pitchFamily="34" charset="-122"/>
+              <a:cs typeface="Calibri" pitchFamily="34" charset="-120"/>
+            </a:endParaRPr>
+          </a:p>
+          <a:p>
+            <a:pPr marL="171450" indent="-171450">
+              <a:buFont typeface="Wingdings" panose="05000000000000000000" pitchFamily="2" charset="2"/>
+              <a:buChar char="§"/>
+            </a:pPr>
+            <a:endParaRPr lang="es-ES" sz="1000" i="1" dirty="0">
+              <a:solidFill>
+                <a:srgbClr val="2C3E50"/>
+              </a:solidFill>
+              <a:latin typeface="Calibri" pitchFamily="34" charset="0"/>
+              <a:ea typeface="Calibri" pitchFamily="34" charset="-122"/>
+              <a:cs typeface="Calibri" pitchFamily="34" charset="-120"/>
+            </a:endParaRPr>
+          </a:p>
+        </p:txBody>
+      </p:sp>
+      <p:pic>
+        <p:nvPicPr>
+          <p:cNvPr id="29" name="Imagen 28">
+            <a:extLst>
+              <a:ext uri="{FF2B5EF4-FFF2-40B4-BE49-F238E27FC236}">
+                <a16:creationId xmlns:a16="http://schemas.microsoft.com/office/drawing/2014/main" id="{56DF4123-1E93-D9D1-00B9-18FD77F10CC5}"/>
+              </a:ext>
+            </a:extLst>
+          </p:cNvPr>
+          <p:cNvPicPr>
+            <a:picLocks noChangeAspect="1"/>
+          </p:cNvPicPr>
+          <p:nvPr/>
+        </p:nvPicPr>
+        <p:blipFill>
+          <a:blip r:embed="rId6"/>
+          <a:stretch>
+            <a:fillRect/>
+          </a:stretch>
+        </p:blipFill>
+        <p:spPr>
+          <a:xfrm>
+            <a:off x="4412518" y="3170347"/>
+            <a:ext cx="4731482" cy="1973154"/>
+          </a:xfrm>
+          <a:prstGeom prst="rect">
+            <a:avLst/>
+          </a:prstGeom>
+        </p:spPr>
+      </p:pic>
+      <p:pic>
+        <p:nvPicPr>
+          <p:cNvPr id="31" name="Imagen 30">
+            <a:extLst>
+              <a:ext uri="{FF2B5EF4-FFF2-40B4-BE49-F238E27FC236}">
+                <a16:creationId xmlns:a16="http://schemas.microsoft.com/office/drawing/2014/main" id="{92E8760D-F521-4129-043C-CFF35781AB6D}"/>
+              </a:ext>
+            </a:extLst>
+          </p:cNvPr>
+          <p:cNvPicPr>
+            <a:picLocks noChangeAspect="1"/>
+          </p:cNvPicPr>
+          <p:nvPr/>
+        </p:nvPicPr>
+        <p:blipFill>
+          <a:blip r:embed="rId7"/>
+          <a:srcRect b="50000"/>
+          <a:stretch>
+            <a:fillRect/>
+          </a:stretch>
+        </p:blipFill>
+        <p:spPr>
+          <a:xfrm>
+            <a:off x="5383028" y="4672177"/>
+            <a:ext cx="1300910" cy="208065"/>
+          </a:xfrm>
+          <a:prstGeom prst="rect">
+            <a:avLst/>
+          </a:prstGeom>
+        </p:spPr>
+      </p:pic>
+      <p:pic>
+        <p:nvPicPr>
+          <p:cNvPr id="32" name="Imagen 31">
+            <a:extLst>
+              <a:ext uri="{FF2B5EF4-FFF2-40B4-BE49-F238E27FC236}">
+                <a16:creationId xmlns:a16="http://schemas.microsoft.com/office/drawing/2014/main" id="{C9C9C296-82EB-414E-0F51-A9E2E98B0EEB}"/>
+              </a:ext>
+            </a:extLst>
+          </p:cNvPr>
+          <p:cNvPicPr>
+            <a:picLocks noChangeAspect="1"/>
+          </p:cNvPicPr>
+          <p:nvPr/>
+        </p:nvPicPr>
+        <p:blipFill>
+          <a:blip r:embed="rId7"/>
+          <a:srcRect t="66514"/>
+          <a:stretch>
+            <a:fillRect/>
+          </a:stretch>
+        </p:blipFill>
+        <p:spPr>
+          <a:xfrm>
+            <a:off x="7517419" y="4743568"/>
+            <a:ext cx="1431001" cy="153281"/>
+          </a:xfrm>
+          <a:prstGeom prst="rect">
+            <a:avLst/>
+          </a:prstGeom>
+        </p:spPr>
+      </p:pic>
+      <p:pic>
+        <p:nvPicPr>
+          <p:cNvPr id="34" name="Imagen 33">
+            <a:extLst>
+              <a:ext uri="{FF2B5EF4-FFF2-40B4-BE49-F238E27FC236}">
+                <a16:creationId xmlns:a16="http://schemas.microsoft.com/office/drawing/2014/main" id="{7625F3CE-388C-8E5A-2644-B88343DDDF1D}"/>
+              </a:ext>
+            </a:extLst>
+          </p:cNvPr>
+          <p:cNvPicPr>
+            <a:picLocks noChangeAspect="1"/>
+          </p:cNvPicPr>
+          <p:nvPr/>
+        </p:nvPicPr>
+        <p:blipFill>
+          <a:blip r:embed="rId8"/>
+          <a:stretch>
+            <a:fillRect/>
+          </a:stretch>
+        </p:blipFill>
+        <p:spPr>
+          <a:xfrm>
+            <a:off x="365760" y="4164478"/>
+            <a:ext cx="2328990" cy="979023"/>
+          </a:xfrm>
+          <a:prstGeom prst="rect">
+            <a:avLst/>
+          </a:prstGeom>
+        </p:spPr>
+      </p:pic>
+      <p:pic>
+        <p:nvPicPr>
+          <p:cNvPr id="36" name="Imagen 35">
+            <a:extLst>
+              <a:ext uri="{FF2B5EF4-FFF2-40B4-BE49-F238E27FC236}">
+                <a16:creationId xmlns:a16="http://schemas.microsoft.com/office/drawing/2014/main" id="{701352A9-A318-636C-A4DA-816C2DB43301}"/>
+              </a:ext>
+            </a:extLst>
+          </p:cNvPr>
+          <p:cNvPicPr>
+            <a:picLocks noChangeAspect="1"/>
+          </p:cNvPicPr>
+          <p:nvPr/>
+        </p:nvPicPr>
+        <p:blipFill>
+          <a:blip r:embed="rId9"/>
+          <a:stretch>
+            <a:fillRect/>
+          </a:stretch>
+        </p:blipFill>
+        <p:spPr>
+          <a:xfrm>
+            <a:off x="3332665" y="4138255"/>
+            <a:ext cx="905001" cy="252447"/>
+          </a:xfrm>
+          <a:prstGeom prst="rect">
+            <a:avLst/>
+          </a:prstGeom>
+        </p:spPr>
+      </p:pic>
+      <p:pic>
+        <p:nvPicPr>
+          <p:cNvPr id="38" name="Imagen 37">
+            <a:extLst>
+              <a:ext uri="{FF2B5EF4-FFF2-40B4-BE49-F238E27FC236}">
+                <a16:creationId xmlns:a16="http://schemas.microsoft.com/office/drawing/2014/main" id="{19D64E19-B9DA-4580-BD78-26B025F87D33}"/>
+              </a:ext>
+            </a:extLst>
+          </p:cNvPr>
+          <p:cNvPicPr>
+            <a:picLocks noChangeAspect="1"/>
+          </p:cNvPicPr>
+          <p:nvPr/>
+        </p:nvPicPr>
+        <p:blipFill>
+          <a:blip r:embed="rId10"/>
+          <a:stretch>
+            <a:fillRect/>
+          </a:stretch>
+        </p:blipFill>
+        <p:spPr>
+          <a:xfrm>
+            <a:off x="2694750" y="4175213"/>
+            <a:ext cx="1717767" cy="968287"/>
+          </a:xfrm>
+          <a:prstGeom prst="rect">
+            <a:avLst/>
+          </a:prstGeom>
+        </p:spPr>
+      </p:pic>
+    </p:spTree>
+    <p:extLst>
+      <p:ext uri="{BB962C8B-B14F-4D97-AF65-F5344CB8AC3E}">
+        <p14:creationId xmlns:p14="http://schemas.microsoft.com/office/powerpoint/2010/main" val="2724039648"/>
+      </p:ext>
+    </p:extLst>
+  </p:cSld>
+  <p:clrMapOvr>
+    <a:masterClrMapping/>
+  </p:clrMapOvr>
+</p:sld>
+</file>
+
+<file path=ppt/slides/slide4.xml><?xml version="1.0" encoding="utf-8"?>
+<p:sld xmlns:a="http://schemas.openxmlformats.org/drawingml/2006/main" xmlns:r="http://schemas.openxmlformats.org/officeDocument/2006/relationships" xmlns:p="http://schemas.openxmlformats.org/presentationml/2006/main">
   <p:cSld name="Slide 3">
     <p:bg>
       <p:bgPr>
         <a:solidFill>
           <a:srgbClr val="FAF5EC"/>
         </a:solidFill>
+        <a:effectLst/>
       </p:bgPr>
     </p:bg>
     <p:spTree>
@@ -2821,6 +4046,13 @@
           </a:solidFill>
           <a:ln/>
         </p:spPr>
+        <p:txBody>
+          <a:bodyPr/>
+          <a:lstStyle/>
+          <a:p>
+            <a:endParaRPr lang="en-US"/>
+          </a:p>
+        </p:txBody>
       </p:sp>
       <p:sp>
         <p:nvSpPr>
@@ -2841,6 +4073,13 @@
           </a:solidFill>
           <a:ln/>
         </p:spPr>
+        <p:txBody>
+          <a:bodyPr/>
+          <a:lstStyle/>
+          <a:p>
+            <a:endParaRPr lang="en-US"/>
+          </a:p>
+        </p:txBody>
       </p:sp>
       <p:sp>
         <p:nvSpPr>
@@ -2863,11 +4102,11 @@
           <a:bodyPr wrap="square" lIns="0" tIns="0" rIns="0" bIns="0" rtlCol="0" anchor="ctr"/>
           <a:lstStyle/>
           <a:p>
-            <a:pPr indent="0" marL="0">
+            <a:pPr marL="0" indent="0">
               <a:buNone/>
             </a:pPr>
             <a:r>
-              <a:rPr lang="en-US" sz="1000" b="1" spc="600" kern="0" dirty="0">
+              <a:rPr lang="en-US" sz="1000" b="1" kern="0" spc="600" dirty="0">
                 <a:solidFill>
                   <a:srgbClr val="E67E22"/>
                 </a:solidFill>
@@ -2902,7 +4141,7 @@
           <a:bodyPr wrap="square" lIns="0" tIns="0" rIns="0" bIns="0" rtlCol="0" anchor="ctr"/>
           <a:lstStyle/>
           <a:p>
-            <a:pPr indent="0" marL="0">
+            <a:pPr marL="0" indent="0">
               <a:buNone/>
             </a:pPr>
             <a:r>
@@ -2944,6 +4183,13 @@
             <a:prstDash val="dash"/>
           </a:ln>
         </p:spPr>
+        <p:txBody>
+          <a:bodyPr/>
+          <a:lstStyle/>
+          <a:p>
+            <a:endParaRPr lang="en-US"/>
+          </a:p>
+        </p:txBody>
       </p:sp>
       <p:sp>
         <p:nvSpPr>
@@ -2966,11 +4212,11 @@
           <a:bodyPr wrap="square" rtlCol="0" anchor="ctr"/>
           <a:lstStyle/>
           <a:p>
-            <a:pPr algn="ctr" indent="0" marL="0">
+            <a:pPr marL="0" indent="0" algn="ctr">
               <a:buNone/>
             </a:pPr>
             <a:r>
-              <a:rPr lang="en-US" sz="1100" b="1" spc="500" kern="0" dirty="0">
+              <a:rPr lang="en-US" sz="1100" b="1" kern="0" spc="500" dirty="0">
                 <a:solidFill>
                   <a:srgbClr val="E67E22"/>
                 </a:solidFill>
@@ -3005,7 +4251,7 @@
           <a:bodyPr wrap="square" lIns="0" tIns="0" rIns="0" bIns="0" rtlCol="0" anchor="ctr"/>
           <a:lstStyle/>
           <a:p>
-            <a:pPr indent="0" marL="0">
+            <a:pPr marL="0" indent="0">
               <a:buNone/>
             </a:pPr>
             <a:r>
@@ -3157,6 +4403,13 @@
             <a:prstDash val="solid"/>
           </a:ln>
         </p:spPr>
+        <p:txBody>
+          <a:bodyPr/>
+          <a:lstStyle/>
+          <a:p>
+            <a:endParaRPr lang="en-US"/>
+          </a:p>
+        </p:txBody>
       </p:sp>
       <p:sp>
         <p:nvSpPr>
@@ -3179,7 +4432,7 @@
           <a:bodyPr wrap="square" lIns="0" tIns="0" rIns="0" bIns="0" rtlCol="0" anchor="ctr"/>
           <a:lstStyle/>
           <a:p>
-            <a:pPr indent="0" marL="0">
+            <a:pPr marL="0" indent="0">
               <a:buNone/>
             </a:pPr>
             <a:r>
@@ -3205,7 +4458,7 @@
 </p:sld>
 </file>
 
-<file path=ppt/slides/slide4.xml><?xml version="1.0" encoding="utf-8"?>
+<file path=ppt/slides/slide5.xml><?xml version="1.0" encoding="utf-8"?>
 <p:sld xmlns:a="http://schemas.openxmlformats.org/drawingml/2006/main" xmlns:r="http://schemas.openxmlformats.org/officeDocument/2006/relationships" xmlns:p="http://schemas.openxmlformats.org/presentationml/2006/main">
   <p:cSld name="Slide 4">
     <p:bg>
@@ -3213,6 +4466,7 @@
         <a:solidFill>
           <a:srgbClr val="FAF5EC"/>
         </a:solidFill>
+        <a:effectLst/>
       </p:bgPr>
     </p:bg>
     <p:spTree>
@@ -3248,6 +4502,13 @@
           </a:solidFill>
           <a:ln/>
         </p:spPr>
+        <p:txBody>
+          <a:bodyPr/>
+          <a:lstStyle/>
+          <a:p>
+            <a:endParaRPr lang="en-US"/>
+          </a:p>
+        </p:txBody>
       </p:sp>
       <p:sp>
         <p:nvSpPr>
@@ -3268,6 +4529,13 @@
           </a:solidFill>
           <a:ln/>
         </p:spPr>
+        <p:txBody>
+          <a:bodyPr/>
+          <a:lstStyle/>
+          <a:p>
+            <a:endParaRPr lang="en-US"/>
+          </a:p>
+        </p:txBody>
       </p:sp>
       <p:sp>
         <p:nvSpPr>
@@ -3290,11 +4558,11 @@
           <a:bodyPr wrap="square" lIns="0" tIns="0" rIns="0" bIns="0" rtlCol="0" anchor="ctr"/>
           <a:lstStyle/>
           <a:p>
-            <a:pPr indent="0" marL="0">
+            <a:pPr marL="0" indent="0">
               <a:buNone/>
             </a:pPr>
             <a:r>
-              <a:rPr lang="en-US" sz="1000" b="1" spc="600" kern="0" dirty="0">
+              <a:rPr lang="en-US" sz="1000" b="1" kern="0" spc="600" dirty="0">
                 <a:solidFill>
                   <a:srgbClr val="E67E22"/>
                 </a:solidFill>
@@ -3329,7 +4597,7 @@
           <a:bodyPr wrap="square" lIns="0" tIns="0" rIns="0" bIns="0" rtlCol="0" anchor="ctr"/>
           <a:lstStyle/>
           <a:p>
-            <a:pPr indent="0" marL="0">
+            <a:pPr marL="0" indent="0">
               <a:buNone/>
             </a:pPr>
             <a:r>
@@ -3371,6 +4639,13 @@
             <a:prstDash val="dash"/>
           </a:ln>
         </p:spPr>
+        <p:txBody>
+          <a:bodyPr/>
+          <a:lstStyle/>
+          <a:p>
+            <a:endParaRPr lang="en-US"/>
+          </a:p>
+        </p:txBody>
       </p:sp>
       <p:sp>
         <p:nvSpPr>
@@ -3393,11 +4668,11 @@
           <a:bodyPr wrap="square" rtlCol="0" anchor="ctr"/>
           <a:lstStyle/>
           <a:p>
-            <a:pPr algn="ctr" indent="0" marL="0">
+            <a:pPr marL="0" indent="0" algn="ctr">
               <a:buNone/>
             </a:pPr>
             <a:r>
-              <a:rPr lang="en-US" sz="1100" b="1" spc="500" kern="0" dirty="0">
+              <a:rPr lang="en-US" sz="1100" b="1" kern="0" spc="500" dirty="0">
                 <a:solidFill>
                   <a:srgbClr val="E67E22"/>
                 </a:solidFill>
@@ -3432,7 +4707,7 @@
           <a:bodyPr wrap="square" lIns="0" tIns="0" rIns="0" bIns="0" rtlCol="0" anchor="ctr"/>
           <a:lstStyle/>
           <a:p>
-            <a:pPr indent="0" marL="0">
+            <a:pPr marL="0" indent="0">
               <a:buNone/>
             </a:pPr>
             <a:r>
@@ -3584,6 +4859,13 @@
             <a:prstDash val="solid"/>
           </a:ln>
         </p:spPr>
+        <p:txBody>
+          <a:bodyPr/>
+          <a:lstStyle/>
+          <a:p>
+            <a:endParaRPr lang="en-US"/>
+          </a:p>
+        </p:txBody>
       </p:sp>
       <p:sp>
         <p:nvSpPr>
@@ -3606,7 +4888,7 @@
           <a:bodyPr wrap="square" lIns="0" tIns="0" rIns="0" bIns="0" rtlCol="0" anchor="ctr"/>
           <a:lstStyle/>
           <a:p>
-            <a:pPr indent="0" marL="0">
+            <a:pPr marL="0" indent="0">
               <a:buNone/>
             </a:pPr>
             <a:r>
@@ -3632,7 +4914,7 @@
 </p:sld>
 </file>
 
-<file path=ppt/slides/slide5.xml><?xml version="1.0" encoding="utf-8"?>
+<file path=ppt/slides/slide6.xml><?xml version="1.0" encoding="utf-8"?>
 <p:sld xmlns:a="http://schemas.openxmlformats.org/drawingml/2006/main" xmlns:r="http://schemas.openxmlformats.org/officeDocument/2006/relationships" xmlns:p="http://schemas.openxmlformats.org/presentationml/2006/main">
   <p:cSld name="Slide 5">
     <p:bg>
@@ -3640,6 +4922,7 @@
         <a:solidFill>
           <a:srgbClr val="FAF5EC"/>
         </a:solidFill>
+        <a:effectLst/>
       </p:bgPr>
     </p:bg>
     <p:spTree>
@@ -3675,6 +4958,13 @@
           </a:solidFill>
           <a:ln/>
         </p:spPr>
+        <p:txBody>
+          <a:bodyPr/>
+          <a:lstStyle/>
+          <a:p>
+            <a:endParaRPr lang="en-US"/>
+          </a:p>
+        </p:txBody>
       </p:sp>
       <p:sp>
         <p:nvSpPr>
@@ -3695,6 +4985,13 @@
           </a:solidFill>
           <a:ln/>
         </p:spPr>
+        <p:txBody>
+          <a:bodyPr/>
+          <a:lstStyle/>
+          <a:p>
+            <a:endParaRPr lang="en-US"/>
+          </a:p>
+        </p:txBody>
       </p:sp>
       <p:sp>
         <p:nvSpPr>
@@ -3717,11 +5014,11 @@
           <a:bodyPr wrap="square" lIns="0" tIns="0" rIns="0" bIns="0" rtlCol="0" anchor="ctr"/>
           <a:lstStyle/>
           <a:p>
-            <a:pPr indent="0" marL="0">
+            <a:pPr marL="0" indent="0">
               <a:buNone/>
             </a:pPr>
             <a:r>
-              <a:rPr lang="en-US" sz="1000" b="1" spc="600" kern="0" dirty="0">
+              <a:rPr lang="en-US" sz="1000" b="1" kern="0" spc="600" dirty="0">
                 <a:solidFill>
                   <a:srgbClr val="E67E22"/>
                 </a:solidFill>
@@ -3756,7 +5053,7 @@
           <a:bodyPr wrap="square" lIns="0" tIns="0" rIns="0" bIns="0" rtlCol="0" anchor="ctr"/>
           <a:lstStyle/>
           <a:p>
-            <a:pPr indent="0" marL="0">
+            <a:pPr marL="0" indent="0">
               <a:buNone/>
             </a:pPr>
             <a:r>
@@ -3798,6 +5095,13 @@
             <a:prstDash val="dash"/>
           </a:ln>
         </p:spPr>
+        <p:txBody>
+          <a:bodyPr/>
+          <a:lstStyle/>
+          <a:p>
+            <a:endParaRPr lang="en-US"/>
+          </a:p>
+        </p:txBody>
       </p:sp>
       <p:sp>
         <p:nvSpPr>
@@ -3820,11 +5124,11 @@
           <a:bodyPr wrap="square" rtlCol="0" anchor="ctr"/>
           <a:lstStyle/>
           <a:p>
-            <a:pPr algn="ctr" indent="0" marL="0">
+            <a:pPr marL="0" indent="0" algn="ctr">
               <a:buNone/>
             </a:pPr>
             <a:r>
-              <a:rPr lang="en-US" sz="1100" b="1" spc="500" kern="0" dirty="0">
+              <a:rPr lang="en-US" sz="1100" b="1" kern="0" spc="500" dirty="0">
                 <a:solidFill>
                   <a:srgbClr val="E67E22"/>
                 </a:solidFill>
@@ -3859,7 +5163,7 @@
           <a:bodyPr wrap="square" lIns="0" tIns="0" rIns="0" bIns="0" rtlCol="0" anchor="ctr"/>
           <a:lstStyle/>
           <a:p>
-            <a:pPr indent="0" marL="0">
+            <a:pPr marL="0" indent="0">
               <a:buNone/>
             </a:pPr>
             <a:r>
@@ -3952,7 +5256,7 @@
             <a:endParaRPr lang="en-US" sz="1200" dirty="0"/>
           </a:p>
           <a:p>
-            <a:pPr lvl="1" indent="0" marL="0">
+            <a:pPr marL="0" lvl="1" indent="0">
               <a:buNone/>
             </a:pPr>
             <a:r>
@@ -3969,7 +5273,7 @@
             <a:endParaRPr lang="en-US" sz="1200" dirty="0"/>
           </a:p>
           <a:p>
-            <a:pPr lvl="1" indent="0" marL="0">
+            <a:pPr marL="0" lvl="1" indent="0">
               <a:buNone/>
             </a:pPr>
             <a:r>
@@ -4027,6 +5331,13 @@
             <a:prstDash val="solid"/>
           </a:ln>
         </p:spPr>
+        <p:txBody>
+          <a:bodyPr/>
+          <a:lstStyle/>
+          <a:p>
+            <a:endParaRPr lang="en-US"/>
+          </a:p>
+        </p:txBody>
       </p:sp>
       <p:sp>
         <p:nvSpPr>
@@ -4049,7 +5360,7 @@
           <a:bodyPr wrap="square" lIns="0" tIns="0" rIns="0" bIns="0" rtlCol="0" anchor="ctr"/>
           <a:lstStyle/>
           <a:p>
-            <a:pPr indent="0" marL="0">
+            <a:pPr marL="0" indent="0">
               <a:buNone/>
             </a:pPr>
             <a:r>
@@ -4075,7 +5386,7 @@
 </p:sld>
 </file>
 
-<file path=ppt/slides/slide6.xml><?xml version="1.0" encoding="utf-8"?>
+<file path=ppt/slides/slide7.xml><?xml version="1.0" encoding="utf-8"?>
 <p:sld xmlns:a="http://schemas.openxmlformats.org/drawingml/2006/main" xmlns:r="http://schemas.openxmlformats.org/officeDocument/2006/relationships" xmlns:p="http://schemas.openxmlformats.org/presentationml/2006/main">
   <p:cSld name="Slide 6">
     <p:bg>
@@ -4083,6 +5394,7 @@
         <a:solidFill>
           <a:srgbClr val="FAF5EC"/>
         </a:solidFill>
+        <a:effectLst/>
       </p:bgPr>
     </p:bg>
     <p:spTree>
@@ -4118,6 +5430,13 @@
           </a:solidFill>
           <a:ln/>
         </p:spPr>
+        <p:txBody>
+          <a:bodyPr/>
+          <a:lstStyle/>
+          <a:p>
+            <a:endParaRPr lang="en-US"/>
+          </a:p>
+        </p:txBody>
       </p:sp>
       <p:sp>
         <p:nvSpPr>
@@ -4138,6 +5457,13 @@
           </a:solidFill>
           <a:ln/>
         </p:spPr>
+        <p:txBody>
+          <a:bodyPr/>
+          <a:lstStyle/>
+          <a:p>
+            <a:endParaRPr lang="en-US"/>
+          </a:p>
+        </p:txBody>
       </p:sp>
       <p:sp>
         <p:nvSpPr>
@@ -4160,11 +5486,11 @@
           <a:bodyPr wrap="square" lIns="0" tIns="0" rIns="0" bIns="0" rtlCol="0" anchor="ctr"/>
           <a:lstStyle/>
           <a:p>
-            <a:pPr indent="0" marL="0">
+            <a:pPr marL="0" indent="0">
               <a:buNone/>
             </a:pPr>
             <a:r>
-              <a:rPr lang="en-US" sz="1000" b="1" spc="600" kern="0" dirty="0">
+              <a:rPr lang="en-US" sz="1000" b="1" kern="0" spc="600" dirty="0">
                 <a:solidFill>
                   <a:srgbClr val="E67E22"/>
                 </a:solidFill>
@@ -4199,7 +5525,7 @@
           <a:bodyPr wrap="square" lIns="0" tIns="0" rIns="0" bIns="0" rtlCol="0" anchor="ctr"/>
           <a:lstStyle/>
           <a:p>
-            <a:pPr indent="0" marL="0">
+            <a:pPr marL="0" indent="0">
               <a:buNone/>
             </a:pPr>
             <a:r>
@@ -4241,6 +5567,13 @@
             <a:prstDash val="dash"/>
           </a:ln>
         </p:spPr>
+        <p:txBody>
+          <a:bodyPr/>
+          <a:lstStyle/>
+          <a:p>
+            <a:endParaRPr lang="en-US"/>
+          </a:p>
+        </p:txBody>
       </p:sp>
       <p:sp>
         <p:nvSpPr>
@@ -4263,11 +5596,11 @@
           <a:bodyPr wrap="square" rtlCol="0" anchor="ctr"/>
           <a:lstStyle/>
           <a:p>
-            <a:pPr algn="ctr" indent="0" marL="0">
+            <a:pPr marL="0" indent="0" algn="ctr">
               <a:buNone/>
             </a:pPr>
             <a:r>
-              <a:rPr lang="en-US" sz="1100" b="1" spc="500" kern="0" dirty="0">
+              <a:rPr lang="en-US" sz="1100" b="1" kern="0" spc="500" dirty="0">
                 <a:solidFill>
                   <a:srgbClr val="E67E22"/>
                 </a:solidFill>
@@ -4302,7 +5635,7 @@
           <a:bodyPr wrap="square" lIns="0" tIns="0" rIns="0" bIns="0" rtlCol="0" anchor="ctr"/>
           <a:lstStyle/>
           <a:p>
-            <a:pPr indent="0" marL="0">
+            <a:pPr marL="0" indent="0">
               <a:buNone/>
             </a:pPr>
             <a:r>
@@ -4454,6 +5787,13 @@
             <a:prstDash val="solid"/>
           </a:ln>
         </p:spPr>
+        <p:txBody>
+          <a:bodyPr/>
+          <a:lstStyle/>
+          <a:p>
+            <a:endParaRPr lang="en-US"/>
+          </a:p>
+        </p:txBody>
       </p:sp>
       <p:sp>
         <p:nvSpPr>
@@ -4476,7 +5816,7 @@
           <a:bodyPr wrap="square" lIns="0" tIns="0" rIns="0" bIns="0" rtlCol="0" anchor="ctr"/>
           <a:lstStyle/>
           <a:p>
-            <a:pPr indent="0" marL="0">
+            <a:pPr marL="0" indent="0">
               <a:buNone/>
             </a:pPr>
             <a:r>
@@ -4795,4 +6135,319 @@
     </a:ext>
   </a:extLst>
 </a:theme>
+</file>
+
+<file path=ppt/theme/theme2.xml><?xml version="1.0" encoding="utf-8"?>
+<a:theme xmlns:a="http://schemas.openxmlformats.org/drawingml/2006/main" name="Tema de Office">
+  <a:themeElements>
+    <a:clrScheme name="Office">
+      <a:dk1>
+        <a:sysClr val="windowText" lastClr="000000"/>
+      </a:dk1>
+      <a:lt1>
+        <a:sysClr val="window" lastClr="FFFFFF"/>
+      </a:lt1>
+      <a:dk2>
+        <a:srgbClr val="0E2841"/>
+      </a:dk2>
+      <a:lt2>
+        <a:srgbClr val="E8E8E8"/>
+      </a:lt2>
+      <a:accent1>
+        <a:srgbClr val="156082"/>
+      </a:accent1>
+      <a:accent2>
+        <a:srgbClr val="E97132"/>
+      </a:accent2>
+      <a:accent3>
+        <a:srgbClr val="196B24"/>
+      </a:accent3>
+      <a:accent4>
+        <a:srgbClr val="0F9ED5"/>
+      </a:accent4>
+      <a:accent5>
+        <a:srgbClr val="A02B93"/>
+      </a:accent5>
+      <a:accent6>
+        <a:srgbClr val="4EA72E"/>
+      </a:accent6>
+      <a:hlink>
+        <a:srgbClr val="467886"/>
+      </a:hlink>
+      <a:folHlink>
+        <a:srgbClr val="96607D"/>
+      </a:folHlink>
+    </a:clrScheme>
+    <a:fontScheme name="Office">
+      <a:majorFont>
+        <a:latin typeface="Aptos Display" panose="02110004020202020204"/>
+        <a:ea typeface=""/>
+        <a:cs typeface=""/>
+        <a:font script="Jpan" typeface="游ゴシック Light"/>
+        <a:font script="Hang" typeface="맑은 고딕"/>
+        <a:font script="Hans" typeface="等线 Light"/>
+        <a:font script="Hant" typeface="新細明體"/>
+        <a:font script="Arab" typeface="Times New Roman"/>
+        <a:font script="Hebr" typeface="Times New Roman"/>
+        <a:font script="Thai" typeface="Angsana New"/>
+        <a:font script="Ethi" typeface="Nyala"/>
+        <a:font script="Beng" typeface="Vrinda"/>
+        <a:font script="Gujr" typeface="Shruti"/>
+        <a:font script="Khmr" typeface="MoolBoran"/>
+        <a:font script="Knda" typeface="Tunga"/>
+        <a:font script="Guru" typeface="Raavi"/>
+        <a:font script="Cans" typeface="Euphemia"/>
+        <a:font script="Cher" typeface="Plantagenet Cherokee"/>
+        <a:font script="Yiii" typeface="Microsoft Yi Baiti"/>
+        <a:font script="Tibt" typeface="Microsoft Himalaya"/>
+        <a:font script="Thaa" typeface="MV Boli"/>
+        <a:font script="Deva" typeface="Mangal"/>
+        <a:font script="Telu" typeface="Gautami"/>
+        <a:font script="Taml" typeface="Latha"/>
+        <a:font script="Syrc" typeface="Estrangelo Edessa"/>
+        <a:font script="Orya" typeface="Kalinga"/>
+        <a:font script="Mlym" typeface="Kartika"/>
+        <a:font script="Laoo" typeface="DokChampa"/>
+        <a:font script="Sinh" typeface="Iskoola Pota"/>
+        <a:font script="Mong" typeface="Mongolian Baiti"/>
+        <a:font script="Viet" typeface="Times New Roman"/>
+        <a:font script="Uigh" typeface="Microsoft Uighur"/>
+        <a:font script="Geor" typeface="Sylfaen"/>
+        <a:font script="Armn" typeface="Arial"/>
+        <a:font script="Bugi" typeface="Leelawadee UI"/>
+        <a:font script="Bopo" typeface="Microsoft JhengHei"/>
+        <a:font script="Java" typeface="Javanese Text"/>
+        <a:font script="Lisu" typeface="Segoe UI"/>
+        <a:font script="Mymr" typeface="Myanmar Text"/>
+        <a:font script="Nkoo" typeface="Ebrima"/>
+        <a:font script="Olck" typeface="Nirmala UI"/>
+        <a:font script="Osma" typeface="Ebrima"/>
+        <a:font script="Phag" typeface="Phagspa"/>
+        <a:font script="Syrn" typeface="Estrangelo Edessa"/>
+        <a:font script="Syrj" typeface="Estrangelo Edessa"/>
+        <a:font script="Syre" typeface="Estrangelo Edessa"/>
+        <a:font script="Sora" typeface="Nirmala UI"/>
+        <a:font script="Tale" typeface="Microsoft Tai Le"/>
+        <a:font script="Talu" typeface="Microsoft New Tai Lue"/>
+        <a:font script="Tfng" typeface="Ebrima"/>
+      </a:majorFont>
+      <a:minorFont>
+        <a:latin typeface="Aptos" panose="02110004020202020204"/>
+        <a:ea typeface=""/>
+        <a:cs typeface=""/>
+        <a:font script="Jpan" typeface="游ゴシック"/>
+        <a:font script="Hang" typeface="맑은 고딕"/>
+        <a:font script="Hans" typeface="等线"/>
+        <a:font script="Hant" typeface="新細明體"/>
+        <a:font script="Arab" typeface="Arial"/>
+        <a:font script="Hebr" typeface="Arial"/>
+        <a:font script="Thai" typeface="Cordia New"/>
+        <a:font script="Ethi" typeface="Nyala"/>
+        <a:font script="Beng" typeface="Vrinda"/>
+        <a:font script="Gujr" typeface="Shruti"/>
+        <a:font script="Khmr" typeface="DaunPenh"/>
+        <a:font script="Knda" typeface="Tunga"/>
+        <a:font script="Guru" typeface="Raavi"/>
+        <a:font script="Cans" typeface="Euphemia"/>
+        <a:font script="Cher" typeface="Plantagenet Cherokee"/>
+        <a:font script="Yiii" typeface="Microsoft Yi Baiti"/>
+        <a:font script="Tibt" typeface="Microsoft Himalaya"/>
+        <a:font script="Thaa" typeface="MV Boli"/>
+        <a:font script="Deva" typeface="Mangal"/>
+        <a:font script="Telu" typeface="Gautami"/>
+        <a:font script="Taml" typeface="Latha"/>
+        <a:font script="Syrc" typeface="Estrangelo Edessa"/>
+        <a:font script="Orya" typeface="Kalinga"/>
+        <a:font script="Mlym" typeface="Kartika"/>
+        <a:font script="Laoo" typeface="DokChampa"/>
+        <a:font script="Sinh" typeface="Iskoola Pota"/>
+        <a:font script="Mong" typeface="Mongolian Baiti"/>
+        <a:font script="Viet" typeface="Arial"/>
+        <a:font script="Uigh" typeface="Microsoft Uighur"/>
+        <a:font script="Geor" typeface="Sylfaen"/>
+        <a:font script="Armn" typeface="Arial"/>
+        <a:font script="Bugi" typeface="Leelawadee UI"/>
+        <a:font script="Bopo" typeface="Microsoft JhengHei"/>
+        <a:font script="Java" typeface="Javanese Text"/>
+        <a:font script="Lisu" typeface="Segoe UI"/>
+        <a:font script="Mymr" typeface="Myanmar Text"/>
+        <a:font script="Nkoo" typeface="Ebrima"/>
+        <a:font script="Olck" typeface="Nirmala UI"/>
+        <a:font script="Osma" typeface="Ebrima"/>
+        <a:font script="Phag" typeface="Phagspa"/>
+        <a:font script="Syrn" typeface="Estrangelo Edessa"/>
+        <a:font script="Syrj" typeface="Estrangelo Edessa"/>
+        <a:font script="Syre" typeface="Estrangelo Edessa"/>
+        <a:font script="Sora" typeface="Nirmala UI"/>
+        <a:font script="Tale" typeface="Microsoft Tai Le"/>
+        <a:font script="Talu" typeface="Microsoft New Tai Lue"/>
+        <a:font script="Tfng" typeface="Ebrima"/>
+      </a:minorFont>
+    </a:fontScheme>
+    <a:fmtScheme name="Office">
+      <a:fillStyleLst>
+        <a:solidFill>
+          <a:schemeClr val="phClr"/>
+        </a:solidFill>
+        <a:gradFill rotWithShape="1">
+          <a:gsLst>
+            <a:gs pos="0">
+              <a:schemeClr val="phClr">
+                <a:lumMod val="110000"/>
+                <a:satMod val="105000"/>
+                <a:tint val="67000"/>
+              </a:schemeClr>
+            </a:gs>
+            <a:gs pos="50000">
+              <a:schemeClr val="phClr">
+                <a:lumMod val="105000"/>
+                <a:satMod val="103000"/>
+                <a:tint val="73000"/>
+              </a:schemeClr>
+            </a:gs>
+            <a:gs pos="100000">
+              <a:schemeClr val="phClr">
+                <a:lumMod val="105000"/>
+                <a:satMod val="109000"/>
+                <a:tint val="81000"/>
+              </a:schemeClr>
+            </a:gs>
+          </a:gsLst>
+          <a:lin ang="5400000" scaled="0"/>
+        </a:gradFill>
+        <a:gradFill rotWithShape="1">
+          <a:gsLst>
+            <a:gs pos="0">
+              <a:schemeClr val="phClr">
+                <a:satMod val="103000"/>
+                <a:lumMod val="102000"/>
+                <a:tint val="94000"/>
+              </a:schemeClr>
+            </a:gs>
+            <a:gs pos="50000">
+              <a:schemeClr val="phClr">
+                <a:satMod val="110000"/>
+                <a:lumMod val="100000"/>
+                <a:shade val="100000"/>
+              </a:schemeClr>
+            </a:gs>
+            <a:gs pos="100000">
+              <a:schemeClr val="phClr">
+                <a:lumMod val="99000"/>
+                <a:satMod val="120000"/>
+                <a:shade val="78000"/>
+              </a:schemeClr>
+            </a:gs>
+          </a:gsLst>
+          <a:lin ang="5400000" scaled="0"/>
+        </a:gradFill>
+      </a:fillStyleLst>
+      <a:lnStyleLst>
+        <a:ln w="12700" cap="flat" cmpd="sng" algn="ctr">
+          <a:solidFill>
+            <a:schemeClr val="phClr"/>
+          </a:solidFill>
+          <a:prstDash val="solid"/>
+          <a:miter lim="800000"/>
+        </a:ln>
+        <a:ln w="19050" cap="flat" cmpd="sng" algn="ctr">
+          <a:solidFill>
+            <a:schemeClr val="phClr"/>
+          </a:solidFill>
+          <a:prstDash val="solid"/>
+          <a:miter lim="800000"/>
+        </a:ln>
+        <a:ln w="25400" cap="flat" cmpd="sng" algn="ctr">
+          <a:solidFill>
+            <a:schemeClr val="phClr"/>
+          </a:solidFill>
+          <a:prstDash val="solid"/>
+          <a:miter lim="800000"/>
+        </a:ln>
+      </a:lnStyleLst>
+      <a:effectStyleLst>
+        <a:effectStyle>
+          <a:effectLst/>
+        </a:effectStyle>
+        <a:effectStyle>
+          <a:effectLst/>
+        </a:effectStyle>
+        <a:effectStyle>
+          <a:effectLst>
+            <a:outerShdw blurRad="57150" dist="19050" dir="5400000" algn="ctr" rotWithShape="0">
+              <a:srgbClr val="000000">
+                <a:alpha val="63000"/>
+              </a:srgbClr>
+            </a:outerShdw>
+          </a:effectLst>
+        </a:effectStyle>
+      </a:effectStyleLst>
+      <a:bgFillStyleLst>
+        <a:solidFill>
+          <a:schemeClr val="phClr"/>
+        </a:solidFill>
+        <a:solidFill>
+          <a:schemeClr val="phClr">
+            <a:tint val="95000"/>
+            <a:satMod val="170000"/>
+          </a:schemeClr>
+        </a:solidFill>
+        <a:gradFill rotWithShape="1">
+          <a:gsLst>
+            <a:gs pos="0">
+              <a:schemeClr val="phClr">
+                <a:tint val="93000"/>
+                <a:satMod val="150000"/>
+                <a:shade val="98000"/>
+                <a:lumMod val="102000"/>
+              </a:schemeClr>
+            </a:gs>
+            <a:gs pos="50000">
+              <a:schemeClr val="phClr">
+                <a:tint val="98000"/>
+                <a:satMod val="130000"/>
+                <a:shade val="90000"/>
+                <a:lumMod val="103000"/>
+              </a:schemeClr>
+            </a:gs>
+            <a:gs pos="100000">
+              <a:schemeClr val="phClr">
+                <a:shade val="63000"/>
+                <a:satMod val="120000"/>
+              </a:schemeClr>
+            </a:gs>
+          </a:gsLst>
+          <a:lin ang="5400000" scaled="0"/>
+        </a:gradFill>
+      </a:bgFillStyleLst>
+    </a:fmtScheme>
+  </a:themeElements>
+  <a:objectDefaults>
+    <a:lnDef>
+      <a:spPr/>
+      <a:bodyPr/>
+      <a:lstStyle/>
+      <a:style>
+        <a:lnRef idx="2">
+          <a:schemeClr val="accent1"/>
+        </a:lnRef>
+        <a:fillRef idx="0">
+          <a:schemeClr val="accent1"/>
+        </a:fillRef>
+        <a:effectRef idx="1">
+          <a:schemeClr val="accent1"/>
+        </a:effectRef>
+        <a:fontRef idx="minor">
+          <a:schemeClr val="tx1"/>
+        </a:fontRef>
+      </a:style>
+    </a:lnDef>
+  </a:objectDefaults>
+  <a:extraClrSchemeLst/>
+  <a:extLst>
+    <a:ext uri="{05A4C25C-085E-4340-85A3-A5531E510DB2}">
+      <thm15:themeFamily xmlns:thm15="http://schemas.microsoft.com/office/thememl/2012/main" name="Office Theme" id="{2E142A2C-CD16-42D6-873A-C26D2A0506FA}" vid="{1BDDFF52-6CD6-40A5-AB3C-68EB2F1E4D0A}"/>
+    </a:ext>
+  </a:extLst>
+</a:theme>
 </file>
</xml_diff>

<commit_message>
Integra slide 6 completado por María · Reducción de dimensionalidad con MI + XGBoost
</commit_message>
<xml_diff>
--- a/presentacion/Presentacion_Grupo7_Final.pptx
+++ b/presentacion/Presentacion_Grupo7_Final.pptx
@@ -5105,212 +5105,6 @@
       </p:sp>
       <p:sp>
         <p:nvSpPr>
-          <p:cNvPr id="7" name="Text 5"/>
-          <p:cNvSpPr/>
-          <p:nvPr/>
-        </p:nvSpPr>
-        <p:spPr>
-          <a:xfrm>
-            <a:off x="365760" y="1097280"/>
-            <a:ext cx="8412480" cy="365760"/>
-          </a:xfrm>
-          <a:prstGeom prst="rect">
-            <a:avLst/>
-          </a:prstGeom>
-          <a:noFill/>
-          <a:ln/>
-        </p:spPr>
-        <p:txBody>
-          <a:bodyPr wrap="square" rtlCol="0" anchor="ctr"/>
-          <a:lstStyle/>
-          <a:p>
-            <a:pPr marL="0" indent="0" algn="ctr">
-              <a:buNone/>
-            </a:pPr>
-            <a:r>
-              <a:rPr lang="en-US" sz="1100" b="1" kern="0" spc="500" dirty="0">
-                <a:solidFill>
-                  <a:srgbClr val="E67E22"/>
-                </a:solidFill>
-                <a:latin typeface="Arial" pitchFamily="34" charset="0"/>
-                <a:ea typeface="Arial" pitchFamily="34" charset="-122"/>
-                <a:cs typeface="Arial" pitchFamily="34" charset="-120"/>
-              </a:rPr>
-              <a:t>SLIDE EN CONSTRUCCIÓN · INTEGRANTE 5</a:t>
-            </a:r>
-            <a:endParaRPr lang="en-US" sz="1100" dirty="0"/>
-          </a:p>
-        </p:txBody>
-      </p:sp>
-      <p:sp>
-        <p:nvSpPr>
-          <p:cNvPr id="8" name="Text 6"/>
-          <p:cNvSpPr/>
-          <p:nvPr/>
-        </p:nvSpPr>
-        <p:spPr>
-          <a:xfrm>
-            <a:off x="731520" y="1645920"/>
-            <a:ext cx="7680960" cy="274320"/>
-          </a:xfrm>
-          <a:prstGeom prst="rect">
-            <a:avLst/>
-          </a:prstGeom>
-          <a:noFill/>
-          <a:ln/>
-        </p:spPr>
-        <p:txBody>
-          <a:bodyPr wrap="square" lIns="0" tIns="0" rIns="0" bIns="0" rtlCol="0" anchor="ctr"/>
-          <a:lstStyle/>
-          <a:p>
-            <a:pPr marL="0" indent="0">
-              <a:buNone/>
-            </a:pPr>
-            <a:r>
-              <a:rPr lang="en-US" sz="1300" b="1" dirty="0">
-                <a:solidFill>
-                  <a:srgbClr val="2C3E50"/>
-                </a:solidFill>
-                <a:latin typeface="Calibri" pitchFamily="34" charset="0"/>
-                <a:ea typeface="Calibri" pitchFamily="34" charset="-122"/>
-                <a:cs typeface="Calibri" pitchFamily="34" charset="-120"/>
-              </a:rPr>
-              <a:t>Contenido sugerido:</a:t>
-            </a:r>
-            <a:endParaRPr lang="en-US" sz="1300" dirty="0"/>
-          </a:p>
-        </p:txBody>
-      </p:sp>
-      <p:sp>
-        <p:nvSpPr>
-          <p:cNvPr id="9" name="Text 7"/>
-          <p:cNvSpPr/>
-          <p:nvPr/>
-        </p:nvSpPr>
-        <p:spPr>
-          <a:xfrm>
-            <a:off x="731520" y="2011680"/>
-            <a:ext cx="7680960" cy="2286000"/>
-          </a:xfrm>
-          <a:prstGeom prst="rect">
-            <a:avLst/>
-          </a:prstGeom>
-          <a:noFill/>
-          <a:ln/>
-        </p:spPr>
-        <p:txBody>
-          <a:bodyPr wrap="square" lIns="50800" tIns="50800" rIns="50800" bIns="50800" rtlCol="0" anchor="ctr"/>
-          <a:lstStyle/>
-          <a:p>
-            <a:pPr marL="342900" indent="-342900">
-              <a:buSzPct val="100000"/>
-              <a:buChar char="•"/>
-            </a:pPr>
-            <a:r>
-              <a:rPr lang="en-US" sz="1200" dirty="0">
-                <a:solidFill>
-                  <a:srgbClr val="2C3E50"/>
-                </a:solidFill>
-                <a:latin typeface="Calibri" pitchFamily="34" charset="0"/>
-                <a:ea typeface="Calibri" pitchFamily="34" charset="-122"/>
-                <a:cs typeface="Calibri" pitchFamily="34" charset="-120"/>
-              </a:rPr>
-              <a:t>Selección de features por filtro · Mutual Information (MI &gt; Pearson en clasificación no lineal)</a:t>
-            </a:r>
-            <a:endParaRPr lang="en-US" sz="1200" dirty="0"/>
-          </a:p>
-          <a:p>
-            <a:pPr marL="342900" indent="-342900">
-              <a:buSzPct val="100000"/>
-              <a:buChar char="•"/>
-            </a:pPr>
-            <a:r>
-              <a:rPr lang="en-US" sz="1200" dirty="0">
-                <a:solidFill>
-                  <a:srgbClr val="2C3E50"/>
-                </a:solidFill>
-                <a:latin typeface="Calibri" pitchFamily="34" charset="0"/>
-                <a:ea typeface="Calibri" pitchFamily="34" charset="-122"/>
-                <a:cs typeface="Calibri" pitchFamily="34" charset="-120"/>
-              </a:rPr>
-              <a:t>Extracción ya implementada: encoding cíclico (23→2, 11→2) y Haversine (4→1)</a:t>
-            </a:r>
-            <a:endParaRPr lang="en-US" sz="1200" dirty="0"/>
-          </a:p>
-          <a:p>
-            <a:pPr marL="342900" indent="-342900">
-              <a:buSzPct val="100000"/>
-              <a:buChar char="•"/>
-            </a:pPr>
-            <a:r>
-              <a:rPr lang="en-US" sz="1200" dirty="0">
-                <a:solidFill>
-                  <a:srgbClr val="2C3E50"/>
-                </a:solidFill>
-                <a:latin typeface="Calibri" pitchFamily="34" charset="0"/>
-                <a:ea typeface="Calibri" pitchFamily="34" charset="-122"/>
-                <a:cs typeface="Calibri" pitchFamily="34" charset="-120"/>
-              </a:rPr>
-              <a:t>Evaluación de PCA como alternativa general · 4 razones para no aplicarlo:</a:t>
-            </a:r>
-            <a:endParaRPr lang="en-US" sz="1200" dirty="0"/>
-          </a:p>
-          <a:p>
-            <a:pPr marL="0" lvl="1" indent="0">
-              <a:buNone/>
-            </a:pPr>
-            <a:r>
-              <a:rPr lang="en-US" sz="1200" dirty="0">
-                <a:solidFill>
-                  <a:srgbClr val="2C3E50"/>
-                </a:solidFill>
-                <a:latin typeface="Calibri" pitchFamily="34" charset="0"/>
-                <a:ea typeface="Calibri" pitchFamily="34" charset="-122"/>
-                <a:cs typeface="Calibri" pitchFamily="34" charset="-120"/>
-              </a:rPr>
-              <a:t>— dimensionalidad final ya baja (~16 features) · features continuas ya ortogonales</a:t>
-            </a:r>
-            <a:endParaRPr lang="en-US" sz="1200" dirty="0"/>
-          </a:p>
-          <a:p>
-            <a:pPr marL="0" lvl="1" indent="0">
-              <a:buNone/>
-            </a:pPr>
-            <a:r>
-              <a:rPr lang="en-US" sz="1200" dirty="0">
-                <a:solidFill>
-                  <a:srgbClr val="2C3E50"/>
-                </a:solidFill>
-                <a:latin typeface="Calibri" pitchFamily="34" charset="0"/>
-                <a:ea typeface="Calibri" pitchFamily="34" charset="-122"/>
-                <a:cs typeface="Calibri" pitchFamily="34" charset="-120"/>
-              </a:rPr>
-              <a:t>— binarias violan supuestos PCA · modelos de árbol downstream no se benefician</a:t>
-            </a:r>
-            <a:endParaRPr lang="en-US" sz="1200" dirty="0"/>
-          </a:p>
-          <a:p>
-            <a:pPr marL="342900" indent="-342900">
-              <a:buSzPct val="100000"/>
-              <a:buChar char="•"/>
-            </a:pPr>
-            <a:r>
-              <a:rPr lang="en-US" sz="1200" dirty="0">
-                <a:solidFill>
-                  <a:srgbClr val="2C3E50"/>
-                </a:solidFill>
-                <a:latin typeface="Calibri" pitchFamily="34" charset="0"/>
-                <a:ea typeface="Calibri" pitchFamily="34" charset="-122"/>
-                <a:cs typeface="Calibri" pitchFamily="34" charset="-120"/>
-              </a:rPr>
-              <a:t>Ventaja competitiva: extracciones con justificación de dominio preservan interpretabilidad</a:t>
-            </a:r>
-            <a:endParaRPr lang="en-US" sz="1200" dirty="0"/>
-          </a:p>
-        </p:txBody>
-      </p:sp>
-      <p:sp>
-        <p:nvSpPr>
           <p:cNvPr id="10" name="Shape 8"/>
           <p:cNvSpPr/>
           <p:nvPr/>
@@ -5375,6 +5169,142 @@
               <a:t>→  Dataset final listo: X_train.csv · X_test.csv · y_train.csv · y_test.csv.</a:t>
             </a:r>
             <a:endParaRPr lang="en-US" sz="900" dirty="0"/>
+          </a:p>
+        </p:txBody>
+      </p:sp>
+      <p:pic>
+        <p:nvPicPr>
+          <p:cNvPr id="12" name="Imagen 11">
+            <a:extLst>
+              <a:ext uri="{FF2B5EF4-FFF2-40B4-BE49-F238E27FC236}">
+                <a16:creationId xmlns:a16="http://schemas.microsoft.com/office/drawing/2014/main" id="{47943A58-38EB-DA67-8926-5ED5499C9134}"/>
+              </a:ext>
+            </a:extLst>
+          </p:cNvPr>
+          <p:cNvPicPr>
+            <a:picLocks noChangeAspect="1"/>
+          </p:cNvPicPr>
+          <p:nvPr/>
+        </p:nvPicPr>
+        <p:blipFill>
+          <a:blip r:embed="rId3"/>
+          <a:stretch>
+            <a:fillRect/>
+          </a:stretch>
+        </p:blipFill>
+        <p:spPr>
+          <a:xfrm>
+            <a:off x="231945" y="1129247"/>
+            <a:ext cx="4102161" cy="2478049"/>
+          </a:xfrm>
+          <a:prstGeom prst="rect">
+            <a:avLst/>
+          </a:prstGeom>
+        </p:spPr>
+      </p:pic>
+      <p:pic>
+        <p:nvPicPr>
+          <p:cNvPr id="13" name="Imagen 12">
+            <a:extLst>
+              <a:ext uri="{FF2B5EF4-FFF2-40B4-BE49-F238E27FC236}">
+                <a16:creationId xmlns:a16="http://schemas.microsoft.com/office/drawing/2014/main" id="{AECF9BBF-6E63-B4C3-8F29-075C60686855}"/>
+              </a:ext>
+            </a:extLst>
+          </p:cNvPr>
+          <p:cNvPicPr>
+            <a:picLocks noChangeAspect="1"/>
+          </p:cNvPicPr>
+          <p:nvPr/>
+        </p:nvPicPr>
+        <p:blipFill>
+          <a:blip r:embed="rId4"/>
+          <a:stretch>
+            <a:fillRect/>
+          </a:stretch>
+        </p:blipFill>
+        <p:spPr>
+          <a:xfrm>
+            <a:off x="4445620" y="1129247"/>
+            <a:ext cx="4282062" cy="2478049"/>
+          </a:xfrm>
+          <a:prstGeom prst="rect">
+            <a:avLst/>
+          </a:prstGeom>
+        </p:spPr>
+      </p:pic>
+      <p:sp>
+        <p:nvSpPr>
+          <p:cNvPr id="14" name="Rectángulo 13">
+            <a:extLst>
+              <a:ext uri="{FF2B5EF4-FFF2-40B4-BE49-F238E27FC236}">
+                <a16:creationId xmlns:a16="http://schemas.microsoft.com/office/drawing/2014/main" id="{AA4408F7-B9E8-AC2B-56E3-2A726170A5CF}"/>
+              </a:ext>
+            </a:extLst>
+          </p:cNvPr>
+          <p:cNvSpPr/>
+          <p:nvPr/>
+        </p:nvSpPr>
+        <p:spPr>
+          <a:xfrm>
+            <a:off x="1085385" y="3794760"/>
+            <a:ext cx="6765074" cy="524479"/>
+          </a:xfrm>
+          <a:prstGeom prst="rect">
+            <a:avLst/>
+          </a:prstGeom>
+        </p:spPr>
+        <p:style>
+          <a:lnRef idx="2">
+            <a:schemeClr val="accent5"/>
+          </a:lnRef>
+          <a:fillRef idx="1">
+            <a:schemeClr val="lt1"/>
+          </a:fillRef>
+          <a:effectRef idx="0">
+            <a:schemeClr val="accent5"/>
+          </a:effectRef>
+          <a:fontRef idx="minor">
+            <a:schemeClr val="dk1"/>
+          </a:fontRef>
+        </p:style>
+        <p:txBody>
+          <a:bodyPr rtlCol="0" anchor="ctr"/>
+          <a:lstStyle/>
+          <a:p>
+            <a:pPr algn="ctr"/>
+            <a:r>
+              <a:rPr lang="es-PE" sz="1000" b="0" dirty="0">
+                <a:solidFill>
+                  <a:srgbClr val="000000"/>
+                </a:solidFill>
+                <a:effectLst/>
+                <a:latin typeface="Arial" panose="020B0604020202020204" pitchFamily="34" charset="0"/>
+                <a:cs typeface="Arial" panose="020B0604020202020204" pitchFamily="34" charset="0"/>
+              </a:rPr>
+              <a:t>El modelo XGBoost y el MI confirma que la variable clave para predecir el tipo de viaje es la </a:t>
+            </a:r>
+            <a:r>
+              <a:rPr lang="es-PE" sz="1000" b="0" dirty="0">
+                <a:solidFill>
+                  <a:srgbClr val="800000"/>
+                </a:solidFill>
+                <a:effectLst/>
+                <a:latin typeface="Arial" panose="020B0604020202020204" pitchFamily="34" charset="0"/>
+                <a:cs typeface="Arial" panose="020B0604020202020204" pitchFamily="34" charset="0"/>
+              </a:rPr>
+              <a:t>distancia recorrida (distancia_km)</a:t>
+            </a:r>
+            <a:r>
+              <a:rPr lang="es-PE" sz="1000" b="0" dirty="0">
+                <a:solidFill>
+                  <a:srgbClr val="000000"/>
+                </a:solidFill>
+                <a:effectLst/>
+                <a:latin typeface="Arial" panose="020B0604020202020204" pitchFamily="34" charset="0"/>
+                <a:cs typeface="Arial" panose="020B0604020202020204" pitchFamily="34" charset="0"/>
+              </a:rPr>
+              <a:t>, seguida por factores temporales de alto nivel como el indicador de fin de semana.</a:t>
+            </a:r>
           </a:p>
         </p:txBody>
       </p:sp>

</xml_diff>

<commit_message>
Integra slide 4 de Federico (preprocesamiento + problema ML) · título ajustado
</commit_message>
<xml_diff>
--- a/presentacion/Presentacion_Grupo7_Final.pptx
+++ b/presentacion/Presentacion_Grupo7_Final.pptx
@@ -4145,7 +4145,7 @@
               <a:buNone/>
             </a:pPr>
             <a:r>
-              <a:rPr lang="en-US" sz="2200" b="1" dirty="0">
+              <a:rPr lang="en-US" sz="2200" b="1" dirty="0" err="1">
                 <a:solidFill>
                   <a:srgbClr val="FFFFFF"/>
                 </a:solidFill>
@@ -4153,7 +4153,40 @@
                 <a:ea typeface="Georgia" pitchFamily="34" charset="-122"/>
                 <a:cs typeface="Georgia" pitchFamily="34" charset="-120"/>
               </a:rPr>
-              <a:t>Preprocesamiento y limpieza del dataset</a:t>
+              <a:t>Preprocesamiento</a:t>
+            </a:r>
+            <a:r>
+              <a:rPr lang="en-US" sz="2200" b="1" dirty="0">
+                <a:solidFill>
+                  <a:srgbClr val="FFFFFF"/>
+                </a:solidFill>
+                <a:latin typeface="Georgia" pitchFamily="34" charset="0"/>
+                <a:ea typeface="Georgia" pitchFamily="34" charset="-122"/>
+                <a:cs typeface="Georgia" pitchFamily="34" charset="-120"/>
+              </a:rPr>
+              <a:t> y </a:t>
+            </a:r>
+            <a:r>
+              <a:rPr lang="en-US" sz="2200" b="1" dirty="0" err="1">
+                <a:solidFill>
+                  <a:srgbClr val="FFFFFF"/>
+                </a:solidFill>
+                <a:latin typeface="Georgia" pitchFamily="34" charset="0"/>
+                <a:ea typeface="Georgia" pitchFamily="34" charset="-122"/>
+                <a:cs typeface="Georgia" pitchFamily="34" charset="-120"/>
+              </a:rPr>
+              <a:t>problema</a:t>
+            </a:r>
+            <a:r>
+              <a:rPr lang="en-US" sz="2200" b="1" dirty="0">
+                <a:solidFill>
+                  <a:srgbClr val="FFFFFF"/>
+                </a:solidFill>
+                <a:latin typeface="Georgia" pitchFamily="34" charset="0"/>
+                <a:ea typeface="Georgia" pitchFamily="34" charset="-122"/>
+                <a:cs typeface="Georgia" pitchFamily="34" charset="-120"/>
+              </a:rPr>
+              <a:t> de ML</a:t>
             </a:r>
             <a:endParaRPr lang="en-US" sz="2200" dirty="0"/>
           </a:p>
@@ -4167,7 +4200,7 @@
         </p:nvSpPr>
         <p:spPr>
           <a:xfrm>
-            <a:off x="365760" y="914400"/>
+            <a:off x="365760" y="834390"/>
             <a:ext cx="8412480" cy="3657600"/>
           </a:xfrm>
           <a:prstGeom prst="rect">
@@ -4187,7 +4220,7 @@
           <a:bodyPr/>
           <a:lstStyle/>
           <a:p>
-            <a:endParaRPr lang="en-US"/>
+            <a:endParaRPr lang="en-US" dirty="0"/>
           </a:p>
         </p:txBody>
       </p:sp>
@@ -4215,17 +4248,6 @@
             <a:pPr marL="0" indent="0" algn="ctr">
               <a:buNone/>
             </a:pPr>
-            <a:r>
-              <a:rPr lang="en-US" sz="1100" b="1" kern="0" spc="500" dirty="0">
-                <a:solidFill>
-                  <a:srgbClr val="E67E22"/>
-                </a:solidFill>
-                <a:latin typeface="Arial" pitchFamily="34" charset="0"/>
-                <a:ea typeface="Arial" pitchFamily="34" charset="-122"/>
-                <a:cs typeface="Arial" pitchFamily="34" charset="-120"/>
-              </a:rPr>
-              <a:t>SLIDE EN CONSTRUCCIÓN · INTEGRANTE 3</a:t>
-            </a:r>
             <a:endParaRPr lang="en-US" sz="1100" dirty="0"/>
           </a:p>
         </p:txBody>
@@ -4238,7 +4260,7 @@
         </p:nvSpPr>
         <p:spPr>
           <a:xfrm>
-            <a:off x="731520" y="1645920"/>
+            <a:off x="731520" y="960120"/>
             <a:ext cx="7680960" cy="274320"/>
           </a:xfrm>
           <a:prstGeom prst="rect">
@@ -4255,7 +4277,7 @@
               <a:buNone/>
             </a:pPr>
             <a:r>
-              <a:rPr lang="en-US" sz="1300" b="1" dirty="0">
+              <a:rPr lang="en-US" sz="1300" b="1" dirty="0" err="1">
                 <a:solidFill>
                   <a:srgbClr val="2C3E50"/>
                 </a:solidFill>
@@ -4263,7 +4285,29 @@
                 <a:ea typeface="Calibri" pitchFamily="34" charset="-122"/>
                 <a:cs typeface="Calibri" pitchFamily="34" charset="-120"/>
               </a:rPr>
-              <a:t>Contenido sugerido:</a:t>
+              <a:t>Preprocesamiento</a:t>
+            </a:r>
+            <a:r>
+              <a:rPr lang="en-US" sz="1300" b="1" dirty="0">
+                <a:solidFill>
+                  <a:srgbClr val="2C3E50"/>
+                </a:solidFill>
+                <a:latin typeface="Calibri" pitchFamily="34" charset="0"/>
+                <a:ea typeface="Calibri" pitchFamily="34" charset="-122"/>
+                <a:cs typeface="Calibri" pitchFamily="34" charset="-120"/>
+              </a:rPr>
+              <a:t> y </a:t>
+            </a:r>
+            <a:r>
+              <a:rPr lang="en-US" sz="1300" b="1" dirty="0" err="1">
+                <a:solidFill>
+                  <a:srgbClr val="2C3E50"/>
+                </a:solidFill>
+                <a:latin typeface="Calibri" pitchFamily="34" charset="0"/>
+                <a:ea typeface="Calibri" pitchFamily="34" charset="-122"/>
+                <a:cs typeface="Calibri" pitchFamily="34" charset="-120"/>
+              </a:rPr>
+              <a:t>limpieza</a:t>
             </a:r>
             <a:endParaRPr lang="en-US" sz="1300" dirty="0"/>
           </a:p>
@@ -4277,8 +4321,8 @@
         </p:nvSpPr>
         <p:spPr>
           <a:xfrm>
-            <a:off x="731520" y="2011680"/>
-            <a:ext cx="7680960" cy="2286000"/>
+            <a:off x="731520" y="1168838"/>
+            <a:ext cx="7680960" cy="1654372"/>
           </a:xfrm>
           <a:prstGeom prst="rect">
             <a:avLst/>
@@ -4289,94 +4333,107 @@
         <p:txBody>
           <a:bodyPr wrap="square" lIns="50800" tIns="50800" rIns="50800" bIns="50800" rtlCol="0" anchor="ctr"/>
           <a:lstStyle/>
+          <a:p>
+            <a:pPr marL="171450" indent="-171450">
+              <a:buFont typeface="Arial" panose="020B0604020202020204" pitchFamily="34" charset="0"/>
+              <a:buChar char="•"/>
+            </a:pPr>
+            <a:r>
+              <a:rPr lang="es-AR" sz="1200" dirty="0"/>
+              <a:t>El CSV tenía problemas estructurales: fila de título extra y </a:t>
+            </a:r>
+            <a:r>
+              <a:rPr lang="es-AR" sz="1200" dirty="0" err="1"/>
+              <a:t>headers</a:t>
+            </a:r>
+            <a:r>
+              <a:rPr lang="es-AR" sz="1200" dirty="0"/>
+              <a:t> con punto y coma. Resolvimos manualmente</a:t>
+            </a:r>
+          </a:p>
+          <a:p>
+            <a:pPr marL="171450" indent="-171450">
+              <a:buFont typeface="Arial" panose="020B0604020202020204" pitchFamily="34" charset="0"/>
+              <a:buChar char="•"/>
+            </a:pPr>
+            <a:r>
+              <a:rPr lang="es-AR" sz="1200" dirty="0"/>
+              <a:t>Para </a:t>
+            </a:r>
+            <a:r>
+              <a:rPr lang="es-AR" sz="1200" dirty="0" err="1"/>
+              <a:t>outliers</a:t>
+            </a:r>
+            <a:r>
+              <a:rPr lang="es-AR" sz="1200" dirty="0"/>
+              <a:t> de duración usamos un </a:t>
+            </a:r>
+            <a:r>
+              <a:rPr lang="es-AR" sz="1200" b="1" dirty="0"/>
+              <a:t>criterio de dominio</a:t>
+            </a:r>
+            <a:r>
+              <a:rPr lang="es-AR" sz="1200" dirty="0"/>
+              <a:t>: descartamos viajes &lt; 30 segundos y &gt; 24 horas. Eliminó 8% de los registros</a:t>
+            </a:r>
+          </a:p>
+          <a:p>
+            <a:pPr marL="171450" indent="-171450">
+              <a:buFont typeface="Arial" panose="020B0604020202020204" pitchFamily="34" charset="0"/>
+              <a:buChar char="•"/>
+            </a:pPr>
+            <a:r>
+              <a:rPr lang="es-AR" sz="1200" dirty="0"/>
+              <a:t>Los nulos en genero (0.34%) se clasificaron como </a:t>
+            </a:r>
+            <a:r>
+              <a:rPr lang="es-AR" sz="1200" b="1" dirty="0"/>
+              <a:t>MNAR</a:t>
+            </a:r>
+            <a:r>
+              <a:rPr lang="es-AR" sz="1200" dirty="0"/>
+              <a:t>: usuarios que eligieron no declarar su género. Imputar hubiera introducido sesgo → se eliminaron las filas</a:t>
+            </a:r>
+          </a:p>
+          <a:p>
+            <a:pPr marL="171450" indent="-171450">
+              <a:buFont typeface="Arial" panose="020B0604020202020204" pitchFamily="34" charset="0"/>
+              <a:buChar char="•"/>
+            </a:pPr>
+            <a:r>
+              <a:rPr lang="es-AR" sz="1200" dirty="0"/>
+              <a:t>Split </a:t>
+            </a:r>
+            <a:r>
+              <a:rPr lang="es-AR" sz="1200" b="1" dirty="0"/>
+              <a:t>70/30 con </a:t>
+            </a:r>
+            <a:r>
+              <a:rPr lang="es-AR" sz="1200" b="1" dirty="0" err="1"/>
+              <a:t>stratify</a:t>
+            </a:r>
+            <a:r>
+              <a:rPr lang="es-AR" sz="1200" b="1" dirty="0"/>
+              <a:t>=y</a:t>
+            </a:r>
+            <a:r>
+              <a:rPr lang="es-AR" sz="1200" dirty="0"/>
+              <a:t> para garantizar la misma proporción de clases en </a:t>
+            </a:r>
+            <a:r>
+              <a:rPr lang="es-AR" sz="1200" dirty="0" err="1"/>
+              <a:t>train</a:t>
+            </a:r>
+            <a:r>
+              <a:rPr lang="es-AR" sz="1200" dirty="0"/>
+              <a:t> y test</a:t>
+            </a:r>
+          </a:p>
           <a:p>
             <a:pPr marL="342900" indent="-342900">
               <a:buSzPct val="100000"/>
               <a:buChar char="•"/>
             </a:pPr>
-            <a:r>
-              <a:rPr lang="en-US" sz="1200" dirty="0">
-                <a:solidFill>
-                  <a:srgbClr val="2C3E50"/>
-                </a:solidFill>
-                <a:latin typeface="Calibri" pitchFamily="34" charset="0"/>
-                <a:ea typeface="Calibri" pitchFamily="34" charset="-122"/>
-                <a:cs typeface="Calibri" pitchFamily="34" charset="-120"/>
-              </a:rPr>
-              <a:t>Criterio de limpieza por dominio (30 s &lt; duración &lt; 24 h) vs IQR/Winsor evaluados</a:t>
-            </a:r>
-            <a:endParaRPr lang="en-US" sz="1200" dirty="0"/>
-          </a:p>
-          <a:p>
-            <a:pPr marL="342900" indent="-342900">
-              <a:buSzPct val="100000"/>
-              <a:buChar char="•"/>
-            </a:pPr>
-            <a:r>
-              <a:rPr lang="en-US" sz="1200" dirty="0">
-                <a:solidFill>
-                  <a:srgbClr val="2C3E50"/>
-                </a:solidFill>
-                <a:latin typeface="Calibri" pitchFamily="34" charset="0"/>
-                <a:ea typeface="Calibri" pitchFamily="34" charset="-122"/>
-                <a:cs typeface="Calibri" pitchFamily="34" charset="-120"/>
-              </a:rPr>
-              <a:t>Tratamiento de faltantes: eliminación de MNAR (género) · decisión sobre fecha_destino (MAR · leakage)</a:t>
-            </a:r>
-            <a:endParaRPr lang="en-US" sz="1200" dirty="0"/>
-          </a:p>
-          <a:p>
-            <a:pPr marL="342900" indent="-342900">
-              <a:buSzPct val="100000"/>
-              <a:buChar char="•"/>
-            </a:pPr>
-            <a:r>
-              <a:rPr lang="en-US" sz="1200" dirty="0">
-                <a:solidFill>
-                  <a:srgbClr val="2C3E50"/>
-                </a:solidFill>
-                <a:latin typeface="Calibri" pitchFamily="34" charset="0"/>
-                <a:ea typeface="Calibri" pitchFamily="34" charset="-122"/>
-                <a:cs typeface="Calibri" pitchFamily="34" charset="-120"/>
-              </a:rPr>
-              <a:t>Split 70/30 estratificado (stratify=y · random_state=42)</a:t>
-            </a:r>
-            <a:endParaRPr lang="en-US" sz="1200" dirty="0"/>
-          </a:p>
-          <a:p>
-            <a:pPr marL="342900" indent="-342900">
-              <a:buSzPct val="100000"/>
-              <a:buChar char="•"/>
-            </a:pPr>
-            <a:r>
-              <a:rPr lang="en-US" sz="1200" dirty="0">
-                <a:solidFill>
-                  <a:srgbClr val="2C3E50"/>
-                </a:solidFill>
-                <a:latin typeface="Calibri" pitchFamily="34" charset="0"/>
-                <a:ea typeface="Calibri" pitchFamily="34" charset="-122"/>
-                <a:cs typeface="Calibri" pitchFamily="34" charset="-120"/>
-              </a:rPr>
-              <a:t>Escalado con StandardScaler · fit solo en train para evitar data leakage</a:t>
-            </a:r>
-            <a:endParaRPr lang="en-US" sz="1200" dirty="0"/>
-          </a:p>
-          <a:p>
-            <a:pPr marL="342900" indent="-342900">
-              <a:buSzPct val="100000"/>
-              <a:buChar char="•"/>
-            </a:pPr>
-            <a:r>
-              <a:rPr lang="en-US" sz="1200" dirty="0">
-                <a:solidFill>
-                  <a:srgbClr val="2C3E50"/>
-                </a:solidFill>
-                <a:latin typeface="Calibri" pitchFamily="34" charset="0"/>
-                <a:ea typeface="Calibri" pitchFamily="34" charset="-122"/>
-                <a:cs typeface="Calibri" pitchFamily="34" charset="-120"/>
-              </a:rPr>
-              <a:t>Boxplot comparativo antes/después del filtro como evidencia visual</a:t>
-            </a:r>
             <a:endParaRPr lang="en-US" sz="1200" dirty="0"/>
           </a:p>
         </p:txBody>
@@ -4447,6 +4504,224 @@
               <a:t>→  Dataset limpio y splitado listo para ingeniería de features.</a:t>
             </a:r>
             <a:endParaRPr lang="en-US" sz="900" dirty="0"/>
+          </a:p>
+        </p:txBody>
+      </p:sp>
+      <p:sp>
+        <p:nvSpPr>
+          <p:cNvPr id="12" name="Text 6">
+            <a:extLst>
+              <a:ext uri="{FF2B5EF4-FFF2-40B4-BE49-F238E27FC236}">
+                <a16:creationId xmlns:a16="http://schemas.microsoft.com/office/drawing/2014/main" id="{5B577262-B372-8843-DE3C-6A494D213094}"/>
+              </a:ext>
+            </a:extLst>
+          </p:cNvPr>
+          <p:cNvSpPr/>
+          <p:nvPr/>
+        </p:nvSpPr>
+        <p:spPr>
+          <a:xfrm>
+            <a:off x="731520" y="2526030"/>
+            <a:ext cx="7680960" cy="274320"/>
+          </a:xfrm>
+          <a:prstGeom prst="rect">
+            <a:avLst/>
+          </a:prstGeom>
+          <a:noFill/>
+          <a:ln/>
+        </p:spPr>
+        <p:txBody>
+          <a:bodyPr wrap="square" lIns="0" tIns="0" rIns="0" bIns="0" rtlCol="0" anchor="ctr"/>
+          <a:lstStyle/>
+          <a:p>
+            <a:pPr marL="0" indent="0" algn="r">
+              <a:buNone/>
+            </a:pPr>
+            <a:r>
+              <a:rPr lang="en-US" sz="1300" b="1" dirty="0" err="1">
+                <a:solidFill>
+                  <a:srgbClr val="2C3E50"/>
+                </a:solidFill>
+                <a:latin typeface="Calibri" pitchFamily="34" charset="0"/>
+                <a:ea typeface="Calibri" pitchFamily="34" charset="-122"/>
+                <a:cs typeface="Calibri" pitchFamily="34" charset="-120"/>
+              </a:rPr>
+              <a:t>Problema</a:t>
+            </a:r>
+            <a:r>
+              <a:rPr lang="en-US" sz="1300" b="1" dirty="0">
+                <a:solidFill>
+                  <a:srgbClr val="2C3E50"/>
+                </a:solidFill>
+                <a:latin typeface="Calibri" pitchFamily="34" charset="0"/>
+                <a:ea typeface="Calibri" pitchFamily="34" charset="-122"/>
+                <a:cs typeface="Calibri" pitchFamily="34" charset="-120"/>
+              </a:rPr>
+              <a:t> de Machine Learning</a:t>
+            </a:r>
+            <a:endParaRPr lang="en-US" sz="1300" dirty="0"/>
+          </a:p>
+        </p:txBody>
+      </p:sp>
+      <p:sp>
+        <p:nvSpPr>
+          <p:cNvPr id="13" name="Text 7">
+            <a:extLst>
+              <a:ext uri="{FF2B5EF4-FFF2-40B4-BE49-F238E27FC236}">
+                <a16:creationId xmlns:a16="http://schemas.microsoft.com/office/drawing/2014/main" id="{FA23F4A1-D290-5F79-1EC2-C9F4DB5342B7}"/>
+              </a:ext>
+            </a:extLst>
+          </p:cNvPr>
+          <p:cNvSpPr/>
+          <p:nvPr/>
+        </p:nvSpPr>
+        <p:spPr>
+          <a:xfrm>
+            <a:off x="768096" y="2781908"/>
+            <a:ext cx="7680960" cy="1654372"/>
+          </a:xfrm>
+          <a:prstGeom prst="rect">
+            <a:avLst/>
+          </a:prstGeom>
+          <a:noFill/>
+          <a:ln/>
+        </p:spPr>
+        <p:txBody>
+          <a:bodyPr wrap="square" lIns="50800" tIns="50800" rIns="50800" bIns="50800" rtlCol="0" anchor="ctr"/>
+          <a:lstStyle/>
+          <a:p>
+            <a:pPr marL="171450" indent="-171450">
+              <a:buFont typeface="Arial" panose="020B0604020202020204" pitchFamily="34" charset="0"/>
+              <a:buChar char="•"/>
+            </a:pPr>
+            <a:endParaRPr lang="en-US" sz="1200" dirty="0"/>
+          </a:p>
+        </p:txBody>
+      </p:sp>
+      <p:sp>
+        <p:nvSpPr>
+          <p:cNvPr id="14" name="Text 7">
+            <a:extLst>
+              <a:ext uri="{FF2B5EF4-FFF2-40B4-BE49-F238E27FC236}">
+                <a16:creationId xmlns:a16="http://schemas.microsoft.com/office/drawing/2014/main" id="{7C6ECD7D-E07B-7E12-0B8E-C8DEA457E1BE}"/>
+              </a:ext>
+            </a:extLst>
+          </p:cNvPr>
+          <p:cNvSpPr/>
+          <p:nvPr/>
+        </p:nvSpPr>
+        <p:spPr>
+          <a:xfrm>
+            <a:off x="731520" y="2755686"/>
+            <a:ext cx="7680960" cy="1654372"/>
+          </a:xfrm>
+          <a:prstGeom prst="rect">
+            <a:avLst/>
+          </a:prstGeom>
+          <a:noFill/>
+          <a:ln/>
+        </p:spPr>
+        <p:txBody>
+          <a:bodyPr wrap="square" lIns="50800" tIns="50800" rIns="50800" bIns="50800" rtlCol="0" anchor="ctr"/>
+          <a:lstStyle/>
+          <a:p>
+            <a:pPr marL="171450" indent="-171450">
+              <a:buFont typeface="Arial" panose="020B0604020202020204" pitchFamily="34" charset="0"/>
+              <a:buChar char="•"/>
+            </a:pPr>
+            <a:r>
+              <a:rPr lang="es-AR" sz="1200" dirty="0"/>
+              <a:t>Planteamos un problema de </a:t>
+            </a:r>
+            <a:r>
+              <a:rPr lang="es-AR" sz="1200" b="1" dirty="0"/>
+              <a:t>clasificación multiclase supervisada</a:t>
+            </a:r>
+            <a:r>
+              <a:rPr lang="es-AR" sz="1200" dirty="0"/>
+              <a:t>: predecir la categoría de duración de un viaje antes de que comience</a:t>
+            </a:r>
+          </a:p>
+          <a:p>
+            <a:pPr marL="171450" indent="-171450">
+              <a:buFont typeface="Arial" panose="020B0604020202020204" pitchFamily="34" charset="0"/>
+              <a:buChar char="•"/>
+            </a:pPr>
+            <a:r>
+              <a:rPr lang="es-AR" sz="1200" dirty="0"/>
+              <a:t>Tiene sentido operativo real: el sistema puede anticipar si el viaje cae dentro del período gratuito (≤ 30 min)</a:t>
+            </a:r>
+          </a:p>
+          <a:p>
+            <a:pPr marL="171450" indent="-171450">
+              <a:buFont typeface="Arial" panose="020B0604020202020204" pitchFamily="34" charset="0"/>
+              <a:buChar char="•"/>
+            </a:pPr>
+            <a:r>
+              <a:rPr lang="es-AR" sz="1200" dirty="0"/>
+              <a:t>La variable target es </a:t>
+            </a:r>
+            <a:r>
+              <a:rPr lang="es-AR" sz="1200" b="1" dirty="0" err="1"/>
+              <a:t>tipo_viaje</a:t>
+            </a:r>
+            <a:r>
+              <a:rPr lang="es-AR" sz="1200" dirty="0"/>
+              <a:t>, creada discretizando la duración en tres clases: </a:t>
+            </a:r>
+            <a:r>
+              <a:rPr lang="es-AR" sz="1200" b="1" dirty="0"/>
+              <a:t>Corto</a:t>
+            </a:r>
+            <a:r>
+              <a:rPr lang="es-AR" sz="1200" dirty="0"/>
+              <a:t> (&lt; 10 min), </a:t>
+            </a:r>
+            <a:r>
+              <a:rPr lang="es-AR" sz="1200" b="1" dirty="0"/>
+              <a:t>Medio</a:t>
+            </a:r>
+            <a:r>
+              <a:rPr lang="es-AR" sz="1200" dirty="0"/>
+              <a:t> (10–30 min) y </a:t>
+            </a:r>
+            <a:r>
+              <a:rPr lang="es-AR" sz="1200" b="1" dirty="0"/>
+              <a:t>Largo</a:t>
+            </a:r>
+            <a:r>
+              <a:rPr lang="es-AR" sz="1200" dirty="0"/>
+              <a:t> (&gt; 30 min)</a:t>
+            </a:r>
+          </a:p>
+          <a:p>
+            <a:pPr marL="171450" indent="-171450">
+              <a:buFont typeface="Arial" panose="020B0604020202020204" pitchFamily="34" charset="0"/>
+              <a:buChar char="•"/>
+            </a:pPr>
+            <a:r>
+              <a:rPr lang="es-AR" sz="1200" dirty="0"/>
+              <a:t>Elegimos clasificación sobre regresión porque la distribución de duración es fuertemente asimétrica — predecir la categoría es más robusto y más útil en la práctica y nos da fácil interpretabilidad.</a:t>
+            </a:r>
+          </a:p>
+          <a:p>
+            <a:pPr marL="171450" indent="-171450">
+              <a:buFont typeface="Arial" panose="020B0604020202020204" pitchFamily="34" charset="0"/>
+              <a:buChar char="•"/>
+            </a:pPr>
+            <a:r>
+              <a:rPr lang="es-AR" sz="1200" dirty="0"/>
+              <a:t>Este problema se puede utilizar para Stock de bicis por Estacion, Sistema de </a:t>
+            </a:r>
+            <a:r>
+              <a:rPr lang="es-AR" sz="1200" dirty="0" err="1"/>
+              <a:t>pricing</a:t>
+            </a:r>
+            <a:r>
+              <a:rPr lang="es-AR" sz="1200" dirty="0"/>
+              <a:t>, Congestión de trafico, etc.</a:t>
+            </a:r>
+            <a:endParaRPr lang="en-US" sz="1200" dirty="0"/>
           </a:p>
         </p:txBody>
       </p:sp>

</xml_diff>

<commit_message>
Integra slide 5 (Feature Engineering) de Carmen · finaliza pptx con 6 slides
- Slide 5 · Carmen completa Feature Engineering: 6 gráficos (histograma por tipo, CDF distancia, encoding cíclico hora y mes, tabla X_train, distribución de clases) + 5 razones del no-rebalanceo (stratify + class_weight)
- Slide 4 · Carmen agrega barplot 'Distribución de clases — Train' como evidencia visual del balance
- Slide 4 · título restaurado a versión corta 'Preprocesamiento y problema de ML'
- Slide 6 duplicado (placeholder Feature Engineering) eliminado
- Slide 7 (Cierre placeholder) eliminado
- Resultado: 6 slides completos · autorizado por la docente
</commit_message>
<xml_diff>
--- a/presentacion/Presentacion_Grupo7_Final.pptx
+++ b/presentacion/Presentacion_Grupo7_Final.pptx
@@ -5,7 +5,7 @@
     <p:sldMasterId id="2147483648" r:id="rId1"/>
   </p:sldMasterIdLst>
   <p:notesMasterIdLst>
-    <p:notesMasterId r:id="rId9"/>
+    <p:notesMasterId r:id="rId10"/>
   </p:notesMasterIdLst>
   <p:sldIdLst>
     <p:sldId id="256" r:id="rId2"/>
@@ -13,8 +13,7 @@
     <p:sldId id="262" r:id="rId4"/>
     <p:sldId id="258" r:id="rId5"/>
     <p:sldId id="259" r:id="rId6"/>
-    <p:sldId id="260" r:id="rId7"/>
-    <p:sldId id="261" r:id="rId8"/>
+    <p:sldId id="260" r:id="rId8"/>
   </p:sldIdLst>
   <p:sldSz cx="9144000" cy="5143500" type="screen16x9"/>
   <p:notesSz cx="5143500" cy="9144000"/>
@@ -729,90 +728,6 @@
             <a:fld id="{F7021451-1387-4CA6-816F-3879F97B5CBC}" type="slidenum">
               <a:rPr lang="en-US"/>
               <a:t>5</a:t>
-            </a:fld>
-            <a:endParaRPr lang="en-US"/>
-          </a:p>
-        </p:txBody>
-      </p:sp>
-    </p:spTree>
-    <p:extLst>
-      <p:ext uri="{BB962C8B-B14F-4D97-AF65-F5344CB8AC3E}">
-        <p14:creationId xmlns:p14="http://schemas.microsoft.com/office/powerpoint/2010/main" val="1024086991"/>
-      </p:ext>
-    </p:extLst>
-  </p:cSld>
-  <p:clrMapOvr>
-    <a:masterClrMapping/>
-  </p:clrMapOvr>
-</p:notes>
-</file>
-
-<file path=ppt/notesSlides/notesSlide6.xml><?xml version="1.0" encoding="utf-8"?>
-<p:notes xmlns:a="http://schemas.openxmlformats.org/drawingml/2006/main" xmlns:r="http://schemas.openxmlformats.org/officeDocument/2006/relationships" xmlns:p="http://schemas.openxmlformats.org/presentationml/2006/main">
-  <p:cSld>
-    <p:spTree>
-      <p:nvGrpSpPr>
-        <p:cNvPr id="1" name=""/>
-        <p:cNvGrpSpPr/>
-        <p:nvPr/>
-      </p:nvGrpSpPr>
-      <p:grpSpPr>
-        <a:xfrm>
-          <a:off x="0" y="0"/>
-          <a:ext cx="0" cy="0"/>
-          <a:chOff x="0" y="0"/>
-          <a:chExt cx="0" cy="0"/>
-        </a:xfrm>
-      </p:grpSpPr>
-      <p:sp>
-        <p:nvSpPr>
-          <p:cNvPr id="2" name="Slide Image Placeholder 1"/>
-          <p:cNvSpPr>
-            <a:spLocks noGrp="1" noRot="1" noChangeAspect="1"/>
-          </p:cNvSpPr>
-          <p:nvPr>
-            <p:ph type="sldImg"/>
-          </p:nvPr>
-        </p:nvSpPr>
-        <p:spPr/>
-      </p:sp>
-      <p:sp>
-        <p:nvSpPr>
-          <p:cNvPr id="3" name="Notes Placeholder 2"/>
-          <p:cNvSpPr>
-            <a:spLocks noGrp="1"/>
-          </p:cNvSpPr>
-          <p:nvPr>
-            <p:ph type="body" idx="1"/>
-          </p:nvPr>
-        </p:nvSpPr>
-        <p:spPr/>
-        <p:txBody>
-          <a:bodyPr/>
-          <a:lstStyle/>
-          <a:p>
-            <a:endParaRPr lang="en-US" dirty="0"/>
-          </a:p>
-        </p:txBody>
-      </p:sp>
-      <p:sp>
-        <p:nvSpPr>
-          <p:cNvPr id="4" name="Slide Number Placeholder 3"/>
-          <p:cNvSpPr>
-            <a:spLocks noGrp="1"/>
-          </p:cNvSpPr>
-          <p:nvPr>
-            <p:ph type="sldNum" sz="quarter" idx="10"/>
-          </p:nvPr>
-        </p:nvSpPr>
-        <p:spPr/>
-        <p:txBody>
-          <a:bodyPr/>
-          <a:lstStyle/>
-          <a:p>
-            <a:fld id="{F7021451-1387-4CA6-816F-3879F97B5CBC}" type="slidenum">
-              <a:rPr lang="en-US"/>
-              <a:t>6</a:t>
             </a:fld>
             <a:endParaRPr lang="en-US"/>
           </a:p>
@@ -2124,6 +2039,87 @@
           </a:p>
         </p:txBody>
       </p:sp>
+      <p:grpSp>
+        <p:nvGrpSpPr>
+          <p:cNvPr id="28" name="Grupo 27">
+            <a:extLst>
+              <a:ext uri="{FF2B5EF4-FFF2-40B4-BE49-F238E27FC236}">
+                <a16:creationId xmlns:a16="http://schemas.microsoft.com/office/drawing/2014/main" id="{446E4CB9-D61A-4B81-A0CD-5F5A7C465FF4}"/>
+              </a:ext>
+            </a:extLst>
+          </p:cNvPr>
+          <p:cNvGrpSpPr/>
+          <p:nvPr/>
+        </p:nvGrpSpPr>
+        <p:grpSpPr>
+          <a:xfrm>
+            <a:off x="5615597" y="1130300"/>
+            <a:ext cx="1585301" cy="1396174"/>
+            <a:chOff x="5615598" y="1452939"/>
+            <a:chExt cx="1073533" cy="1073533"/>
+          </a:xfrm>
+        </p:grpSpPr>
+        <p:pic>
+          <p:nvPicPr>
+            <p:cNvPr id="25" name="Imagen 24">
+              <a:extLst>
+                <a:ext uri="{FF2B5EF4-FFF2-40B4-BE49-F238E27FC236}">
+                  <a16:creationId xmlns:a16="http://schemas.microsoft.com/office/drawing/2014/main" id="{1AD7083D-39EE-4F28-B2C4-31929D212593}"/>
+                </a:ext>
+              </a:extLst>
+            </p:cNvPr>
+            <p:cNvPicPr>
+              <a:picLocks noChangeAspect="1"/>
+            </p:cNvPicPr>
+            <p:nvPr/>
+          </p:nvPicPr>
+          <p:blipFill>
+            <a:blip r:embed="rId3"/>
+            <a:stretch>
+              <a:fillRect/>
+            </a:stretch>
+          </p:blipFill>
+          <p:spPr>
+            <a:xfrm>
+              <a:off x="5615598" y="1452939"/>
+              <a:ext cx="1073533" cy="1073533"/>
+            </a:xfrm>
+            <a:prstGeom prst="rect">
+              <a:avLst/>
+            </a:prstGeom>
+          </p:spPr>
+        </p:pic>
+        <p:pic>
+          <p:nvPicPr>
+            <p:cNvPr id="27" name="Imagen 26">
+              <a:extLst>
+                <a:ext uri="{FF2B5EF4-FFF2-40B4-BE49-F238E27FC236}">
+                  <a16:creationId xmlns:a16="http://schemas.microsoft.com/office/drawing/2014/main" id="{B12BDD17-B896-47B5-B8CC-3A0DBB285CFD}"/>
+                </a:ext>
+              </a:extLst>
+            </p:cNvPr>
+            <p:cNvPicPr>
+              <a:picLocks noChangeAspect="1"/>
+            </p:cNvPicPr>
+            <p:nvPr/>
+          </p:nvPicPr>
+          <p:blipFill>
+            <a:blip r:embed="rId4"/>
+            <a:stretch>
+              <a:fillRect/>
+            </a:stretch>
+          </p:blipFill>
+          <p:spPr>
+            <a:xfrm flipV="1">
+              <a:off x="5784850" y="1869190"/>
+              <a:ext cx="519028" cy="84664"/>
+            </a:xfrm>
+            <a:prstGeom prst="rect">
+              <a:avLst/>
+            </a:prstGeom>
+          </p:spPr>
+        </p:pic>
+      </p:grpSp>
     </p:spTree>
   </p:cSld>
   <p:clrMapOvr>
@@ -4201,7 +4197,7 @@
         <p:spPr>
           <a:xfrm>
             <a:off x="365760" y="834390"/>
-            <a:ext cx="8412480" cy="3657600"/>
+            <a:ext cx="8412480" cy="3989070"/>
           </a:xfrm>
           <a:prstGeom prst="rect">
             <a:avLst/>
@@ -4612,8 +4608,8 @@
         </p:nvSpPr>
         <p:spPr>
           <a:xfrm>
-            <a:off x="731520" y="2755686"/>
-            <a:ext cx="7680960" cy="1654372"/>
+            <a:off x="768096" y="2951918"/>
+            <a:ext cx="5015230" cy="1654372"/>
           </a:xfrm>
           <a:prstGeom prst="rect">
             <a:avLst/>
@@ -4725,6 +4721,35 @@
           </a:p>
         </p:txBody>
       </p:sp>
+      <p:pic>
+        <p:nvPicPr>
+          <p:cNvPr id="15" name="Imagen 14">
+            <a:extLst>
+              <a:ext uri="{FF2B5EF4-FFF2-40B4-BE49-F238E27FC236}">
+                <a16:creationId xmlns:a16="http://schemas.microsoft.com/office/drawing/2014/main" id="{8ED72FE0-3F1E-4B97-A009-4D70E7C4635C}"/>
+              </a:ext>
+            </a:extLst>
+          </p:cNvPr>
+          <p:cNvPicPr>
+            <a:picLocks noChangeAspect="1"/>
+          </p:cNvPicPr>
+          <p:nvPr/>
+        </p:nvPicPr>
+        <p:blipFill rotWithShape="1">
+          <a:blip r:embed="rId3"/>
+          <a:srcRect t="9160" r="51477"/>
+          <a:stretch/>
+        </p:blipFill>
+        <p:spPr>
+          <a:xfrm>
+            <a:off x="6018224" y="2868464"/>
+            <a:ext cx="2723440" cy="1873499"/>
+          </a:xfrm>
+          <a:prstGeom prst="rect">
+            <a:avLst/>
+          </a:prstGeom>
+        </p:spPr>
+      </p:pic>
     </p:spTree>
   </p:cSld>
   <p:clrMapOvr>
@@ -4892,228 +4917,6 @@
       </p:sp>
       <p:sp>
         <p:nvSpPr>
-          <p:cNvPr id="6" name="Shape 4"/>
-          <p:cNvSpPr/>
-          <p:nvPr/>
-        </p:nvSpPr>
-        <p:spPr>
-          <a:xfrm>
-            <a:off x="365760" y="914400"/>
-            <a:ext cx="8412480" cy="3657600"/>
-          </a:xfrm>
-          <a:prstGeom prst="rect">
-            <a:avLst/>
-          </a:prstGeom>
-          <a:solidFill>
-            <a:srgbClr val="F5EEE0"/>
-          </a:solidFill>
-          <a:ln w="6350">
-            <a:solidFill>
-              <a:srgbClr val="E67E22"/>
-            </a:solidFill>
-            <a:prstDash val="dash"/>
-          </a:ln>
-        </p:spPr>
-        <p:txBody>
-          <a:bodyPr/>
-          <a:lstStyle/>
-          <a:p>
-            <a:endParaRPr lang="en-US"/>
-          </a:p>
-        </p:txBody>
-      </p:sp>
-      <p:sp>
-        <p:nvSpPr>
-          <p:cNvPr id="7" name="Text 5"/>
-          <p:cNvSpPr/>
-          <p:nvPr/>
-        </p:nvSpPr>
-        <p:spPr>
-          <a:xfrm>
-            <a:off x="365760" y="1097280"/>
-            <a:ext cx="8412480" cy="365760"/>
-          </a:xfrm>
-          <a:prstGeom prst="rect">
-            <a:avLst/>
-          </a:prstGeom>
-          <a:noFill/>
-          <a:ln/>
-        </p:spPr>
-        <p:txBody>
-          <a:bodyPr wrap="square" rtlCol="0" anchor="ctr"/>
-          <a:lstStyle/>
-          <a:p>
-            <a:pPr marL="0" indent="0" algn="ctr">
-              <a:buNone/>
-            </a:pPr>
-            <a:r>
-              <a:rPr lang="en-US" sz="1100" b="1" kern="0" spc="500" dirty="0">
-                <a:solidFill>
-                  <a:srgbClr val="E67E22"/>
-                </a:solidFill>
-                <a:latin typeface="Arial" pitchFamily="34" charset="0"/>
-                <a:ea typeface="Arial" pitchFamily="34" charset="-122"/>
-                <a:cs typeface="Arial" pitchFamily="34" charset="-120"/>
-              </a:rPr>
-              <a:t>SLIDE EN CONSTRUCCIÓN · INTEGRANTE 4</a:t>
-            </a:r>
-            <a:endParaRPr lang="en-US" sz="1100" dirty="0"/>
-          </a:p>
-        </p:txBody>
-      </p:sp>
-      <p:sp>
-        <p:nvSpPr>
-          <p:cNvPr id="8" name="Text 6"/>
-          <p:cNvSpPr/>
-          <p:nvPr/>
-        </p:nvSpPr>
-        <p:spPr>
-          <a:xfrm>
-            <a:off x="731520" y="1645920"/>
-            <a:ext cx="7680960" cy="274320"/>
-          </a:xfrm>
-          <a:prstGeom prst="rect">
-            <a:avLst/>
-          </a:prstGeom>
-          <a:noFill/>
-          <a:ln/>
-        </p:spPr>
-        <p:txBody>
-          <a:bodyPr wrap="square" lIns="0" tIns="0" rIns="0" bIns="0" rtlCol="0" anchor="ctr"/>
-          <a:lstStyle/>
-          <a:p>
-            <a:pPr marL="0" indent="0">
-              <a:buNone/>
-            </a:pPr>
-            <a:r>
-              <a:rPr lang="en-US" sz="1300" b="1" dirty="0">
-                <a:solidFill>
-                  <a:srgbClr val="2C3E50"/>
-                </a:solidFill>
-                <a:latin typeface="Calibri" pitchFamily="34" charset="0"/>
-                <a:ea typeface="Calibri" pitchFamily="34" charset="-122"/>
-                <a:cs typeface="Calibri" pitchFamily="34" charset="-120"/>
-              </a:rPr>
-              <a:t>Contenido sugerido:</a:t>
-            </a:r>
-            <a:endParaRPr lang="en-US" sz="1300" dirty="0"/>
-          </a:p>
-        </p:txBody>
-      </p:sp>
-      <p:sp>
-        <p:nvSpPr>
-          <p:cNvPr id="9" name="Text 7"/>
-          <p:cNvSpPr/>
-          <p:nvPr/>
-        </p:nvSpPr>
-        <p:spPr>
-          <a:xfrm>
-            <a:off x="731520" y="2011680"/>
-            <a:ext cx="7680960" cy="2286000"/>
-          </a:xfrm>
-          <a:prstGeom prst="rect">
-            <a:avLst/>
-          </a:prstGeom>
-          <a:noFill/>
-          <a:ln/>
-        </p:spPr>
-        <p:txBody>
-          <a:bodyPr wrap="square" lIns="50800" tIns="50800" rIns="50800" bIns="50800" rtlCol="0" anchor="ctr"/>
-          <a:lstStyle/>
-          <a:p>
-            <a:pPr marL="342900" indent="-342900">
-              <a:buSzPct val="100000"/>
-              <a:buChar char="•"/>
-            </a:pPr>
-            <a:r>
-              <a:rPr lang="en-US" sz="1200" dirty="0">
-                <a:solidFill>
-                  <a:srgbClr val="2C3E50"/>
-                </a:solidFill>
-                <a:latin typeface="Calibri" pitchFamily="34" charset="0"/>
-                <a:ea typeface="Calibri" pitchFamily="34" charset="-122"/>
-                <a:cs typeface="Calibri" pitchFamily="34" charset="-120"/>
-              </a:rPr>
-              <a:t>Encoding cíclico de hora y mes (sin/cos) · justificación topológica</a:t>
-            </a:r>
-            <a:endParaRPr lang="en-US" sz="1200" dirty="0"/>
-          </a:p>
-          <a:p>
-            <a:pPr marL="342900" indent="-342900">
-              <a:buSzPct val="100000"/>
-              <a:buChar char="•"/>
-            </a:pPr>
-            <a:r>
-              <a:rPr lang="en-US" sz="1200" dirty="0">
-                <a:solidFill>
-                  <a:srgbClr val="2C3E50"/>
-                </a:solidFill>
-                <a:latin typeface="Calibri" pitchFamily="34" charset="0"/>
-                <a:ea typeface="Calibri" pitchFamily="34" charset="-122"/>
-                <a:cs typeface="Calibri" pitchFamily="34" charset="-120"/>
-              </a:rPr>
-              <a:t>Distancia Haversine como síntesis geométrica de 4 coordenadas → 1 escalar interpretable</a:t>
-            </a:r>
-            <a:endParaRPr lang="en-US" sz="1200" dirty="0"/>
-          </a:p>
-          <a:p>
-            <a:pPr marL="342900" indent="-342900">
-              <a:buSzPct val="100000"/>
-              <a:buChar char="•"/>
-            </a:pPr>
-            <a:r>
-              <a:rPr lang="en-US" sz="1200" dirty="0">
-                <a:solidFill>
-                  <a:srgbClr val="2C3E50"/>
-                </a:solidFill>
-                <a:latin typeface="Calibri" pitchFamily="34" charset="0"/>
-                <a:ea typeface="Calibri" pitchFamily="34" charset="-122"/>
-                <a:cs typeface="Calibri" pitchFamily="34" charset="-120"/>
-              </a:rPr>
-              <a:t>Encoding categórico: Label (modelo_bicicleta) · One-Hot (género · día de semana)</a:t>
-            </a:r>
-            <a:endParaRPr lang="en-US" sz="1200" dirty="0"/>
-          </a:p>
-          <a:p>
-            <a:pPr marL="342900" indent="-342900">
-              <a:buSzPct val="100000"/>
-              <a:buChar char="•"/>
-            </a:pPr>
-            <a:r>
-              <a:rPr lang="en-US" sz="1200" dirty="0">
-                <a:solidFill>
-                  <a:srgbClr val="2C3E50"/>
-                </a:solidFill>
-                <a:latin typeface="Calibri" pitchFamily="34" charset="0"/>
-                <a:ea typeface="Calibri" pitchFamily="34" charset="-122"/>
-                <a:cs typeface="Calibri" pitchFamily="34" charset="-120"/>
-              </a:rPr>
-              <a:t>Discretización del target (tipo_viaje) · cortes 10 / 30 min con justificación operativa</a:t>
-            </a:r>
-            <a:endParaRPr lang="en-US" sz="1200" dirty="0"/>
-          </a:p>
-          <a:p>
-            <a:pPr marL="342900" indent="-342900">
-              <a:buSzPct val="100000"/>
-              <a:buChar char="•"/>
-            </a:pPr>
-            <a:r>
-              <a:rPr lang="en-US" sz="1200" dirty="0">
-                <a:solidFill>
-                  <a:srgbClr val="2C3E50"/>
-                </a:solidFill>
-                <a:latin typeface="Calibri" pitchFamily="34" charset="0"/>
-                <a:ea typeface="Calibri" pitchFamily="34" charset="-122"/>
-                <a:cs typeface="Calibri" pitchFamily="34" charset="-120"/>
-              </a:rPr>
-              <a:t>Balance de clases (26 / 56 / 18 %) · decisión de no rebalancear (stratify + class_weight downstream)</a:t>
-            </a:r>
-            <a:endParaRPr lang="en-US" sz="1200" dirty="0"/>
-          </a:p>
-        </p:txBody>
-      </p:sp>
-      <p:sp>
-        <p:nvSpPr>
           <p:cNvPr id="10" name="Shape 8"/>
           <p:cNvSpPr/>
           <p:nvPr/>
@@ -5178,6 +4981,1215 @@
               <a:t>→  Features construidas antes del split · ningún dato de test toca el entrenamiento.</a:t>
             </a:r>
             <a:endParaRPr lang="en-US" sz="900" dirty="0"/>
+          </a:p>
+        </p:txBody>
+      </p:sp>
+      <p:pic>
+        <p:nvPicPr>
+          <p:cNvPr id="15" name="Imagen 14">
+            <a:extLst>
+              <a:ext uri="{FF2B5EF4-FFF2-40B4-BE49-F238E27FC236}">
+                <a16:creationId xmlns:a16="http://schemas.microsoft.com/office/drawing/2014/main" id="{FAD41402-5BE4-4C2B-9C45-46EB45215E6E}"/>
+              </a:ext>
+            </a:extLst>
+          </p:cNvPr>
+          <p:cNvPicPr>
+            <a:picLocks noChangeAspect="1"/>
+          </p:cNvPicPr>
+          <p:nvPr/>
+        </p:nvPicPr>
+        <p:blipFill rotWithShape="1">
+          <a:blip r:embed="rId3"/>
+          <a:srcRect/>
+          <a:stretch/>
+        </p:blipFill>
+        <p:spPr>
+          <a:xfrm>
+            <a:off x="7751099" y="775651"/>
+            <a:ext cx="1236443" cy="1012420"/>
+          </a:xfrm>
+          <a:prstGeom prst="rect">
+            <a:avLst/>
+          </a:prstGeom>
+        </p:spPr>
+      </p:pic>
+      <p:pic>
+        <p:nvPicPr>
+          <p:cNvPr id="17" name="Imagen 16">
+            <a:extLst>
+              <a:ext uri="{FF2B5EF4-FFF2-40B4-BE49-F238E27FC236}">
+                <a16:creationId xmlns:a16="http://schemas.microsoft.com/office/drawing/2014/main" id="{01087F3C-3B71-476A-BCD0-F854413CC4E6}"/>
+              </a:ext>
+            </a:extLst>
+          </p:cNvPr>
+          <p:cNvPicPr>
+            <a:picLocks noChangeAspect="1"/>
+          </p:cNvPicPr>
+          <p:nvPr/>
+        </p:nvPicPr>
+        <p:blipFill>
+          <a:blip r:embed="rId4"/>
+          <a:stretch>
+            <a:fillRect/>
+          </a:stretch>
+        </p:blipFill>
+        <p:spPr>
+          <a:xfrm>
+            <a:off x="6599614" y="1677356"/>
+            <a:ext cx="1270900" cy="1012421"/>
+          </a:xfrm>
+          <a:prstGeom prst="rect">
+            <a:avLst/>
+          </a:prstGeom>
+        </p:spPr>
+      </p:pic>
+      <p:pic>
+        <p:nvPicPr>
+          <p:cNvPr id="22" name="Imagen 21">
+            <a:extLst>
+              <a:ext uri="{FF2B5EF4-FFF2-40B4-BE49-F238E27FC236}">
+                <a16:creationId xmlns:a16="http://schemas.microsoft.com/office/drawing/2014/main" id="{38739C48-6A15-42D8-BA49-0870FEED3F5C}"/>
+              </a:ext>
+            </a:extLst>
+          </p:cNvPr>
+          <p:cNvPicPr>
+            <a:picLocks noChangeAspect="1"/>
+          </p:cNvPicPr>
+          <p:nvPr/>
+        </p:nvPicPr>
+        <p:blipFill>
+          <a:blip r:embed="rId5"/>
+          <a:stretch>
+            <a:fillRect/>
+          </a:stretch>
+        </p:blipFill>
+        <p:spPr>
+          <a:xfrm>
+            <a:off x="179918" y="1143552"/>
+            <a:ext cx="3302022" cy="1561896"/>
+          </a:xfrm>
+          <a:prstGeom prst="rect">
+            <a:avLst/>
+          </a:prstGeom>
+        </p:spPr>
+      </p:pic>
+      <p:sp>
+        <p:nvSpPr>
+          <p:cNvPr id="24" name="CuadroTexto 23">
+            <a:extLst>
+              <a:ext uri="{FF2B5EF4-FFF2-40B4-BE49-F238E27FC236}">
+                <a16:creationId xmlns:a16="http://schemas.microsoft.com/office/drawing/2014/main" id="{051A8569-6D44-4809-8C02-40EFED890A81}"/>
+              </a:ext>
+            </a:extLst>
+          </p:cNvPr>
+          <p:cNvSpPr txBox="1"/>
+          <p:nvPr/>
+        </p:nvSpPr>
+        <p:spPr>
+          <a:xfrm>
+            <a:off x="156458" y="834726"/>
+            <a:ext cx="1802402" cy="215444"/>
+          </a:xfrm>
+          <a:prstGeom prst="rect">
+            <a:avLst/>
+          </a:prstGeom>
+          <a:noFill/>
+        </p:spPr>
+        <p:txBody>
+          <a:bodyPr wrap="square">
+            <a:spAutoFit/>
+          </a:bodyPr>
+          <a:lstStyle/>
+          <a:p>
+            <a:r>
+              <a:rPr lang="en-US" sz="800" b="1" kern="0" spc="400" dirty="0">
+                <a:solidFill>
+                  <a:srgbClr val="E67E22"/>
+                </a:solidFill>
+                <a:latin typeface="Arial" panose="020B0604020202020204" pitchFamily="34" charset="0"/>
+                <a:cs typeface="Arial" panose="020B0604020202020204" pitchFamily="34" charset="0"/>
+              </a:rPr>
+              <a:t>DISCRETIZACION</a:t>
+            </a:r>
+            <a:endParaRPr lang="es-AR" dirty="0"/>
+          </a:p>
+        </p:txBody>
+      </p:sp>
+      <p:sp>
+        <p:nvSpPr>
+          <p:cNvPr id="25" name="CuadroTexto 24">
+            <a:extLst>
+              <a:ext uri="{FF2B5EF4-FFF2-40B4-BE49-F238E27FC236}">
+                <a16:creationId xmlns:a16="http://schemas.microsoft.com/office/drawing/2014/main" id="{FA809AC9-32E2-4D6C-8D1C-9295FEADB9CB}"/>
+              </a:ext>
+            </a:extLst>
+          </p:cNvPr>
+          <p:cNvSpPr txBox="1"/>
+          <p:nvPr/>
+        </p:nvSpPr>
+        <p:spPr>
+          <a:xfrm>
+            <a:off x="6239407" y="834726"/>
+            <a:ext cx="1643893" cy="215444"/>
+          </a:xfrm>
+          <a:prstGeom prst="rect">
+            <a:avLst/>
+          </a:prstGeom>
+          <a:noFill/>
+        </p:spPr>
+        <p:txBody>
+          <a:bodyPr wrap="square">
+            <a:spAutoFit/>
+          </a:bodyPr>
+          <a:lstStyle/>
+          <a:p>
+            <a:r>
+              <a:rPr lang="en-US" sz="800" b="1" kern="0" spc="400" dirty="0">
+                <a:solidFill>
+                  <a:srgbClr val="E67E22"/>
+                </a:solidFill>
+                <a:latin typeface="Arial" panose="020B0604020202020204" pitchFamily="34" charset="0"/>
+                <a:cs typeface="Arial" panose="020B0604020202020204" pitchFamily="34" charset="0"/>
+              </a:rPr>
+              <a:t>CODIFICACION</a:t>
+            </a:r>
+            <a:endParaRPr lang="es-AR" dirty="0"/>
+          </a:p>
+        </p:txBody>
+      </p:sp>
+      <p:sp>
+        <p:nvSpPr>
+          <p:cNvPr id="26" name="CuadroTexto 25">
+            <a:extLst>
+              <a:ext uri="{FF2B5EF4-FFF2-40B4-BE49-F238E27FC236}">
+                <a16:creationId xmlns:a16="http://schemas.microsoft.com/office/drawing/2014/main" id="{BE6FDD97-9E52-4DF4-809C-C80942C856E2}"/>
+              </a:ext>
+            </a:extLst>
+          </p:cNvPr>
+          <p:cNvSpPr txBox="1"/>
+          <p:nvPr/>
+        </p:nvSpPr>
+        <p:spPr>
+          <a:xfrm>
+            <a:off x="136772" y="2819296"/>
+            <a:ext cx="2180342" cy="215444"/>
+          </a:xfrm>
+          <a:prstGeom prst="rect">
+            <a:avLst/>
+          </a:prstGeom>
+          <a:noFill/>
+        </p:spPr>
+        <p:txBody>
+          <a:bodyPr wrap="square">
+            <a:spAutoFit/>
+          </a:bodyPr>
+          <a:lstStyle/>
+          <a:p>
+            <a:r>
+              <a:rPr lang="en-US" sz="800" b="1" kern="0" spc="400" dirty="0">
+                <a:solidFill>
+                  <a:srgbClr val="E67E22"/>
+                </a:solidFill>
+                <a:latin typeface="Arial" panose="020B0604020202020204" pitchFamily="34" charset="0"/>
+                <a:cs typeface="Arial" panose="020B0604020202020204" pitchFamily="34" charset="0"/>
+              </a:rPr>
+              <a:t>ESTANDARIZACION</a:t>
+            </a:r>
+            <a:endParaRPr lang="es-AR" dirty="0"/>
+          </a:p>
+        </p:txBody>
+      </p:sp>
+      <p:sp>
+        <p:nvSpPr>
+          <p:cNvPr id="27" name="CuadroTexto 26">
+            <a:extLst>
+              <a:ext uri="{FF2B5EF4-FFF2-40B4-BE49-F238E27FC236}">
+                <a16:creationId xmlns:a16="http://schemas.microsoft.com/office/drawing/2014/main" id="{0302A9CA-E721-4E9E-AF55-7E715B407B83}"/>
+              </a:ext>
+            </a:extLst>
+          </p:cNvPr>
+          <p:cNvSpPr txBox="1"/>
+          <p:nvPr/>
+        </p:nvSpPr>
+        <p:spPr>
+          <a:xfrm>
+            <a:off x="3970879" y="2865164"/>
+            <a:ext cx="2015986" cy="215444"/>
+          </a:xfrm>
+          <a:prstGeom prst="rect">
+            <a:avLst/>
+          </a:prstGeom>
+          <a:noFill/>
+        </p:spPr>
+        <p:txBody>
+          <a:bodyPr wrap="square">
+            <a:spAutoFit/>
+          </a:bodyPr>
+          <a:lstStyle/>
+          <a:p>
+            <a:r>
+              <a:rPr lang="en-US" sz="800" b="1" kern="0" spc="400" dirty="0">
+                <a:solidFill>
+                  <a:srgbClr val="E67E22"/>
+                </a:solidFill>
+                <a:latin typeface="Arial" panose="020B0604020202020204" pitchFamily="34" charset="0"/>
+                <a:cs typeface="Arial" panose="020B0604020202020204" pitchFamily="34" charset="0"/>
+              </a:rPr>
+              <a:t>BALANCEO TARGET</a:t>
+            </a:r>
+            <a:endParaRPr lang="es-AR" dirty="0"/>
+          </a:p>
+        </p:txBody>
+      </p:sp>
+      <p:sp>
+        <p:nvSpPr>
+          <p:cNvPr id="31" name="CuadroTexto 30">
+            <a:extLst>
+              <a:ext uri="{FF2B5EF4-FFF2-40B4-BE49-F238E27FC236}">
+                <a16:creationId xmlns:a16="http://schemas.microsoft.com/office/drawing/2014/main" id="{A83644F8-555D-4994-96D1-DC688BDA86FD}"/>
+              </a:ext>
+            </a:extLst>
+          </p:cNvPr>
+          <p:cNvSpPr txBox="1"/>
+          <p:nvPr/>
+        </p:nvSpPr>
+        <p:spPr>
+          <a:xfrm>
+            <a:off x="7819714" y="1884981"/>
+            <a:ext cx="1375086" cy="707886"/>
+          </a:xfrm>
+          <a:prstGeom prst="rect">
+            <a:avLst/>
+          </a:prstGeom>
+          <a:noFill/>
+        </p:spPr>
+        <p:txBody>
+          <a:bodyPr wrap="square">
+            <a:spAutoFit/>
+          </a:bodyPr>
+          <a:lstStyle>
+            <a:lvl1pPr>
+              <a:defRPr sz="1200" b="1">
+                <a:solidFill>
+                  <a:srgbClr val="000000"/>
+                </a:solidFill>
+                <a:effectLst/>
+                <a:latin typeface="Courier New" panose="02070309020205020404" pitchFamily="49" charset="0"/>
+              </a:defRPr>
+            </a:lvl1pPr>
+          </a:lstStyle>
+          <a:p>
+            <a:r>
+              <a:rPr lang="es-AR" sz="800" dirty="0" err="1"/>
+              <a:t>One</a:t>
+            </a:r>
+            <a:r>
+              <a:rPr lang="es-AR" sz="800" dirty="0"/>
+              <a:t>-Hot:  </a:t>
+            </a:r>
+          </a:p>
+          <a:p>
+            <a:r>
+              <a:rPr lang="es-AR" sz="800" dirty="0"/>
+              <a:t>Dia semana – Genero</a:t>
+            </a:r>
+          </a:p>
+          <a:p>
+            <a:r>
+              <a:rPr lang="es-ES" sz="800" dirty="0"/>
+              <a:t>variables cíclicas: Hora y mes </a:t>
+            </a:r>
+          </a:p>
+          <a:p>
+            <a:endParaRPr lang="es-AR" sz="800" dirty="0"/>
+          </a:p>
+        </p:txBody>
+      </p:sp>
+      <p:sp>
+        <p:nvSpPr>
+          <p:cNvPr id="33" name="CuadroTexto 32">
+            <a:extLst>
+              <a:ext uri="{FF2B5EF4-FFF2-40B4-BE49-F238E27FC236}">
+                <a16:creationId xmlns:a16="http://schemas.microsoft.com/office/drawing/2014/main" id="{EBE2FFFA-EC1F-4CB3-B0B3-CA13B6F67BBB}"/>
+              </a:ext>
+            </a:extLst>
+          </p:cNvPr>
+          <p:cNvSpPr txBox="1"/>
+          <p:nvPr/>
+        </p:nvSpPr>
+        <p:spPr>
+          <a:xfrm>
+            <a:off x="209878" y="3046407"/>
+            <a:ext cx="3019114" cy="338554"/>
+          </a:xfrm>
+          <a:prstGeom prst="rect">
+            <a:avLst/>
+          </a:prstGeom>
+          <a:noFill/>
+        </p:spPr>
+        <p:txBody>
+          <a:bodyPr wrap="square">
+            <a:spAutoFit/>
+          </a:bodyPr>
+          <a:lstStyle/>
+          <a:p>
+            <a:r>
+              <a:rPr lang="es-AR" sz="800" b="1" dirty="0" err="1">
+                <a:solidFill>
+                  <a:srgbClr val="000000"/>
+                </a:solidFill>
+                <a:effectLst/>
+                <a:latin typeface="Courier New" panose="02070309020205020404" pitchFamily="49" charset="0"/>
+              </a:rPr>
+              <a:t>StandardScaler</a:t>
+            </a:r>
+            <a:r>
+              <a:rPr lang="es-AR" sz="800" b="1" dirty="0">
+                <a:solidFill>
+                  <a:srgbClr val="000000"/>
+                </a:solidFill>
+                <a:effectLst/>
+                <a:latin typeface="Courier New" panose="02070309020205020404" pitchFamily="49" charset="0"/>
+              </a:rPr>
+              <a:t> (media):</a:t>
+            </a:r>
+          </a:p>
+          <a:p>
+            <a:r>
+              <a:rPr lang="es-AR" sz="800" b="1" dirty="0">
+                <a:solidFill>
+                  <a:srgbClr val="000000"/>
+                </a:solidFill>
+                <a:latin typeface="Courier New" panose="02070309020205020404" pitchFamily="49" charset="0"/>
+              </a:rPr>
+              <a:t>Distancia – latitud - </a:t>
+            </a:r>
+            <a:r>
+              <a:rPr lang="es-AR" sz="800" b="1" dirty="0" err="1">
+                <a:solidFill>
+                  <a:srgbClr val="000000"/>
+                </a:solidFill>
+                <a:latin typeface="Courier New" panose="02070309020205020404" pitchFamily="49" charset="0"/>
+              </a:rPr>
+              <a:t>logitud</a:t>
+            </a:r>
+            <a:endParaRPr lang="es-AR" sz="800" b="0" dirty="0">
+              <a:solidFill>
+                <a:srgbClr val="000000"/>
+              </a:solidFill>
+              <a:effectLst/>
+              <a:latin typeface="Courier New" panose="02070309020205020404" pitchFamily="49" charset="0"/>
+            </a:endParaRPr>
+          </a:p>
+        </p:txBody>
+      </p:sp>
+      <p:pic>
+        <p:nvPicPr>
+          <p:cNvPr id="35" name="Imagen 34">
+            <a:extLst>
+              <a:ext uri="{FF2B5EF4-FFF2-40B4-BE49-F238E27FC236}">
+                <a16:creationId xmlns:a16="http://schemas.microsoft.com/office/drawing/2014/main" id="{F192C81E-9DFE-4AAA-BBBB-6712FE5CE8B1}"/>
+              </a:ext>
+            </a:extLst>
+          </p:cNvPr>
+          <p:cNvPicPr>
+            <a:picLocks noChangeAspect="1"/>
+          </p:cNvPicPr>
+          <p:nvPr/>
+        </p:nvPicPr>
+        <p:blipFill>
+          <a:blip r:embed="rId6"/>
+          <a:stretch>
+            <a:fillRect/>
+          </a:stretch>
+        </p:blipFill>
+        <p:spPr>
+          <a:xfrm>
+            <a:off x="3534685" y="1102014"/>
+            <a:ext cx="3180093" cy="1751753"/>
+          </a:xfrm>
+          <a:prstGeom prst="rect">
+            <a:avLst/>
+          </a:prstGeom>
+        </p:spPr>
+      </p:pic>
+      <p:sp>
+        <p:nvSpPr>
+          <p:cNvPr id="39" name="CuadroTexto 38">
+            <a:extLst>
+              <a:ext uri="{FF2B5EF4-FFF2-40B4-BE49-F238E27FC236}">
+                <a16:creationId xmlns:a16="http://schemas.microsoft.com/office/drawing/2014/main" id="{6BE8BBA2-2F6F-4E35-917C-EB0C825C2310}"/>
+              </a:ext>
+            </a:extLst>
+          </p:cNvPr>
+          <p:cNvSpPr txBox="1"/>
+          <p:nvPr/>
+        </p:nvSpPr>
+        <p:spPr>
+          <a:xfrm>
+            <a:off x="3768226" y="851751"/>
+            <a:ext cx="2218639" cy="215444"/>
+          </a:xfrm>
+          <a:prstGeom prst="rect">
+            <a:avLst/>
+          </a:prstGeom>
+          <a:noFill/>
+        </p:spPr>
+        <p:txBody>
+          <a:bodyPr wrap="square">
+            <a:spAutoFit/>
+          </a:bodyPr>
+          <a:lstStyle/>
+          <a:p>
+            <a:r>
+              <a:rPr lang="en-US" sz="800" b="1" kern="0" spc="400" dirty="0">
+                <a:solidFill>
+                  <a:srgbClr val="E67E22"/>
+                </a:solidFill>
+                <a:latin typeface="Arial" panose="020B0604020202020204" pitchFamily="34" charset="0"/>
+                <a:cs typeface="Arial" panose="020B0604020202020204" pitchFamily="34" charset="0"/>
+              </a:rPr>
+              <a:t>FEATURE</a:t>
+            </a:r>
+            <a:endParaRPr lang="es-AR" dirty="0"/>
+          </a:p>
+        </p:txBody>
+      </p:sp>
+      <p:pic>
+        <p:nvPicPr>
+          <p:cNvPr id="45" name="Imagen 44">
+            <a:extLst>
+              <a:ext uri="{FF2B5EF4-FFF2-40B4-BE49-F238E27FC236}">
+                <a16:creationId xmlns:a16="http://schemas.microsoft.com/office/drawing/2014/main" id="{78B06BAC-358A-433E-B5EC-E2C6119E553C}"/>
+              </a:ext>
+            </a:extLst>
+          </p:cNvPr>
+          <p:cNvPicPr>
+            <a:picLocks noChangeAspect="1"/>
+          </p:cNvPicPr>
+          <p:nvPr/>
+        </p:nvPicPr>
+        <p:blipFill>
+          <a:blip r:embed="rId7"/>
+          <a:stretch>
+            <a:fillRect/>
+          </a:stretch>
+        </p:blipFill>
+        <p:spPr>
+          <a:xfrm>
+            <a:off x="6465954" y="3126327"/>
+            <a:ext cx="2628600" cy="1653841"/>
+          </a:xfrm>
+          <a:prstGeom prst="rect">
+            <a:avLst/>
+          </a:prstGeom>
+        </p:spPr>
+      </p:pic>
+      <p:pic>
+        <p:nvPicPr>
+          <p:cNvPr id="47" name="Imagen 46">
+            <a:extLst>
+              <a:ext uri="{FF2B5EF4-FFF2-40B4-BE49-F238E27FC236}">
+                <a16:creationId xmlns:a16="http://schemas.microsoft.com/office/drawing/2014/main" id="{2212DA91-F79C-4BF8-93FE-76E1048022C7}"/>
+              </a:ext>
+            </a:extLst>
+          </p:cNvPr>
+          <p:cNvPicPr>
+            <a:picLocks noChangeAspect="1"/>
+          </p:cNvPicPr>
+          <p:nvPr/>
+        </p:nvPicPr>
+        <p:blipFill rotWithShape="1">
+          <a:blip r:embed="rId8"/>
+          <a:srcRect r="10191"/>
+          <a:stretch/>
+        </p:blipFill>
+        <p:spPr>
+          <a:xfrm>
+            <a:off x="143913" y="3374201"/>
+            <a:ext cx="3761337" cy="1287759"/>
+          </a:xfrm>
+          <a:prstGeom prst="rect">
+            <a:avLst/>
+          </a:prstGeom>
+        </p:spPr>
+      </p:pic>
+      <p:sp>
+        <p:nvSpPr>
+          <p:cNvPr id="43" name="Rectangle 3">
+            <a:extLst>
+              <a:ext uri="{FF2B5EF4-FFF2-40B4-BE49-F238E27FC236}">
+                <a16:creationId xmlns:a16="http://schemas.microsoft.com/office/drawing/2014/main" id="{1CC835C5-A4B6-407C-B965-303ABA99EE74}"/>
+              </a:ext>
+            </a:extLst>
+          </p:cNvPr>
+          <p:cNvSpPr>
+            <a:spLocks noChangeArrowheads="1"/>
+          </p:cNvSpPr>
+          <p:nvPr/>
+        </p:nvSpPr>
+        <p:spPr bwMode="auto">
+          <a:xfrm>
+            <a:off x="3952165" y="3190200"/>
+            <a:ext cx="2762613" cy="1585049"/>
+          </a:xfrm>
+          <a:prstGeom prst="rect">
+            <a:avLst/>
+          </a:prstGeom>
+          <a:noFill/>
+          <a:ln>
+            <a:noFill/>
+          </a:ln>
+          <a:effectLst/>
+        </p:spPr>
+        <p:txBody>
+          <a:bodyPr vert="horz" wrap="square" lIns="91440" tIns="45720" rIns="91440" bIns="0" numCol="1" anchor="ctr" anchorCtr="0" compatLnSpc="1">
+            <a:prstTxWarp prst="textNoShape">
+              <a:avLst/>
+            </a:prstTxWarp>
+            <a:spAutoFit/>
+          </a:bodyPr>
+          <a:lstStyle/>
+          <a:p>
+            <a:pPr marL="0" marR="0" lvl="0" indent="0" algn="l" defTabSz="914400" rtl="0" eaLnBrk="0" fontAlgn="base" latinLnBrk="0" hangingPunct="0">
+              <a:lnSpc>
+                <a:spcPct val="100000"/>
+              </a:lnSpc>
+              <a:spcBef>
+                <a:spcPct val="0"/>
+              </a:spcBef>
+              <a:spcAft>
+                <a:spcPct val="0"/>
+              </a:spcAft>
+              <a:buClrTx/>
+              <a:buSzTx/>
+              <a:buFontTx/>
+              <a:buNone/>
+              <a:tabLst/>
+            </a:pPr>
+            <a:r>
+              <a:rPr kumimoji="0" lang="es-AR" altLang="es-AR" sz="900" b="1" i="0" u="none" strike="noStrike" cap="none" normalizeH="0" baseline="0" dirty="0">
+                <a:ln>
+                  <a:noFill/>
+                </a:ln>
+                <a:solidFill>
+                  <a:srgbClr val="C00000"/>
+                </a:solidFill>
+                <a:effectLst/>
+                <a:latin typeface="system-ui"/>
+              </a:rPr>
+              <a:t>NO se aplica rebalanceo artificial</a:t>
+            </a:r>
+            <a:r>
+              <a:rPr kumimoji="0" lang="es-AR" altLang="es-AR" sz="900" b="0" i="0" u="none" strike="noStrike" cap="none" normalizeH="0" baseline="0" dirty="0">
+                <a:ln>
+                  <a:noFill/>
+                </a:ln>
+                <a:solidFill>
+                  <a:srgbClr val="C00000"/>
+                </a:solidFill>
+                <a:effectLst/>
+                <a:latin typeface="system-ui"/>
+              </a:rPr>
+              <a:t> </a:t>
+            </a:r>
+            <a:r>
+              <a:rPr kumimoji="0" lang="es-AR" altLang="es-AR" sz="900" b="0" i="0" u="none" strike="noStrike" cap="none" normalizeH="0" baseline="0" dirty="0">
+                <a:ln>
+                  <a:noFill/>
+                </a:ln>
+                <a:solidFill>
+                  <a:schemeClr val="tx1"/>
+                </a:solidFill>
+                <a:effectLst/>
+                <a:latin typeface="system-ui"/>
+              </a:rPr>
+              <a:t>(SMOTE / </a:t>
+            </a:r>
+            <a:r>
+              <a:rPr kumimoji="0" lang="es-AR" altLang="es-AR" sz="900" b="0" i="0" u="none" strike="noStrike" cap="none" normalizeH="0" baseline="0" dirty="0" err="1">
+                <a:ln>
+                  <a:noFill/>
+                </a:ln>
+                <a:solidFill>
+                  <a:schemeClr val="tx1"/>
+                </a:solidFill>
+                <a:effectLst/>
+                <a:latin typeface="system-ui"/>
+              </a:rPr>
+              <a:t>undersampling</a:t>
+            </a:r>
+            <a:r>
+              <a:rPr kumimoji="0" lang="es-AR" altLang="es-AR" sz="900" b="0" i="0" u="none" strike="noStrike" cap="none" normalizeH="0" baseline="0" dirty="0">
+                <a:ln>
+                  <a:noFill/>
+                </a:ln>
+                <a:solidFill>
+                  <a:schemeClr val="tx1"/>
+                </a:solidFill>
+                <a:effectLst/>
+                <a:latin typeface="system-ui"/>
+              </a:rPr>
+              <a:t> / </a:t>
+            </a:r>
+            <a:r>
+              <a:rPr kumimoji="0" lang="es-AR" altLang="es-AR" sz="900" b="0" i="0" u="none" strike="noStrike" cap="none" normalizeH="0" baseline="0" dirty="0" err="1">
+                <a:ln>
+                  <a:noFill/>
+                </a:ln>
+                <a:solidFill>
+                  <a:schemeClr val="tx1"/>
+                </a:solidFill>
+                <a:effectLst/>
+                <a:latin typeface="system-ui"/>
+              </a:rPr>
+              <a:t>oversampling</a:t>
+            </a:r>
+            <a:r>
+              <a:rPr kumimoji="0" lang="es-AR" altLang="es-AR" sz="900" b="0" i="0" u="none" strike="noStrike" cap="none" normalizeH="0" baseline="0" dirty="0">
+                <a:ln>
+                  <a:noFill/>
+                </a:ln>
+                <a:solidFill>
+                  <a:schemeClr val="tx1"/>
+                </a:solidFill>
+                <a:effectLst/>
+                <a:latin typeface="system-ui"/>
+              </a:rPr>
+              <a:t>). </a:t>
+            </a:r>
+          </a:p>
+          <a:p>
+            <a:pPr marL="0" marR="0" lvl="0" indent="0" algn="l" defTabSz="914400" rtl="0" eaLnBrk="0" fontAlgn="base" latinLnBrk="0" hangingPunct="0">
+              <a:lnSpc>
+                <a:spcPct val="100000"/>
+              </a:lnSpc>
+              <a:spcBef>
+                <a:spcPct val="0"/>
+              </a:spcBef>
+              <a:spcAft>
+                <a:spcPct val="0"/>
+              </a:spcAft>
+              <a:buClrTx/>
+              <a:buSzTx/>
+              <a:buFontTx/>
+              <a:buNone/>
+              <a:tabLst/>
+            </a:pPr>
+            <a:r>
+              <a:rPr kumimoji="0" lang="es-AR" altLang="es-AR" sz="900" b="0" i="0" u="none" strike="noStrike" cap="none" normalizeH="0" baseline="0" dirty="0">
+                <a:ln>
+                  <a:noFill/>
+                </a:ln>
+                <a:solidFill>
+                  <a:schemeClr val="tx1"/>
+                </a:solidFill>
+                <a:effectLst/>
+                <a:latin typeface="system-ui"/>
+              </a:rPr>
+              <a:t>Razones:</a:t>
+            </a:r>
+            <a:endParaRPr kumimoji="0" lang="es-AR" altLang="es-AR" sz="900" b="0" i="0" u="none" strike="noStrike" cap="none" normalizeH="0" baseline="0" dirty="0">
+              <a:ln>
+                <a:noFill/>
+              </a:ln>
+              <a:solidFill>
+                <a:schemeClr val="tx1"/>
+              </a:solidFill>
+              <a:effectLst/>
+            </a:endParaRPr>
+          </a:p>
+          <a:p>
+            <a:pPr marL="228600" marR="0" lvl="0" indent="-228600" algn="l" defTabSz="914400" rtl="0" eaLnBrk="0" fontAlgn="base" latinLnBrk="0" hangingPunct="0">
+              <a:lnSpc>
+                <a:spcPct val="100000"/>
+              </a:lnSpc>
+              <a:spcBef>
+                <a:spcPct val="0"/>
+              </a:spcBef>
+              <a:spcAft>
+                <a:spcPct val="0"/>
+              </a:spcAft>
+              <a:buClrTx/>
+              <a:buSzTx/>
+              <a:buFont typeface="Wingdings" panose="05000000000000000000" pitchFamily="2" charset="2"/>
+              <a:buChar char="Ø"/>
+              <a:tabLst/>
+            </a:pPr>
+            <a:r>
+              <a:rPr kumimoji="0" lang="es-AR" altLang="es-AR" sz="800" b="1" i="0" u="none" strike="noStrike" cap="none" normalizeH="0" baseline="0" dirty="0">
+                <a:ln>
+                  <a:noFill/>
+                </a:ln>
+                <a:solidFill>
+                  <a:schemeClr val="tx1">
+                    <a:lumMod val="85000"/>
+                    <a:lumOff val="15000"/>
+                  </a:schemeClr>
+                </a:solidFill>
+                <a:effectLst/>
+                <a:latin typeface="system-ui"/>
+              </a:rPr>
+              <a:t>El desbalance es moderado, no severo</a:t>
+            </a:r>
+            <a:endParaRPr kumimoji="0" lang="es-AR" altLang="es-AR" sz="800" b="0" i="0" u="none" strike="noStrike" cap="none" normalizeH="0" baseline="0" dirty="0">
+              <a:ln>
+                <a:noFill/>
+              </a:ln>
+              <a:solidFill>
+                <a:schemeClr val="tx1">
+                  <a:lumMod val="85000"/>
+                  <a:lumOff val="15000"/>
+                </a:schemeClr>
+              </a:solidFill>
+              <a:effectLst/>
+              <a:latin typeface="system-ui"/>
+            </a:endParaRPr>
+          </a:p>
+          <a:p>
+            <a:pPr marL="228600" marR="0" lvl="0" indent="-228600" algn="l" defTabSz="914400" rtl="0" eaLnBrk="0" fontAlgn="base" latinLnBrk="0" hangingPunct="0">
+              <a:lnSpc>
+                <a:spcPct val="100000"/>
+              </a:lnSpc>
+              <a:spcBef>
+                <a:spcPct val="0"/>
+              </a:spcBef>
+              <a:spcAft>
+                <a:spcPct val="0"/>
+              </a:spcAft>
+              <a:buClrTx/>
+              <a:buSzTx/>
+              <a:buFont typeface="Wingdings" panose="05000000000000000000" pitchFamily="2" charset="2"/>
+              <a:buChar char="Ø"/>
+              <a:tabLst/>
+            </a:pPr>
+            <a:r>
+              <a:rPr kumimoji="0" lang="es-AR" altLang="es-AR" sz="800" b="1" i="0" u="none" strike="noStrike" cap="none" normalizeH="0" baseline="0" dirty="0">
+                <a:ln>
+                  <a:noFill/>
+                </a:ln>
+                <a:solidFill>
+                  <a:schemeClr val="tx1">
+                    <a:lumMod val="85000"/>
+                    <a:lumOff val="15000"/>
+                  </a:schemeClr>
+                </a:solidFill>
+                <a:effectLst/>
+                <a:latin typeface="system-ui"/>
+              </a:rPr>
+              <a:t>La distribución de clases refleja la realidad operativa.</a:t>
+            </a:r>
+            <a:r>
+              <a:rPr kumimoji="0" lang="es-AR" altLang="es-AR" sz="800" b="0" i="0" u="none" strike="noStrike" cap="none" normalizeH="0" baseline="0" dirty="0">
+                <a:ln>
+                  <a:noFill/>
+                </a:ln>
+                <a:solidFill>
+                  <a:schemeClr val="tx1">
+                    <a:lumMod val="85000"/>
+                    <a:lumOff val="15000"/>
+                  </a:schemeClr>
+                </a:solidFill>
+                <a:effectLst/>
+                <a:latin typeface="system-ui"/>
+              </a:rPr>
+              <a:t> </a:t>
+            </a:r>
+          </a:p>
+          <a:p>
+            <a:pPr marL="228600" marR="0" lvl="0" indent="-228600" algn="l" defTabSz="914400" rtl="0" eaLnBrk="0" fontAlgn="base" latinLnBrk="0" hangingPunct="0">
+              <a:lnSpc>
+                <a:spcPct val="100000"/>
+              </a:lnSpc>
+              <a:spcBef>
+                <a:spcPct val="0"/>
+              </a:spcBef>
+              <a:spcAft>
+                <a:spcPct val="0"/>
+              </a:spcAft>
+              <a:buClrTx/>
+              <a:buSzTx/>
+              <a:buFont typeface="Wingdings" panose="05000000000000000000" pitchFamily="2" charset="2"/>
+              <a:buChar char="Ø"/>
+              <a:tabLst/>
+            </a:pPr>
+            <a:r>
+              <a:rPr lang="es-AR" altLang="es-AR" sz="800" b="1" dirty="0" err="1">
+                <a:solidFill>
+                  <a:schemeClr val="tx1">
+                    <a:lumMod val="85000"/>
+                    <a:lumOff val="15000"/>
+                  </a:schemeClr>
+                </a:solidFill>
+                <a:latin typeface="system-ui"/>
+              </a:rPr>
+              <a:t>E</a:t>
+            </a:r>
+            <a:r>
+              <a:rPr kumimoji="0" lang="es-AR" altLang="es-AR" sz="800" b="1" i="0" u="none" strike="noStrike" cap="none" normalizeH="0" baseline="0" dirty="0" err="1">
+                <a:ln>
+                  <a:noFill/>
+                </a:ln>
+                <a:solidFill>
+                  <a:schemeClr val="tx1">
+                    <a:lumMod val="85000"/>
+                    <a:lumOff val="15000"/>
+                  </a:schemeClr>
+                </a:solidFill>
+                <a:effectLst/>
+                <a:latin typeface="menlo"/>
+              </a:rPr>
+              <a:t>stratify</a:t>
+            </a:r>
+            <a:r>
+              <a:rPr kumimoji="0" lang="es-AR" altLang="es-AR" sz="800" b="1" i="0" u="none" strike="noStrike" cap="none" normalizeH="0" baseline="0" dirty="0">
+                <a:ln>
+                  <a:noFill/>
+                </a:ln>
+                <a:solidFill>
+                  <a:schemeClr val="tx1">
+                    <a:lumMod val="85000"/>
+                    <a:lumOff val="15000"/>
+                  </a:schemeClr>
+                </a:solidFill>
+                <a:effectLst/>
+                <a:latin typeface="menlo"/>
+              </a:rPr>
+              <a:t>=y</a:t>
+            </a:r>
+            <a:r>
+              <a:rPr kumimoji="0" lang="es-AR" altLang="es-AR" sz="800" b="1" i="0" u="none" strike="noStrike" cap="none" normalizeH="0" baseline="0" dirty="0">
+                <a:ln>
+                  <a:noFill/>
+                </a:ln>
+                <a:solidFill>
+                  <a:schemeClr val="tx1">
+                    <a:lumMod val="85000"/>
+                    <a:lumOff val="15000"/>
+                  </a:schemeClr>
+                </a:solidFill>
+                <a:effectLst/>
+                <a:latin typeface="system-ui"/>
+              </a:rPr>
+              <a:t> ya resuelve el problema</a:t>
+            </a:r>
+          </a:p>
+          <a:p>
+            <a:pPr marR="0" lvl="0" algn="l" defTabSz="914400" rtl="0" eaLnBrk="0" fontAlgn="base" latinLnBrk="0" hangingPunct="0">
+              <a:lnSpc>
+                <a:spcPct val="100000"/>
+              </a:lnSpc>
+              <a:spcBef>
+                <a:spcPct val="0"/>
+              </a:spcBef>
+              <a:spcAft>
+                <a:spcPct val="0"/>
+              </a:spcAft>
+              <a:buClrTx/>
+              <a:buSzTx/>
+              <a:tabLst/>
+            </a:pPr>
+            <a:r>
+              <a:rPr lang="es-AR" altLang="es-AR" sz="800" b="1" dirty="0">
+                <a:solidFill>
+                  <a:schemeClr val="tx1">
+                    <a:lumMod val="85000"/>
+                    <a:lumOff val="15000"/>
+                  </a:schemeClr>
+                </a:solidFill>
+                <a:latin typeface="system-ui"/>
+              </a:rPr>
+              <a:t>       </a:t>
+            </a:r>
+            <a:r>
+              <a:rPr kumimoji="0" lang="es-AR" altLang="es-AR" sz="800" b="1" i="0" u="none" strike="noStrike" cap="none" normalizeH="0" baseline="0" dirty="0">
+                <a:ln>
+                  <a:noFill/>
+                </a:ln>
+                <a:solidFill>
+                  <a:schemeClr val="tx1">
+                    <a:lumMod val="85000"/>
+                    <a:lumOff val="15000"/>
+                  </a:schemeClr>
+                </a:solidFill>
+                <a:effectLst/>
+                <a:latin typeface="system-ui"/>
+              </a:rPr>
+              <a:t> </a:t>
+            </a:r>
+            <a:r>
+              <a:rPr kumimoji="0" lang="es-AR" altLang="es-AR" sz="800" b="1" i="0" u="none" strike="noStrike" cap="none" normalizeH="0" baseline="0" dirty="0" err="1">
+                <a:ln>
+                  <a:noFill/>
+                </a:ln>
+                <a:solidFill>
+                  <a:schemeClr val="tx1">
+                    <a:lumMod val="85000"/>
+                    <a:lumOff val="15000"/>
+                  </a:schemeClr>
+                </a:solidFill>
+                <a:effectLst/>
+                <a:latin typeface="system-ui"/>
+              </a:rPr>
+              <a:t>downstream</a:t>
+            </a:r>
+            <a:r>
+              <a:rPr kumimoji="0" lang="es-AR" altLang="es-AR" sz="800" b="1" i="0" u="none" strike="noStrike" cap="none" normalizeH="0" baseline="0" dirty="0">
+                <a:ln>
+                  <a:noFill/>
+                </a:ln>
+                <a:solidFill>
+                  <a:schemeClr val="tx1">
+                    <a:lumMod val="85000"/>
+                    <a:lumOff val="15000"/>
+                  </a:schemeClr>
+                </a:solidFill>
+                <a:effectLst/>
+                <a:latin typeface="system-ui"/>
+              </a:rPr>
+              <a:t> más crítico</a:t>
+            </a:r>
+            <a:endParaRPr kumimoji="0" lang="es-AR" altLang="es-AR" sz="800" b="0" i="0" u="none" strike="noStrike" cap="none" normalizeH="0" baseline="0" dirty="0">
+              <a:ln>
+                <a:noFill/>
+              </a:ln>
+              <a:solidFill>
+                <a:schemeClr val="tx1">
+                  <a:lumMod val="85000"/>
+                  <a:lumOff val="15000"/>
+                </a:schemeClr>
+              </a:solidFill>
+              <a:effectLst/>
+              <a:latin typeface="system-ui"/>
+            </a:endParaRPr>
+          </a:p>
+          <a:p>
+            <a:pPr marL="228600" marR="0" lvl="0" indent="-228600" algn="l" defTabSz="914400" rtl="0" eaLnBrk="0" fontAlgn="base" latinLnBrk="0" hangingPunct="0">
+              <a:lnSpc>
+                <a:spcPct val="100000"/>
+              </a:lnSpc>
+              <a:spcBef>
+                <a:spcPct val="0"/>
+              </a:spcBef>
+              <a:spcAft>
+                <a:spcPct val="0"/>
+              </a:spcAft>
+              <a:buClrTx/>
+              <a:buSzTx/>
+              <a:buFont typeface="Wingdings" panose="05000000000000000000" pitchFamily="2" charset="2"/>
+              <a:buChar char="Ø"/>
+              <a:tabLst/>
+            </a:pPr>
+            <a:r>
+              <a:rPr kumimoji="0" lang="es-AR" altLang="es-AR" sz="800" b="1" i="0" u="none" strike="noStrike" cap="none" normalizeH="0" baseline="0" dirty="0">
+                <a:ln>
+                  <a:noFill/>
+                </a:ln>
+                <a:solidFill>
+                  <a:schemeClr val="tx1">
+                    <a:lumMod val="85000"/>
+                    <a:lumOff val="15000"/>
+                  </a:schemeClr>
+                </a:solidFill>
+                <a:effectLst/>
+                <a:latin typeface="system-ui"/>
+              </a:rPr>
+              <a:t>Los modelos candidatos soportan </a:t>
+            </a:r>
+            <a:r>
+              <a:rPr kumimoji="0" lang="es-AR" altLang="es-AR" sz="800" b="1" i="0" u="none" strike="noStrike" cap="none" normalizeH="0" baseline="0" dirty="0" err="1">
+                <a:ln>
+                  <a:noFill/>
+                </a:ln>
+                <a:solidFill>
+                  <a:schemeClr val="tx1">
+                    <a:lumMod val="85000"/>
+                    <a:lumOff val="15000"/>
+                  </a:schemeClr>
+                </a:solidFill>
+                <a:effectLst/>
+                <a:latin typeface="menlo"/>
+              </a:rPr>
+              <a:t>class_weight</a:t>
+            </a:r>
+            <a:r>
+              <a:rPr kumimoji="0" lang="es-AR" altLang="es-AR" sz="800" b="1" i="0" u="none" strike="noStrike" cap="none" normalizeH="0" baseline="0" dirty="0">
+                <a:ln>
+                  <a:noFill/>
+                </a:ln>
+                <a:solidFill>
+                  <a:schemeClr val="tx1">
+                    <a:lumMod val="85000"/>
+                    <a:lumOff val="15000"/>
+                  </a:schemeClr>
+                </a:solidFill>
+                <a:effectLst/>
+                <a:latin typeface="menlo"/>
+              </a:rPr>
+              <a:t>='</a:t>
+            </a:r>
+            <a:r>
+              <a:rPr kumimoji="0" lang="es-AR" altLang="es-AR" sz="800" b="1" i="0" u="none" strike="noStrike" cap="none" normalizeH="0" baseline="0" dirty="0" err="1">
+                <a:ln>
+                  <a:noFill/>
+                </a:ln>
+                <a:solidFill>
+                  <a:schemeClr val="tx1">
+                    <a:lumMod val="85000"/>
+                    <a:lumOff val="15000"/>
+                  </a:schemeClr>
+                </a:solidFill>
+                <a:effectLst/>
+                <a:latin typeface="menlo"/>
+              </a:rPr>
+              <a:t>balanced</a:t>
+            </a:r>
+            <a:r>
+              <a:rPr kumimoji="0" lang="es-AR" altLang="es-AR" sz="800" b="1" i="0" u="none" strike="noStrike" cap="none" normalizeH="0" baseline="0" dirty="0">
+                <a:ln>
+                  <a:noFill/>
+                </a:ln>
+                <a:solidFill>
+                  <a:schemeClr val="tx1">
+                    <a:lumMod val="85000"/>
+                    <a:lumOff val="15000"/>
+                  </a:schemeClr>
+                </a:solidFill>
+                <a:effectLst/>
+                <a:latin typeface="menlo"/>
+              </a:rPr>
+              <a:t>’</a:t>
+            </a:r>
+            <a:endParaRPr kumimoji="0" lang="es-AR" altLang="es-AR" sz="800" b="0" i="0" u="none" strike="noStrike" cap="none" normalizeH="0" baseline="0" dirty="0">
+              <a:ln>
+                <a:noFill/>
+              </a:ln>
+              <a:solidFill>
+                <a:schemeClr val="tx1">
+                  <a:lumMod val="85000"/>
+                  <a:lumOff val="15000"/>
+                </a:schemeClr>
+              </a:solidFill>
+              <a:effectLst/>
+              <a:latin typeface="system-ui"/>
+            </a:endParaRPr>
+          </a:p>
+          <a:p>
+            <a:pPr marL="228600" marR="0" lvl="0" indent="-228600" algn="l" defTabSz="914400" rtl="0" eaLnBrk="0" fontAlgn="base" latinLnBrk="0" hangingPunct="0">
+              <a:lnSpc>
+                <a:spcPct val="100000"/>
+              </a:lnSpc>
+              <a:spcBef>
+                <a:spcPct val="0"/>
+              </a:spcBef>
+              <a:spcAft>
+                <a:spcPct val="0"/>
+              </a:spcAft>
+              <a:buClrTx/>
+              <a:buSzTx/>
+              <a:buFont typeface="Wingdings" panose="05000000000000000000" pitchFamily="2" charset="2"/>
+              <a:buChar char="Ø"/>
+              <a:tabLst/>
+            </a:pPr>
+            <a:r>
+              <a:rPr kumimoji="0" lang="es-AR" altLang="es-AR" sz="800" b="1" i="0" u="none" strike="noStrike" cap="none" normalizeH="0" baseline="0" dirty="0">
+                <a:ln>
+                  <a:noFill/>
+                </a:ln>
+                <a:solidFill>
+                  <a:schemeClr val="tx1">
+                    <a:lumMod val="85000"/>
+                    <a:lumOff val="15000"/>
+                  </a:schemeClr>
+                </a:solidFill>
+                <a:effectLst/>
+                <a:latin typeface="system-ui"/>
+              </a:rPr>
+              <a:t>SMOTE sobre </a:t>
+            </a:r>
+            <a:r>
+              <a:rPr kumimoji="0" lang="es-AR" altLang="es-AR" sz="800" b="1" i="0" u="none" strike="noStrike" cap="none" normalizeH="0" baseline="0" dirty="0" err="1">
+                <a:ln>
+                  <a:noFill/>
+                </a:ln>
+                <a:solidFill>
+                  <a:schemeClr val="tx1">
+                    <a:lumMod val="85000"/>
+                    <a:lumOff val="15000"/>
+                  </a:schemeClr>
+                </a:solidFill>
+                <a:effectLst/>
+                <a:latin typeface="system-ui"/>
+              </a:rPr>
+              <a:t>features</a:t>
+            </a:r>
+            <a:r>
+              <a:rPr kumimoji="0" lang="es-AR" altLang="es-AR" sz="800" b="1" i="0" u="none" strike="noStrike" cap="none" normalizeH="0" baseline="0" dirty="0">
+                <a:ln>
+                  <a:noFill/>
+                </a:ln>
+                <a:solidFill>
+                  <a:schemeClr val="tx1">
+                    <a:lumMod val="85000"/>
+                    <a:lumOff val="15000"/>
+                  </a:schemeClr>
+                </a:solidFill>
+                <a:effectLst/>
+                <a:latin typeface="system-ui"/>
+              </a:rPr>
+              <a:t> mixtas (continuas + binarias) requiere variantes específicas</a:t>
+            </a:r>
+            <a:r>
+              <a:rPr kumimoji="0" lang="es-AR" altLang="es-AR" sz="800" b="1" i="0" u="none" strike="noStrike" cap="none" normalizeH="0" baseline="0" dirty="0">
+                <a:ln>
+                  <a:noFill/>
+                </a:ln>
+                <a:solidFill>
+                  <a:schemeClr val="tx1"/>
+                </a:solidFill>
+                <a:effectLst/>
+                <a:latin typeface="system-ui"/>
+              </a:rPr>
+              <a:t>.</a:t>
+            </a:r>
+            <a:endParaRPr kumimoji="0" lang="es-AR" altLang="es-AR" sz="800" b="0" i="0" u="none" strike="noStrike" cap="none" normalizeH="0" baseline="0" dirty="0">
+              <a:ln>
+                <a:noFill/>
+              </a:ln>
+              <a:solidFill>
+                <a:schemeClr val="tx1"/>
+              </a:solidFill>
+              <a:effectLst/>
+              <a:latin typeface="system-ui"/>
+            </a:endParaRPr>
+          </a:p>
+          <a:p>
+            <a:pPr marL="0" marR="0" lvl="0" indent="0" algn="l" defTabSz="914400" rtl="0" eaLnBrk="0" fontAlgn="base" latinLnBrk="0" hangingPunct="0">
+              <a:lnSpc>
+                <a:spcPct val="100000"/>
+              </a:lnSpc>
+              <a:spcBef>
+                <a:spcPct val="0"/>
+              </a:spcBef>
+              <a:spcAft>
+                <a:spcPct val="0"/>
+              </a:spcAft>
+              <a:buClrTx/>
+              <a:buSzTx/>
+              <a:buFontTx/>
+              <a:buNone/>
+              <a:tabLst/>
+            </a:pPr>
+            <a:endParaRPr kumimoji="0" lang="es-AR" altLang="es-AR" sz="900" b="0" i="0" u="none" strike="noStrike" cap="none" normalizeH="0" baseline="0" dirty="0">
+              <a:ln>
+                <a:noFill/>
+              </a:ln>
+              <a:solidFill>
+                <a:schemeClr val="tx1"/>
+              </a:solidFill>
+              <a:effectLst/>
+              <a:latin typeface="Arial" panose="020B0604020202020204" pitchFamily="34" charset="0"/>
+            </a:endParaRPr>
           </a:p>
         </p:txBody>
       </p:sp>
@@ -5580,462 +6592,6 @@
               </a:rPr>
               <a:t>, seguida por factores temporales de alto nivel como el indicador de fin de semana.</a:t>
             </a:r>
-          </a:p>
-        </p:txBody>
-      </p:sp>
-    </p:spTree>
-  </p:cSld>
-  <p:clrMapOvr>
-    <a:masterClrMapping/>
-  </p:clrMapOvr>
-</p:sld>
-</file>
-
-<file path=ppt/slides/slide7.xml><?xml version="1.0" encoding="utf-8"?>
-<p:sld xmlns:a="http://schemas.openxmlformats.org/drawingml/2006/main" xmlns:r="http://schemas.openxmlformats.org/officeDocument/2006/relationships" xmlns:p="http://schemas.openxmlformats.org/presentationml/2006/main">
-  <p:cSld name="Slide 6">
-    <p:bg>
-      <p:bgPr>
-        <a:solidFill>
-          <a:srgbClr val="FAF5EC"/>
-        </a:solidFill>
-        <a:effectLst/>
-      </p:bgPr>
-    </p:bg>
-    <p:spTree>
-      <p:nvGrpSpPr>
-        <p:cNvPr id="1" name=""/>
-        <p:cNvGrpSpPr/>
-        <p:nvPr/>
-      </p:nvGrpSpPr>
-      <p:grpSpPr>
-        <a:xfrm>
-          <a:off x="0" y="0"/>
-          <a:ext cx="0" cy="0"/>
-          <a:chOff x="0" y="0"/>
-          <a:chExt cx="0" cy="0"/>
-        </a:xfrm>
-      </p:grpSpPr>
-      <p:sp>
-        <p:nvSpPr>
-          <p:cNvPr id="2" name="Shape 0"/>
-          <p:cNvSpPr/>
-          <p:nvPr/>
-        </p:nvSpPr>
-        <p:spPr>
-          <a:xfrm>
-            <a:off x="0" y="0"/>
-            <a:ext cx="9144000" cy="777240"/>
-          </a:xfrm>
-          <a:prstGeom prst="rect">
-            <a:avLst/>
-          </a:prstGeom>
-          <a:solidFill>
-            <a:srgbClr val="1A2332"/>
-          </a:solidFill>
-          <a:ln/>
-        </p:spPr>
-        <p:txBody>
-          <a:bodyPr/>
-          <a:lstStyle/>
-          <a:p>
-            <a:endParaRPr lang="en-US"/>
-          </a:p>
-        </p:txBody>
-      </p:sp>
-      <p:sp>
-        <p:nvSpPr>
-          <p:cNvPr id="3" name="Shape 1"/>
-          <p:cNvSpPr/>
-          <p:nvPr/>
-        </p:nvSpPr>
-        <p:spPr>
-          <a:xfrm>
-            <a:off x="0" y="0"/>
-            <a:ext cx="73152" cy="5143500"/>
-          </a:xfrm>
-          <a:prstGeom prst="rect">
-            <a:avLst/>
-          </a:prstGeom>
-          <a:solidFill>
-            <a:srgbClr val="E67E22"/>
-          </a:solidFill>
-          <a:ln/>
-        </p:spPr>
-        <p:txBody>
-          <a:bodyPr/>
-          <a:lstStyle/>
-          <a:p>
-            <a:endParaRPr lang="en-US"/>
-          </a:p>
-        </p:txBody>
-      </p:sp>
-      <p:sp>
-        <p:nvSpPr>
-          <p:cNvPr id="4" name="Text 2"/>
-          <p:cNvSpPr/>
-          <p:nvPr/>
-        </p:nvSpPr>
-        <p:spPr>
-          <a:xfrm>
-            <a:off x="365760" y="109728"/>
-            <a:ext cx="8412480" cy="228600"/>
-          </a:xfrm>
-          <a:prstGeom prst="rect">
-            <a:avLst/>
-          </a:prstGeom>
-          <a:noFill/>
-          <a:ln/>
-        </p:spPr>
-        <p:txBody>
-          <a:bodyPr wrap="square" lIns="0" tIns="0" rIns="0" bIns="0" rtlCol="0" anchor="ctr"/>
-          <a:lstStyle/>
-          <a:p>
-            <a:pPr marL="0" indent="0">
-              <a:buNone/>
-            </a:pPr>
-            <a:r>
-              <a:rPr lang="en-US" sz="1000" b="1" kern="0" spc="600" dirty="0">
-                <a:solidFill>
-                  <a:srgbClr val="E67E22"/>
-                </a:solidFill>
-                <a:latin typeface="Arial" pitchFamily="34" charset="0"/>
-                <a:ea typeface="Arial" pitchFamily="34" charset="-122"/>
-                <a:cs typeface="Arial" pitchFamily="34" charset="-120"/>
-              </a:rPr>
-              <a:t>CIERRE · EQUIPO COMPLETO</a:t>
-            </a:r>
-            <a:endParaRPr lang="en-US" sz="1000" dirty="0"/>
-          </a:p>
-        </p:txBody>
-      </p:sp>
-      <p:sp>
-        <p:nvSpPr>
-          <p:cNvPr id="5" name="Text 3"/>
-          <p:cNvSpPr/>
-          <p:nvPr/>
-        </p:nvSpPr>
-        <p:spPr>
-          <a:xfrm>
-            <a:off x="365760" y="310896"/>
-            <a:ext cx="8412480" cy="411480"/>
-          </a:xfrm>
-          <a:prstGeom prst="rect">
-            <a:avLst/>
-          </a:prstGeom>
-          <a:noFill/>
-          <a:ln/>
-        </p:spPr>
-        <p:txBody>
-          <a:bodyPr wrap="square" lIns="0" tIns="0" rIns="0" bIns="0" rtlCol="0" anchor="ctr"/>
-          <a:lstStyle/>
-          <a:p>
-            <a:pPr marL="0" indent="0">
-              <a:buNone/>
-            </a:pPr>
-            <a:r>
-              <a:rPr lang="en-US" sz="2200" b="1" dirty="0">
-                <a:solidFill>
-                  <a:srgbClr val="FFFFFF"/>
-                </a:solidFill>
-                <a:latin typeface="Georgia" pitchFamily="34" charset="0"/>
-                <a:ea typeface="Georgia" pitchFamily="34" charset="-122"/>
-                <a:cs typeface="Georgia" pitchFamily="34" charset="-120"/>
-              </a:rPr>
-              <a:t>Conclusiones y próximos pasos</a:t>
-            </a:r>
-            <a:endParaRPr lang="en-US" sz="2200" dirty="0"/>
-          </a:p>
-        </p:txBody>
-      </p:sp>
-      <p:sp>
-        <p:nvSpPr>
-          <p:cNvPr id="6" name="Shape 4"/>
-          <p:cNvSpPr/>
-          <p:nvPr/>
-        </p:nvSpPr>
-        <p:spPr>
-          <a:xfrm>
-            <a:off x="365760" y="914400"/>
-            <a:ext cx="8412480" cy="3657600"/>
-          </a:xfrm>
-          <a:prstGeom prst="rect">
-            <a:avLst/>
-          </a:prstGeom>
-          <a:solidFill>
-            <a:srgbClr val="F5EEE0"/>
-          </a:solidFill>
-          <a:ln w="6350">
-            <a:solidFill>
-              <a:srgbClr val="E67E22"/>
-            </a:solidFill>
-            <a:prstDash val="dash"/>
-          </a:ln>
-        </p:spPr>
-        <p:txBody>
-          <a:bodyPr/>
-          <a:lstStyle/>
-          <a:p>
-            <a:endParaRPr lang="en-US"/>
-          </a:p>
-        </p:txBody>
-      </p:sp>
-      <p:sp>
-        <p:nvSpPr>
-          <p:cNvPr id="7" name="Text 5"/>
-          <p:cNvSpPr/>
-          <p:nvPr/>
-        </p:nvSpPr>
-        <p:spPr>
-          <a:xfrm>
-            <a:off x="365760" y="1097280"/>
-            <a:ext cx="8412480" cy="365760"/>
-          </a:xfrm>
-          <a:prstGeom prst="rect">
-            <a:avLst/>
-          </a:prstGeom>
-          <a:noFill/>
-          <a:ln/>
-        </p:spPr>
-        <p:txBody>
-          <a:bodyPr wrap="square" rtlCol="0" anchor="ctr"/>
-          <a:lstStyle/>
-          <a:p>
-            <a:pPr marL="0" indent="0" algn="ctr">
-              <a:buNone/>
-            </a:pPr>
-            <a:r>
-              <a:rPr lang="en-US" sz="1100" b="1" kern="0" spc="500" dirty="0">
-                <a:solidFill>
-                  <a:srgbClr val="E67E22"/>
-                </a:solidFill>
-                <a:latin typeface="Arial" pitchFamily="34" charset="0"/>
-                <a:ea typeface="Arial" pitchFamily="34" charset="-122"/>
-                <a:cs typeface="Arial" pitchFamily="34" charset="-120"/>
-              </a:rPr>
-              <a:t>SLIDE EN CONSTRUCCIÓN · CIERRE DEL GRUPO</a:t>
-            </a:r>
-            <a:endParaRPr lang="en-US" sz="1100" dirty="0"/>
-          </a:p>
-        </p:txBody>
-      </p:sp>
-      <p:sp>
-        <p:nvSpPr>
-          <p:cNvPr id="8" name="Text 6"/>
-          <p:cNvSpPr/>
-          <p:nvPr/>
-        </p:nvSpPr>
-        <p:spPr>
-          <a:xfrm>
-            <a:off x="731520" y="1645920"/>
-            <a:ext cx="7680960" cy="274320"/>
-          </a:xfrm>
-          <a:prstGeom prst="rect">
-            <a:avLst/>
-          </a:prstGeom>
-          <a:noFill/>
-          <a:ln/>
-        </p:spPr>
-        <p:txBody>
-          <a:bodyPr wrap="square" lIns="0" tIns="0" rIns="0" bIns="0" rtlCol="0" anchor="ctr"/>
-          <a:lstStyle/>
-          <a:p>
-            <a:pPr marL="0" indent="0">
-              <a:buNone/>
-            </a:pPr>
-            <a:r>
-              <a:rPr lang="en-US" sz="1300" b="1" dirty="0">
-                <a:solidFill>
-                  <a:srgbClr val="2C3E50"/>
-                </a:solidFill>
-                <a:latin typeface="Calibri" pitchFamily="34" charset="0"/>
-                <a:ea typeface="Calibri" pitchFamily="34" charset="-122"/>
-                <a:cs typeface="Calibri" pitchFamily="34" charset="-120"/>
-              </a:rPr>
-              <a:t>Contenido sugerido:</a:t>
-            </a:r>
-            <a:endParaRPr lang="en-US" sz="1300" dirty="0"/>
-          </a:p>
-        </p:txBody>
-      </p:sp>
-      <p:sp>
-        <p:nvSpPr>
-          <p:cNvPr id="9" name="Text 7"/>
-          <p:cNvSpPr/>
-          <p:nvPr/>
-        </p:nvSpPr>
-        <p:spPr>
-          <a:xfrm>
-            <a:off x="731520" y="2011680"/>
-            <a:ext cx="7680960" cy="2286000"/>
-          </a:xfrm>
-          <a:prstGeom prst="rect">
-            <a:avLst/>
-          </a:prstGeom>
-          <a:noFill/>
-          <a:ln/>
-        </p:spPr>
-        <p:txBody>
-          <a:bodyPr wrap="square" lIns="50800" tIns="50800" rIns="50800" bIns="50800" rtlCol="0" anchor="ctr"/>
-          <a:lstStyle/>
-          <a:p>
-            <a:pPr marL="342900" indent="-342900">
-              <a:buSzPct val="100000"/>
-              <a:buChar char="•"/>
-            </a:pPr>
-            <a:r>
-              <a:rPr lang="en-US" sz="1200" dirty="0">
-                <a:solidFill>
-                  <a:srgbClr val="2C3E50"/>
-                </a:solidFill>
-                <a:latin typeface="Calibri" pitchFamily="34" charset="0"/>
-                <a:ea typeface="Calibri" pitchFamily="34" charset="-122"/>
-                <a:cs typeface="Calibri" pitchFamily="34" charset="-120"/>
-              </a:rPr>
-              <a:t>Hallazgos destacados: pico único vespertino · Pareto geográfico · clase Mediano mayoritaria</a:t>
-            </a:r>
-            <a:endParaRPr lang="en-US" sz="1200" dirty="0"/>
-          </a:p>
-          <a:p>
-            <a:pPr marL="342900" indent="-342900">
-              <a:buSzPct val="100000"/>
-              <a:buChar char="•"/>
-            </a:pPr>
-            <a:r>
-              <a:rPr lang="en-US" sz="1200" dirty="0">
-                <a:solidFill>
-                  <a:srgbClr val="2C3E50"/>
-                </a:solidFill>
-                <a:latin typeface="Calibri" pitchFamily="34" charset="0"/>
-                <a:ea typeface="Calibri" pitchFamily="34" charset="-122"/>
-                <a:cs typeface="Calibri" pitchFamily="34" charset="-120"/>
-              </a:rPr>
-              <a:t>Calidad del dato manejable: ~8,4 % de filas descartadas (clicks accidentales + bicis no devueltas)</a:t>
-            </a:r>
-            <a:endParaRPr lang="en-US" sz="1200" dirty="0"/>
-          </a:p>
-          <a:p>
-            <a:pPr marL="342900" indent="-342900">
-              <a:buSzPct val="100000"/>
-              <a:buChar char="•"/>
-            </a:pPr>
-            <a:r>
-              <a:rPr lang="en-US" sz="1200" dirty="0">
-                <a:solidFill>
-                  <a:srgbClr val="2C3E50"/>
-                </a:solidFill>
-                <a:latin typeface="Calibri" pitchFamily="34" charset="0"/>
-                <a:ea typeface="Calibri" pitchFamily="34" charset="-122"/>
-                <a:cs typeface="Calibri" pitchFamily="34" charset="-120"/>
-              </a:rPr>
-              <a:t>Próximos pasos: entrenar y comparar LogReg · Random Forest · XGBoost con class_weight=balanced</a:t>
-            </a:r>
-            <a:endParaRPr lang="en-US" sz="1200" dirty="0"/>
-          </a:p>
-          <a:p>
-            <a:pPr marL="342900" indent="-342900">
-              <a:buSzPct val="100000"/>
-              <a:buChar char="•"/>
-            </a:pPr>
-            <a:r>
-              <a:rPr lang="en-US" sz="1200" dirty="0">
-                <a:solidFill>
-                  <a:srgbClr val="2C3E50"/>
-                </a:solidFill>
-                <a:latin typeface="Calibri" pitchFamily="34" charset="0"/>
-                <a:ea typeface="Calibri" pitchFamily="34" charset="-122"/>
-                <a:cs typeface="Calibri" pitchFamily="34" charset="-120"/>
-              </a:rPr>
-              <a:t>Métrica principal: F1-score macro para priorizar la clase minoritaria Largo</a:t>
-            </a:r>
-            <a:endParaRPr lang="en-US" sz="1200" dirty="0"/>
-          </a:p>
-          <a:p>
-            <a:pPr marL="342900" indent="-342900">
-              <a:buSzPct val="100000"/>
-              <a:buChar char="•"/>
-            </a:pPr>
-            <a:r>
-              <a:rPr lang="en-US" sz="1200" dirty="0">
-                <a:solidFill>
-                  <a:srgbClr val="2C3E50"/>
-                </a:solidFill>
-                <a:latin typeface="Calibri" pitchFamily="34" charset="0"/>
-                <a:ea typeface="Calibri" pitchFamily="34" charset="-122"/>
-                <a:cs typeface="Calibri" pitchFamily="34" charset="-120"/>
-              </a:rPr>
-              <a:t>Repositorio: github.com/cimberlina/grupo7-eda-ecobici  ·  Gracias · abierto a preguntas</a:t>
-            </a:r>
-            <a:endParaRPr lang="en-US" sz="1200" dirty="0"/>
-          </a:p>
-        </p:txBody>
-      </p:sp>
-      <p:sp>
-        <p:nvSpPr>
-          <p:cNvPr id="10" name="Shape 8"/>
-          <p:cNvSpPr/>
-          <p:nvPr/>
-        </p:nvSpPr>
-        <p:spPr>
-          <a:xfrm>
-            <a:off x="365760" y="4823460"/>
-            <a:ext cx="8412480" cy="0"/>
-          </a:xfrm>
-          <a:prstGeom prst="line">
-            <a:avLst/>
-          </a:prstGeom>
-          <a:noFill/>
-          <a:ln w="9525">
-            <a:solidFill>
-              <a:srgbClr val="E67E22"/>
-            </a:solidFill>
-            <a:prstDash val="solid"/>
-          </a:ln>
-        </p:spPr>
-        <p:txBody>
-          <a:bodyPr/>
-          <a:lstStyle/>
-          <a:p>
-            <a:endParaRPr lang="en-US"/>
-          </a:p>
-        </p:txBody>
-      </p:sp>
-      <p:sp>
-        <p:nvSpPr>
-          <p:cNvPr id="11" name="Text 9"/>
-          <p:cNvSpPr/>
-          <p:nvPr/>
-        </p:nvSpPr>
-        <p:spPr>
-          <a:xfrm>
-            <a:off x="365760" y="4869180"/>
-            <a:ext cx="8412480" cy="228600"/>
-          </a:xfrm>
-          <a:prstGeom prst="rect">
-            <a:avLst/>
-          </a:prstGeom>
-          <a:noFill/>
-          <a:ln/>
-        </p:spPr>
-        <p:txBody>
-          <a:bodyPr wrap="square" lIns="0" tIns="0" rIns="0" bIns="0" rtlCol="0" anchor="ctr"/>
-          <a:lstStyle/>
-          <a:p>
-            <a:pPr marL="0" indent="0">
-              <a:buNone/>
-            </a:pPr>
-            <a:r>
-              <a:rPr lang="en-US" sz="900" i="1" dirty="0">
-                <a:solidFill>
-                  <a:srgbClr val="5D6D7E"/>
-                </a:solidFill>
-                <a:latin typeface="Calibri" pitchFamily="34" charset="0"/>
-                <a:ea typeface="Calibri" pitchFamily="34" charset="-122"/>
-                <a:cs typeface="Calibri" pitchFamily="34" charset="-120"/>
-              </a:rPr>
-              <a:t>Grupo 7 · CEIA FIUBA · 1B 2026  ·  github.com/cimberlina/grupo7-eda-ecobici</a:t>
-            </a:r>
-            <a:endParaRPr lang="en-US" sz="900" dirty="0"/>
           </a:p>
         </p:txBody>
       </p:sp>

</xml_diff>